<commit_message>
efp_meirhasson: richer Methods/Results — SD/CI tables + per-subject scatter
- manuscript_stats.py: regenerates Table 1 (within-subject r, mean±SD [95% CI])
  and Table 2 (LOSO) directly into MANUSCRIPT.md between markers, and emits a
  per-subject EFP-r scatter figure. Runs locally from the CSVs, so the manuscript
  stays in sync after pipeline re-runs. Bolds the per-row best predictor.
- MANUSCRIPT.md: auto-populated tables, new "individual variability" subsection
  (Fig. 4), LOSO table, figure list entry.

Co-Authored-By: Claude Opus 4.8 (1M context) <noreply@anthropic.com>
</commit_message>
<xml_diff>
--- a/analysis/fingerprint/efp_meirhasson/efp_meirhasson_results.pptx
+++ b/analysis/fingerprint/efp_meirhasson/efp_meirhasson_results.pptx
@@ -5,22 +5,22 @@
     <p:sldMasterId id="2147483648" r:id="rId1"/>
   </p:sldMasterIdLst>
   <p:sldIdLst>
-    <p:sldId id="256" r:id="rId7"/>
-    <p:sldId id="257" r:id="rId8"/>
-    <p:sldId id="258" r:id="rId9"/>
-    <p:sldId id="259" r:id="rId10"/>
-    <p:sldId id="260" r:id="rId11"/>
-    <p:sldId id="261" r:id="rId12"/>
-    <p:sldId id="262" r:id="rId13"/>
-    <p:sldId id="263" r:id="rId14"/>
-    <p:sldId id="264" r:id="rId15"/>
-    <p:sldId id="265" r:id="rId16"/>
-    <p:sldId id="266" r:id="rId17"/>
-    <p:sldId id="267" r:id="rId18"/>
-    <p:sldId id="268" r:id="rId19"/>
-    <p:sldId id="269" r:id="rId20"/>
+    <p:sldId id="256" r:id="rId2"/>
+    <p:sldId id="257" r:id="rId3"/>
+    <p:sldId id="258" r:id="rId4"/>
+    <p:sldId id="259" r:id="rId5"/>
+    <p:sldId id="260" r:id="rId6"/>
+    <p:sldId id="261" r:id="rId7"/>
+    <p:sldId id="262" r:id="rId8"/>
+    <p:sldId id="263" r:id="rId9"/>
+    <p:sldId id="264" r:id="rId10"/>
+    <p:sldId id="265" r:id="rId11"/>
+    <p:sldId id="266" r:id="rId12"/>
+    <p:sldId id="267" r:id="rId13"/>
+    <p:sldId id="268" r:id="rId14"/>
+    <p:sldId id="269" r:id="rId15"/>
   </p:sldIdLst>
-  <p:sldSz cx="12191695" cy="6858000" type="screen4x3"/>
+  <p:sldSz cx="12192000" cy="6858000"/>
   <p:notesSz cx="6858000" cy="9144000"/>
   <p:defaultTextStyle>
     <a:defPPr>
@@ -117,6 +117,22 @@
       </a:defRPr>
     </a:lvl9pPr>
   </p:defaultTextStyle>
+  <p:extLst>
+    <p:ext uri="{EFAFB233-063F-42B5-8137-9DF3F51BA10A}">
+      <p15:sldGuideLst xmlns:p15="http://schemas.microsoft.com/office/powerpoint/2012/main">
+        <p15:guide id="1" orient="horz" pos="2160">
+          <p15:clr>
+            <a:srgbClr val="A4A3A4"/>
+          </p15:clr>
+        </p15:guide>
+        <p15:guide id="2" pos="2880">
+          <p15:clr>
+            <a:srgbClr val="A4A3A4"/>
+          </p15:clr>
+        </p15:guide>
+      </p15:sldGuideLst>
+    </p:ext>
+  </p:extLst>
 </p:presentation>
 </file>
 
@@ -158,10 +174,9 @@
           <a:lstStyle/>
           <a:p>
             <a:r>
-              <a:rPr lang="en-US" smtClean="0"/>
+              <a:rPr lang="en-US"/>
               <a:t>Click to edit Master title style</a:t>
             </a:r>
-            <a:endParaRPr lang="en-US"/>
           </a:p>
         </p:txBody>
       </p:sp>
@@ -277,10 +292,9 @@
           </a:lstStyle>
           <a:p>
             <a:r>
-              <a:rPr lang="en-US" smtClean="0"/>
+              <a:rPr lang="en-US"/>
               <a:t>Click to edit Master subtitle style</a:t>
             </a:r>
-            <a:endParaRPr lang="en-US"/>
           </a:p>
         </p:txBody>
       </p:sp>
@@ -301,7 +315,7 @@
           <a:p>
             <a:fld id="{5BCAD085-E8A6-8845-BD4E-CB4CCA059FC4}" type="datetimeFigureOut">
               <a:rPr lang="en-US" smtClean="0"/>
-              <a:t>1/27/13</a:t>
+              <a:t>7/3/26</a:t>
             </a:fld>
             <a:endParaRPr lang="en-US"/>
           </a:p>
@@ -395,10 +409,9 @@
           <a:lstStyle/>
           <a:p>
             <a:r>
-              <a:rPr lang="en-US" smtClean="0"/>
+              <a:rPr lang="en-US"/>
               <a:t>Click to edit Master title style</a:t>
             </a:r>
-            <a:endParaRPr lang="en-US"/>
           </a:p>
         </p:txBody>
       </p:sp>
@@ -419,38 +432,37 @@
           <a:p>
             <a:pPr lvl="0"/>
             <a:r>
-              <a:rPr lang="en-US" smtClean="0"/>
+              <a:rPr lang="en-US"/>
               <a:t>Click to edit Master text styles</a:t>
             </a:r>
           </a:p>
           <a:p>
             <a:pPr lvl="1"/>
             <a:r>
-              <a:rPr lang="en-US" smtClean="0"/>
+              <a:rPr lang="en-US"/>
               <a:t>Second level</a:t>
             </a:r>
           </a:p>
           <a:p>
             <a:pPr lvl="2"/>
             <a:r>
-              <a:rPr lang="en-US" smtClean="0"/>
+              <a:rPr lang="en-US"/>
               <a:t>Third level</a:t>
             </a:r>
           </a:p>
           <a:p>
             <a:pPr lvl="3"/>
             <a:r>
-              <a:rPr lang="en-US" smtClean="0"/>
+              <a:rPr lang="en-US"/>
               <a:t>Fourth level</a:t>
             </a:r>
           </a:p>
           <a:p>
             <a:pPr lvl="4"/>
             <a:r>
-              <a:rPr lang="en-US" smtClean="0"/>
+              <a:rPr lang="en-US"/>
               <a:t>Fifth level</a:t>
             </a:r>
-            <a:endParaRPr lang="en-US"/>
           </a:p>
         </p:txBody>
       </p:sp>
@@ -471,7 +483,7 @@
           <a:p>
             <a:fld id="{5BCAD085-E8A6-8845-BD4E-CB4CCA059FC4}" type="datetimeFigureOut">
               <a:rPr lang="en-US" smtClean="0"/>
-              <a:t>1/27/13</a:t>
+              <a:t>7/3/26</a:t>
             </a:fld>
             <a:endParaRPr lang="en-US"/>
           </a:p>
@@ -570,10 +582,9 @@
           <a:lstStyle/>
           <a:p>
             <a:r>
-              <a:rPr lang="en-US" smtClean="0"/>
+              <a:rPr lang="en-US"/>
               <a:t>Click to edit Master title style</a:t>
             </a:r>
-            <a:endParaRPr lang="en-US"/>
           </a:p>
         </p:txBody>
       </p:sp>
@@ -599,38 +610,37 @@
           <a:p>
             <a:pPr lvl="0"/>
             <a:r>
-              <a:rPr lang="en-US" smtClean="0"/>
+              <a:rPr lang="en-US"/>
               <a:t>Click to edit Master text styles</a:t>
             </a:r>
           </a:p>
           <a:p>
             <a:pPr lvl="1"/>
             <a:r>
-              <a:rPr lang="en-US" smtClean="0"/>
+              <a:rPr lang="en-US"/>
               <a:t>Second level</a:t>
             </a:r>
           </a:p>
           <a:p>
             <a:pPr lvl="2"/>
             <a:r>
-              <a:rPr lang="en-US" smtClean="0"/>
+              <a:rPr lang="en-US"/>
               <a:t>Third level</a:t>
             </a:r>
           </a:p>
           <a:p>
             <a:pPr lvl="3"/>
             <a:r>
-              <a:rPr lang="en-US" smtClean="0"/>
+              <a:rPr lang="en-US"/>
               <a:t>Fourth level</a:t>
             </a:r>
           </a:p>
           <a:p>
             <a:pPr lvl="4"/>
             <a:r>
-              <a:rPr lang="en-US" smtClean="0"/>
+              <a:rPr lang="en-US"/>
               <a:t>Fifth level</a:t>
             </a:r>
-            <a:endParaRPr lang="en-US"/>
           </a:p>
         </p:txBody>
       </p:sp>
@@ -651,7 +661,7 @@
           <a:p>
             <a:fld id="{5BCAD085-E8A6-8845-BD4E-CB4CCA059FC4}" type="datetimeFigureOut">
               <a:rPr lang="en-US" smtClean="0"/>
-              <a:t>1/27/13</a:t>
+              <a:t>7/3/26</a:t>
             </a:fld>
             <a:endParaRPr lang="en-US"/>
           </a:p>
@@ -745,10 +755,9 @@
           <a:lstStyle/>
           <a:p>
             <a:r>
-              <a:rPr lang="en-US" smtClean="0"/>
+              <a:rPr lang="en-US"/>
               <a:t>Click to edit Master title style</a:t>
             </a:r>
-            <a:endParaRPr lang="en-US"/>
           </a:p>
         </p:txBody>
       </p:sp>
@@ -769,38 +778,37 @@
           <a:p>
             <a:pPr lvl="0"/>
             <a:r>
-              <a:rPr lang="en-US" smtClean="0"/>
+              <a:rPr lang="en-US"/>
               <a:t>Click to edit Master text styles</a:t>
             </a:r>
           </a:p>
           <a:p>
             <a:pPr lvl="1"/>
             <a:r>
-              <a:rPr lang="en-US" smtClean="0"/>
+              <a:rPr lang="en-US"/>
               <a:t>Second level</a:t>
             </a:r>
           </a:p>
           <a:p>
             <a:pPr lvl="2"/>
             <a:r>
-              <a:rPr lang="en-US" smtClean="0"/>
+              <a:rPr lang="en-US"/>
               <a:t>Third level</a:t>
             </a:r>
           </a:p>
           <a:p>
             <a:pPr lvl="3"/>
             <a:r>
-              <a:rPr lang="en-US" smtClean="0"/>
+              <a:rPr lang="en-US"/>
               <a:t>Fourth level</a:t>
             </a:r>
           </a:p>
           <a:p>
             <a:pPr lvl="4"/>
             <a:r>
-              <a:rPr lang="en-US" smtClean="0"/>
+              <a:rPr lang="en-US"/>
               <a:t>Fifth level</a:t>
             </a:r>
-            <a:endParaRPr lang="en-US"/>
           </a:p>
         </p:txBody>
       </p:sp>
@@ -821,7 +829,7 @@
           <a:p>
             <a:fld id="{5BCAD085-E8A6-8845-BD4E-CB4CCA059FC4}" type="datetimeFigureOut">
               <a:rPr lang="en-US" smtClean="0"/>
-              <a:t>1/27/13</a:t>
+              <a:t>7/3/26</a:t>
             </a:fld>
             <a:endParaRPr lang="en-US"/>
           </a:p>
@@ -924,10 +932,9 @@
           </a:lstStyle>
           <a:p>
             <a:r>
-              <a:rPr lang="en-US" smtClean="0"/>
+              <a:rPr lang="en-US"/>
               <a:t>Click to edit Master title style</a:t>
             </a:r>
-            <a:endParaRPr lang="en-US"/>
           </a:p>
         </p:txBody>
       </p:sp>
@@ -1044,7 +1051,7 @@
           <a:p>
             <a:pPr lvl="0"/>
             <a:r>
-              <a:rPr lang="en-US" smtClean="0"/>
+              <a:rPr lang="en-US"/>
               <a:t>Click to edit Master text styles</a:t>
             </a:r>
           </a:p>
@@ -1067,7 +1074,7 @@
           <a:p>
             <a:fld id="{5BCAD085-E8A6-8845-BD4E-CB4CCA059FC4}" type="datetimeFigureOut">
               <a:rPr lang="en-US" smtClean="0"/>
-              <a:t>1/27/13</a:t>
+              <a:t>7/3/26</a:t>
             </a:fld>
             <a:endParaRPr lang="en-US"/>
           </a:p>
@@ -1161,10 +1168,9 @@
           <a:lstStyle/>
           <a:p>
             <a:r>
-              <a:rPr lang="en-US" smtClean="0"/>
+              <a:rPr lang="en-US"/>
               <a:t>Click to edit Master title style</a:t>
             </a:r>
-            <a:endParaRPr lang="en-US"/>
           </a:p>
         </p:txBody>
       </p:sp>
@@ -1218,38 +1224,37 @@
           <a:p>
             <a:pPr lvl="0"/>
             <a:r>
-              <a:rPr lang="en-US" smtClean="0"/>
+              <a:rPr lang="en-US"/>
               <a:t>Click to edit Master text styles</a:t>
             </a:r>
           </a:p>
           <a:p>
             <a:pPr lvl="1"/>
             <a:r>
-              <a:rPr lang="en-US" smtClean="0"/>
+              <a:rPr lang="en-US"/>
               <a:t>Second level</a:t>
             </a:r>
           </a:p>
           <a:p>
             <a:pPr lvl="2"/>
             <a:r>
-              <a:rPr lang="en-US" smtClean="0"/>
+              <a:rPr lang="en-US"/>
               <a:t>Third level</a:t>
             </a:r>
           </a:p>
           <a:p>
             <a:pPr lvl="3"/>
             <a:r>
-              <a:rPr lang="en-US" smtClean="0"/>
+              <a:rPr lang="en-US"/>
               <a:t>Fourth level</a:t>
             </a:r>
           </a:p>
           <a:p>
             <a:pPr lvl="4"/>
             <a:r>
-              <a:rPr lang="en-US" smtClean="0"/>
+              <a:rPr lang="en-US"/>
               <a:t>Fifth level</a:t>
             </a:r>
-            <a:endParaRPr lang="en-US"/>
           </a:p>
         </p:txBody>
       </p:sp>
@@ -1303,38 +1308,37 @@
           <a:p>
             <a:pPr lvl="0"/>
             <a:r>
-              <a:rPr lang="en-US" smtClean="0"/>
+              <a:rPr lang="en-US"/>
               <a:t>Click to edit Master text styles</a:t>
             </a:r>
           </a:p>
           <a:p>
             <a:pPr lvl="1"/>
             <a:r>
-              <a:rPr lang="en-US" smtClean="0"/>
+              <a:rPr lang="en-US"/>
               <a:t>Second level</a:t>
             </a:r>
           </a:p>
           <a:p>
             <a:pPr lvl="2"/>
             <a:r>
-              <a:rPr lang="en-US" smtClean="0"/>
+              <a:rPr lang="en-US"/>
               <a:t>Third level</a:t>
             </a:r>
           </a:p>
           <a:p>
             <a:pPr lvl="3"/>
             <a:r>
-              <a:rPr lang="en-US" smtClean="0"/>
+              <a:rPr lang="en-US"/>
               <a:t>Fourth level</a:t>
             </a:r>
           </a:p>
           <a:p>
             <a:pPr lvl="4"/>
             <a:r>
-              <a:rPr lang="en-US" smtClean="0"/>
+              <a:rPr lang="en-US"/>
               <a:t>Fifth level</a:t>
             </a:r>
-            <a:endParaRPr lang="en-US"/>
           </a:p>
         </p:txBody>
       </p:sp>
@@ -1355,7 +1359,7 @@
           <a:p>
             <a:fld id="{5BCAD085-E8A6-8845-BD4E-CB4CCA059FC4}" type="datetimeFigureOut">
               <a:rPr lang="en-US" smtClean="0"/>
-              <a:t>1/27/13</a:t>
+              <a:t>7/3/26</a:t>
             </a:fld>
             <a:endParaRPr lang="en-US"/>
           </a:p>
@@ -1453,10 +1457,9 @@
           </a:lstStyle>
           <a:p>
             <a:r>
-              <a:rPr lang="en-US" smtClean="0"/>
+              <a:rPr lang="en-US"/>
               <a:t>Click to edit Master title style</a:t>
             </a:r>
-            <a:endParaRPr lang="en-US"/>
           </a:p>
         </p:txBody>
       </p:sp>
@@ -1519,7 +1522,7 @@
           <a:p>
             <a:pPr lvl="0"/>
             <a:r>
-              <a:rPr lang="en-US" smtClean="0"/>
+              <a:rPr lang="en-US"/>
               <a:t>Click to edit Master text styles</a:t>
             </a:r>
           </a:p>
@@ -1575,38 +1578,37 @@
           <a:p>
             <a:pPr lvl="0"/>
             <a:r>
-              <a:rPr lang="en-US" smtClean="0"/>
+              <a:rPr lang="en-US"/>
               <a:t>Click to edit Master text styles</a:t>
             </a:r>
           </a:p>
           <a:p>
             <a:pPr lvl="1"/>
             <a:r>
-              <a:rPr lang="en-US" smtClean="0"/>
+              <a:rPr lang="en-US"/>
               <a:t>Second level</a:t>
             </a:r>
           </a:p>
           <a:p>
             <a:pPr lvl="2"/>
             <a:r>
-              <a:rPr lang="en-US" smtClean="0"/>
+              <a:rPr lang="en-US"/>
               <a:t>Third level</a:t>
             </a:r>
           </a:p>
           <a:p>
             <a:pPr lvl="3"/>
             <a:r>
-              <a:rPr lang="en-US" smtClean="0"/>
+              <a:rPr lang="en-US"/>
               <a:t>Fourth level</a:t>
             </a:r>
           </a:p>
           <a:p>
             <a:pPr lvl="4"/>
             <a:r>
-              <a:rPr lang="en-US" smtClean="0"/>
+              <a:rPr lang="en-US"/>
               <a:t>Fifth level</a:t>
             </a:r>
-            <a:endParaRPr lang="en-US"/>
           </a:p>
         </p:txBody>
       </p:sp>
@@ -1669,7 +1671,7 @@
           <a:p>
             <a:pPr lvl="0"/>
             <a:r>
-              <a:rPr lang="en-US" smtClean="0"/>
+              <a:rPr lang="en-US"/>
               <a:t>Click to edit Master text styles</a:t>
             </a:r>
           </a:p>
@@ -1725,38 +1727,37 @@
           <a:p>
             <a:pPr lvl="0"/>
             <a:r>
-              <a:rPr lang="en-US" smtClean="0"/>
+              <a:rPr lang="en-US"/>
               <a:t>Click to edit Master text styles</a:t>
             </a:r>
           </a:p>
           <a:p>
             <a:pPr lvl="1"/>
             <a:r>
-              <a:rPr lang="en-US" smtClean="0"/>
+              <a:rPr lang="en-US"/>
               <a:t>Second level</a:t>
             </a:r>
           </a:p>
           <a:p>
             <a:pPr lvl="2"/>
             <a:r>
-              <a:rPr lang="en-US" smtClean="0"/>
+              <a:rPr lang="en-US"/>
               <a:t>Third level</a:t>
             </a:r>
           </a:p>
           <a:p>
             <a:pPr lvl="3"/>
             <a:r>
-              <a:rPr lang="en-US" smtClean="0"/>
+              <a:rPr lang="en-US"/>
               <a:t>Fourth level</a:t>
             </a:r>
           </a:p>
           <a:p>
             <a:pPr lvl="4"/>
             <a:r>
-              <a:rPr lang="en-US" smtClean="0"/>
+              <a:rPr lang="en-US"/>
               <a:t>Fifth level</a:t>
             </a:r>
-            <a:endParaRPr lang="en-US"/>
           </a:p>
         </p:txBody>
       </p:sp>
@@ -1777,7 +1778,7 @@
           <a:p>
             <a:fld id="{5BCAD085-E8A6-8845-BD4E-CB4CCA059FC4}" type="datetimeFigureOut">
               <a:rPr lang="en-US" smtClean="0"/>
-              <a:t>1/27/13</a:t>
+              <a:t>7/3/26</a:t>
             </a:fld>
             <a:endParaRPr lang="en-US"/>
           </a:p>
@@ -1871,10 +1872,9 @@
           <a:lstStyle/>
           <a:p>
             <a:r>
-              <a:rPr lang="en-US" smtClean="0"/>
+              <a:rPr lang="en-US"/>
               <a:t>Click to edit Master title style</a:t>
             </a:r>
-            <a:endParaRPr lang="en-US"/>
           </a:p>
         </p:txBody>
       </p:sp>
@@ -1895,7 +1895,7 @@
           <a:p>
             <a:fld id="{5BCAD085-E8A6-8845-BD4E-CB4CCA059FC4}" type="datetimeFigureOut">
               <a:rPr lang="en-US" smtClean="0"/>
-              <a:t>1/27/13</a:t>
+              <a:t>7/3/26</a:t>
             </a:fld>
             <a:endParaRPr lang="en-US"/>
           </a:p>
@@ -1990,7 +1990,7 @@
           <a:p>
             <a:fld id="{5BCAD085-E8A6-8845-BD4E-CB4CCA059FC4}" type="datetimeFigureOut">
               <a:rPr lang="en-US" smtClean="0"/>
-              <a:t>1/27/13</a:t>
+              <a:t>7/3/26</a:t>
             </a:fld>
             <a:endParaRPr lang="en-US"/>
           </a:p>
@@ -2093,10 +2093,9 @@
           </a:lstStyle>
           <a:p>
             <a:r>
-              <a:rPr lang="en-US" smtClean="0"/>
+              <a:rPr lang="en-US"/>
               <a:t>Click to edit Master title style</a:t>
             </a:r>
-            <a:endParaRPr lang="en-US"/>
           </a:p>
         </p:txBody>
       </p:sp>
@@ -2150,38 +2149,37 @@
           <a:p>
             <a:pPr lvl="0"/>
             <a:r>
-              <a:rPr lang="en-US" smtClean="0"/>
+              <a:rPr lang="en-US"/>
               <a:t>Click to edit Master text styles</a:t>
             </a:r>
           </a:p>
           <a:p>
             <a:pPr lvl="1"/>
             <a:r>
-              <a:rPr lang="en-US" smtClean="0"/>
+              <a:rPr lang="en-US"/>
               <a:t>Second level</a:t>
             </a:r>
           </a:p>
           <a:p>
             <a:pPr lvl="2"/>
             <a:r>
-              <a:rPr lang="en-US" smtClean="0"/>
+              <a:rPr lang="en-US"/>
               <a:t>Third level</a:t>
             </a:r>
           </a:p>
           <a:p>
             <a:pPr lvl="3"/>
             <a:r>
-              <a:rPr lang="en-US" smtClean="0"/>
+              <a:rPr lang="en-US"/>
               <a:t>Fourth level</a:t>
             </a:r>
           </a:p>
           <a:p>
             <a:pPr lvl="4"/>
             <a:r>
-              <a:rPr lang="en-US" smtClean="0"/>
+              <a:rPr lang="en-US"/>
               <a:t>Fifth level</a:t>
             </a:r>
-            <a:endParaRPr lang="en-US"/>
           </a:p>
         </p:txBody>
       </p:sp>
@@ -2244,7 +2242,7 @@
           <a:p>
             <a:pPr lvl="0"/>
             <a:r>
-              <a:rPr lang="en-US" smtClean="0"/>
+              <a:rPr lang="en-US"/>
               <a:t>Click to edit Master text styles</a:t>
             </a:r>
           </a:p>
@@ -2267,7 +2265,7 @@
           <a:p>
             <a:fld id="{5BCAD085-E8A6-8845-BD4E-CB4CCA059FC4}" type="datetimeFigureOut">
               <a:rPr lang="en-US" smtClean="0"/>
-              <a:t>1/27/13</a:t>
+              <a:t>7/3/26</a:t>
             </a:fld>
             <a:endParaRPr lang="en-US"/>
           </a:p>
@@ -2370,10 +2368,9 @@
           </a:lstStyle>
           <a:p>
             <a:r>
-              <a:rPr lang="en-US" smtClean="0"/>
+              <a:rPr lang="en-US"/>
               <a:t>Click to edit Master title style</a:t>
             </a:r>
-            <a:endParaRPr lang="en-US"/>
           </a:p>
         </p:txBody>
       </p:sp>
@@ -2497,7 +2494,7 @@
           <a:p>
             <a:pPr lvl="0"/>
             <a:r>
-              <a:rPr lang="en-US" smtClean="0"/>
+              <a:rPr lang="en-US"/>
               <a:t>Click to edit Master text styles</a:t>
             </a:r>
           </a:p>
@@ -2520,7 +2517,7 @@
           <a:p>
             <a:fld id="{5BCAD085-E8A6-8845-BD4E-CB4CCA059FC4}" type="datetimeFigureOut">
               <a:rPr lang="en-US" smtClean="0"/>
-              <a:t>1/27/13</a:t>
+              <a:t>7/3/26</a:t>
             </a:fld>
             <a:endParaRPr lang="en-US"/>
           </a:p>
@@ -2629,10 +2626,9 @@
           <a:lstStyle/>
           <a:p>
             <a:r>
-              <a:rPr lang="en-US" smtClean="0"/>
+              <a:rPr lang="en-US"/>
               <a:t>Click to edit Master title style</a:t>
             </a:r>
-            <a:endParaRPr lang="en-US"/>
           </a:p>
         </p:txBody>
       </p:sp>
@@ -2663,38 +2659,37 @@
           <a:p>
             <a:pPr lvl="0"/>
             <a:r>
-              <a:rPr lang="en-US" smtClean="0"/>
+              <a:rPr lang="en-US"/>
               <a:t>Click to edit Master text styles</a:t>
             </a:r>
           </a:p>
           <a:p>
             <a:pPr lvl="1"/>
             <a:r>
-              <a:rPr lang="en-US" smtClean="0"/>
+              <a:rPr lang="en-US"/>
               <a:t>Second level</a:t>
             </a:r>
           </a:p>
           <a:p>
             <a:pPr lvl="2"/>
             <a:r>
-              <a:rPr lang="en-US" smtClean="0"/>
+              <a:rPr lang="en-US"/>
               <a:t>Third level</a:t>
             </a:r>
           </a:p>
           <a:p>
             <a:pPr lvl="3"/>
             <a:r>
-              <a:rPr lang="en-US" smtClean="0"/>
+              <a:rPr lang="en-US"/>
               <a:t>Fourth level</a:t>
             </a:r>
           </a:p>
           <a:p>
             <a:pPr lvl="4"/>
             <a:r>
-              <a:rPr lang="en-US" smtClean="0"/>
+              <a:rPr lang="en-US"/>
               <a:t>Fifth level</a:t>
             </a:r>
-            <a:endParaRPr lang="en-US"/>
           </a:p>
         </p:txBody>
       </p:sp>
@@ -2733,7 +2728,7 @@
           <a:p>
             <a:fld id="{5BCAD085-E8A6-8845-BD4E-CB4CCA059FC4}" type="datetimeFigureOut">
               <a:rPr lang="en-US" smtClean="0"/>
-              <a:t>1/27/13</a:t>
+              <a:t>7/3/26</a:t>
             </a:fld>
             <a:endParaRPr lang="en-US"/>
           </a:p>
@@ -3092,7 +3087,7 @@
 </file>
 
 <file path=ppt/slides/slide1.xml><?xml version="1.0" encoding="utf-8"?>
-<p:sld xmlns:a="http://schemas.openxmlformats.org/drawingml/2006/main" xmlns:p="http://schemas.openxmlformats.org/presentationml/2006/main" xmlns:r="http://schemas.openxmlformats.org/officeDocument/2006/relationships">
+<p:sld xmlns:a="http://schemas.openxmlformats.org/drawingml/2006/main" xmlns:r="http://schemas.openxmlformats.org/officeDocument/2006/relationships" xmlns:p="http://schemas.openxmlformats.org/presentationml/2006/main">
   <p:cSld>
     <p:spTree>
       <p:nvGrpSpPr>
@@ -3100,7 +3095,14 @@
         <p:cNvGrpSpPr/>
         <p:nvPr/>
       </p:nvGrpSpPr>
-      <p:grpSpPr/>
+      <p:grpSpPr>
+        <a:xfrm>
+          <a:off x="0" y="0"/>
+          <a:ext cx="0" cy="0"/>
+          <a:chOff x="0" y="0"/>
+          <a:chExt cx="0" cy="0"/>
+        </a:xfrm>
+      </p:grpSpPr>
       <p:sp>
         <p:nvSpPr>
           <p:cNvPr id="2" name="TextBox 1"/>
@@ -3163,7 +3165,7 @@
 </file>
 
 <file path=ppt/slides/slide10.xml><?xml version="1.0" encoding="utf-8"?>
-<p:sld xmlns:a="http://schemas.openxmlformats.org/drawingml/2006/main" xmlns:p="http://schemas.openxmlformats.org/presentationml/2006/main" xmlns:r="http://schemas.openxmlformats.org/officeDocument/2006/relationships">
+<p:sld xmlns:a="http://schemas.openxmlformats.org/drawingml/2006/main" xmlns:r="http://schemas.openxmlformats.org/officeDocument/2006/relationships" xmlns:p="http://schemas.openxmlformats.org/presentationml/2006/main">
   <p:cSld>
     <p:spTree>
       <p:nvGrpSpPr>
@@ -3171,7 +3173,14 @@
         <p:cNvGrpSpPr/>
         <p:nvPr/>
       </p:nvGrpSpPr>
-      <p:grpSpPr/>
+      <p:grpSpPr>
+        <a:xfrm>
+          <a:off x="0" y="0"/>
+          <a:ext cx="0" cy="0"/>
+          <a:chOff x="0" y="0"/>
+          <a:chExt cx="0" cy="0"/>
+        </a:xfrm>
+      </p:grpSpPr>
       <p:sp>
         <p:nvSpPr>
           <p:cNvPr id="2" name="TextBox 1"/>
@@ -3231,8 +3240,8 @@
         </p:blipFill>
         <p:spPr>
           <a:xfrm>
-            <a:off x="365760" y="1280160"/>
-            <a:ext cx="11430000" cy="8176517"/>
+            <a:off x="2385946" y="1305504"/>
+            <a:ext cx="7619291" cy="5450504"/>
           </a:xfrm>
           <a:prstGeom prst="rect">
             <a:avLst/>
@@ -3248,7 +3257,7 @@
 </file>
 
 <file path=ppt/slides/slide11.xml><?xml version="1.0" encoding="utf-8"?>
-<p:sld xmlns:a="http://schemas.openxmlformats.org/drawingml/2006/main" xmlns:p="http://schemas.openxmlformats.org/presentationml/2006/main" xmlns:r="http://schemas.openxmlformats.org/officeDocument/2006/relationships">
+<p:sld xmlns:a="http://schemas.openxmlformats.org/drawingml/2006/main" xmlns:r="http://schemas.openxmlformats.org/officeDocument/2006/relationships" xmlns:p="http://schemas.openxmlformats.org/presentationml/2006/main">
   <p:cSld>
     <p:spTree>
       <p:nvGrpSpPr>
@@ -3256,7 +3265,14 @@
         <p:cNvGrpSpPr/>
         <p:nvPr/>
       </p:nvGrpSpPr>
-      <p:grpSpPr/>
+      <p:grpSpPr>
+        <a:xfrm>
+          <a:off x="0" y="0"/>
+          <a:ext cx="0" cy="0"/>
+          <a:chOff x="0" y="0"/>
+          <a:chExt cx="0" cy="0"/>
+        </a:xfrm>
+      </p:grpSpPr>
       <p:sp>
         <p:nvSpPr>
           <p:cNvPr id="2" name="TextBox 1"/>
@@ -3316,8 +3332,8 @@
         </p:blipFill>
         <p:spPr>
           <a:xfrm>
-            <a:off x="365760" y="1280160"/>
-            <a:ext cx="11430000" cy="8127054"/>
+            <a:off x="1981908" y="1264969"/>
+            <a:ext cx="7746882" cy="5508253"/>
           </a:xfrm>
           <a:prstGeom prst="rect">
             <a:avLst/>
@@ -3333,7 +3349,7 @@
 </file>
 
 <file path=ppt/slides/slide12.xml><?xml version="1.0" encoding="utf-8"?>
-<p:sld xmlns:a="http://schemas.openxmlformats.org/drawingml/2006/main" xmlns:p="http://schemas.openxmlformats.org/presentationml/2006/main" xmlns:r="http://schemas.openxmlformats.org/officeDocument/2006/relationships">
+<p:sld xmlns:a="http://schemas.openxmlformats.org/drawingml/2006/main" xmlns:r="http://schemas.openxmlformats.org/officeDocument/2006/relationships" xmlns:p="http://schemas.openxmlformats.org/presentationml/2006/main">
   <p:cSld>
     <p:spTree>
       <p:nvGrpSpPr>
@@ -3341,7 +3357,14 @@
         <p:cNvGrpSpPr/>
         <p:nvPr/>
       </p:nvGrpSpPr>
-      <p:grpSpPr/>
+      <p:grpSpPr>
+        <a:xfrm>
+          <a:off x="0" y="0"/>
+          <a:ext cx="0" cy="0"/>
+          <a:chOff x="0" y="0"/>
+          <a:chExt cx="0" cy="0"/>
+        </a:xfrm>
+      </p:grpSpPr>
       <p:sp>
         <p:nvSpPr>
           <p:cNvPr id="2" name="TextBox 1"/>
@@ -3401,8 +3424,8 @@
         </p:blipFill>
         <p:spPr>
           <a:xfrm>
-            <a:off x="365760" y="1280160"/>
-            <a:ext cx="11430000" cy="8127054"/>
+            <a:off x="2056337" y="1188720"/>
+            <a:ext cx="7757514" cy="5515812"/>
           </a:xfrm>
           <a:prstGeom prst="rect">
             <a:avLst/>
@@ -3418,7 +3441,7 @@
 </file>
 
 <file path=ppt/slides/slide13.xml><?xml version="1.0" encoding="utf-8"?>
-<p:sld xmlns:a="http://schemas.openxmlformats.org/drawingml/2006/main" xmlns:p="http://schemas.openxmlformats.org/presentationml/2006/main" xmlns:r="http://schemas.openxmlformats.org/officeDocument/2006/relationships">
+<p:sld xmlns:a="http://schemas.openxmlformats.org/drawingml/2006/main" xmlns:r="http://schemas.openxmlformats.org/officeDocument/2006/relationships" xmlns:p="http://schemas.openxmlformats.org/presentationml/2006/main">
   <p:cSld>
     <p:spTree>
       <p:nvGrpSpPr>
@@ -3426,7 +3449,14 @@
         <p:cNvGrpSpPr/>
         <p:nvPr/>
       </p:nvGrpSpPr>
-      <p:grpSpPr/>
+      <p:grpSpPr>
+        <a:xfrm>
+          <a:off x="0" y="0"/>
+          <a:ext cx="0" cy="0"/>
+          <a:chOff x="0" y="0"/>
+          <a:chExt cx="0" cy="0"/>
+        </a:xfrm>
+      </p:grpSpPr>
       <p:sp>
         <p:nvSpPr>
           <p:cNvPr id="2" name="TextBox 1"/>
@@ -3486,8 +3516,8 @@
         </p:blipFill>
         <p:spPr>
           <a:xfrm>
-            <a:off x="274320" y="1371600"/>
-            <a:ext cx="8595360" cy="6111545"/>
+            <a:off x="457200" y="1450330"/>
+            <a:ext cx="7219613" cy="5133350"/>
           </a:xfrm>
           <a:prstGeom prst="rect">
             <a:avLst/>
@@ -3527,7 +3557,7 @@
 </file>
 
 <file path=ppt/slides/slide14.xml><?xml version="1.0" encoding="utf-8"?>
-<p:sld xmlns:a="http://schemas.openxmlformats.org/drawingml/2006/main" xmlns:p="http://schemas.openxmlformats.org/presentationml/2006/main" xmlns:r="http://schemas.openxmlformats.org/officeDocument/2006/relationships">
+<p:sld xmlns:a="http://schemas.openxmlformats.org/drawingml/2006/main" xmlns:r="http://schemas.openxmlformats.org/officeDocument/2006/relationships" xmlns:p="http://schemas.openxmlformats.org/presentationml/2006/main">
   <p:cSld>
     <p:spTree>
       <p:nvGrpSpPr>
@@ -3535,7 +3565,14 @@
         <p:cNvGrpSpPr/>
         <p:nvPr/>
       </p:nvGrpSpPr>
-      <p:grpSpPr/>
+      <p:grpSpPr>
+        <a:xfrm>
+          <a:off x="0" y="0"/>
+          <a:ext cx="0" cy="0"/>
+          <a:chOff x="0" y="0"/>
+          <a:chExt cx="0" cy="0"/>
+        </a:xfrm>
+      </p:grpSpPr>
       <p:sp>
         <p:nvSpPr>
           <p:cNvPr id="2" name="TextBox 1"/>
@@ -3686,7 +3723,7 @@
 </file>
 
 <file path=ppt/slides/slide2.xml><?xml version="1.0" encoding="utf-8"?>
-<p:sld xmlns:a="http://schemas.openxmlformats.org/drawingml/2006/main" xmlns:p="http://schemas.openxmlformats.org/presentationml/2006/main" xmlns:r="http://schemas.openxmlformats.org/officeDocument/2006/relationships">
+<p:sld xmlns:a="http://schemas.openxmlformats.org/drawingml/2006/main" xmlns:r="http://schemas.openxmlformats.org/officeDocument/2006/relationships" xmlns:p="http://schemas.openxmlformats.org/presentationml/2006/main">
   <p:cSld>
     <p:spTree>
       <p:nvGrpSpPr>
@@ -3694,7 +3731,14 @@
         <p:cNvGrpSpPr/>
         <p:nvPr/>
       </p:nvGrpSpPr>
-      <p:grpSpPr/>
+      <p:grpSpPr>
+        <a:xfrm>
+          <a:off x="0" y="0"/>
+          <a:ext cx="0" cy="0"/>
+          <a:chOff x="0" y="0"/>
+          <a:chExt cx="0" cy="0"/>
+        </a:xfrm>
+      </p:grpSpPr>
       <p:sp>
         <p:nvSpPr>
           <p:cNvPr id="2" name="TextBox 1"/>
@@ -3841,7 +3885,7 @@
 </file>
 
 <file path=ppt/slides/slide3.xml><?xml version="1.0" encoding="utf-8"?>
-<p:sld xmlns:a="http://schemas.openxmlformats.org/drawingml/2006/main" xmlns:p="http://schemas.openxmlformats.org/presentationml/2006/main" xmlns:r="http://schemas.openxmlformats.org/officeDocument/2006/relationships">
+<p:sld xmlns:a="http://schemas.openxmlformats.org/drawingml/2006/main" xmlns:r="http://schemas.openxmlformats.org/officeDocument/2006/relationships" xmlns:p="http://schemas.openxmlformats.org/presentationml/2006/main">
   <p:cSld>
     <p:spTree>
       <p:nvGrpSpPr>
@@ -3849,7 +3893,14 @@
         <p:cNvGrpSpPr/>
         <p:nvPr/>
       </p:nvGrpSpPr>
-      <p:grpSpPr/>
+      <p:grpSpPr>
+        <a:xfrm>
+          <a:off x="0" y="0"/>
+          <a:ext cx="0" cy="0"/>
+          <a:chOff x="0" y="0"/>
+          <a:chExt cx="0" cy="0"/>
+        </a:xfrm>
+      </p:grpSpPr>
       <p:sp>
         <p:nvSpPr>
           <p:cNvPr id="2" name="TextBox 1"/>
@@ -3950,7 +4001,7 @@
 </file>
 
 <file path=ppt/slides/slide4.xml><?xml version="1.0" encoding="utf-8"?>
-<p:sld xmlns:a="http://schemas.openxmlformats.org/drawingml/2006/main" xmlns:p="http://schemas.openxmlformats.org/presentationml/2006/main" xmlns:r="http://schemas.openxmlformats.org/officeDocument/2006/relationships">
+<p:sld xmlns:a="http://schemas.openxmlformats.org/drawingml/2006/main" xmlns:r="http://schemas.openxmlformats.org/officeDocument/2006/relationships" xmlns:p="http://schemas.openxmlformats.org/presentationml/2006/main">
   <p:cSld>
     <p:spTree>
       <p:nvGrpSpPr>
@@ -3958,7 +4009,14 @@
         <p:cNvGrpSpPr/>
         <p:nvPr/>
       </p:nvGrpSpPr>
-      <p:grpSpPr/>
+      <p:grpSpPr>
+        <a:xfrm>
+          <a:off x="0" y="0"/>
+          <a:ext cx="0" cy="0"/>
+          <a:chOff x="0" y="0"/>
+          <a:chExt cx="0" cy="0"/>
+        </a:xfrm>
+      </p:grpSpPr>
       <p:sp>
         <p:nvSpPr>
           <p:cNvPr id="2" name="TextBox 1"/>
@@ -4083,7 +4141,7 @@
 </file>
 
 <file path=ppt/slides/slide5.xml><?xml version="1.0" encoding="utf-8"?>
-<p:sld xmlns:a="http://schemas.openxmlformats.org/drawingml/2006/main" xmlns:p="http://schemas.openxmlformats.org/presentationml/2006/main" xmlns:r="http://schemas.openxmlformats.org/officeDocument/2006/relationships">
+<p:sld xmlns:a="http://schemas.openxmlformats.org/drawingml/2006/main" xmlns:r="http://schemas.openxmlformats.org/officeDocument/2006/relationships" xmlns:p="http://schemas.openxmlformats.org/presentationml/2006/main">
   <p:cSld>
     <p:spTree>
       <p:nvGrpSpPr>
@@ -4091,7 +4149,14 @@
         <p:cNvGrpSpPr/>
         <p:nvPr/>
       </p:nvGrpSpPr>
-      <p:grpSpPr/>
+      <p:grpSpPr>
+        <a:xfrm>
+          <a:off x="0" y="0"/>
+          <a:ext cx="0" cy="0"/>
+          <a:chOff x="0" y="0"/>
+          <a:chExt cx="0" cy="0"/>
+        </a:xfrm>
+      </p:grpSpPr>
       <p:sp>
         <p:nvSpPr>
           <p:cNvPr id="2" name="TextBox 1"/>
@@ -4207,7 +4272,7 @@
 </file>
 
 <file path=ppt/slides/slide6.xml><?xml version="1.0" encoding="utf-8"?>
-<p:sld xmlns:a="http://schemas.openxmlformats.org/drawingml/2006/main" xmlns:p="http://schemas.openxmlformats.org/presentationml/2006/main" xmlns:r="http://schemas.openxmlformats.org/officeDocument/2006/relationships">
+<p:sld xmlns:a="http://schemas.openxmlformats.org/drawingml/2006/main" xmlns:r="http://schemas.openxmlformats.org/officeDocument/2006/relationships" xmlns:p="http://schemas.openxmlformats.org/presentationml/2006/main">
   <p:cSld>
     <p:spTree>
       <p:nvGrpSpPr>
@@ -4215,7 +4280,14 @@
         <p:cNvGrpSpPr/>
         <p:nvPr/>
       </p:nvGrpSpPr>
-      <p:grpSpPr/>
+      <p:grpSpPr>
+        <a:xfrm>
+          <a:off x="0" y="0"/>
+          <a:ext cx="0" cy="0"/>
+          <a:chOff x="0" y="0"/>
+          <a:chExt cx="0" cy="0"/>
+        </a:xfrm>
+      </p:grpSpPr>
       <p:sp>
         <p:nvSpPr>
           <p:cNvPr id="2" name="TextBox 1"/>
@@ -4359,7 +4431,7 @@
 </file>
 
 <file path=ppt/slides/slide7.xml><?xml version="1.0" encoding="utf-8"?>
-<p:sld xmlns:a="http://schemas.openxmlformats.org/drawingml/2006/main" xmlns:p="http://schemas.openxmlformats.org/presentationml/2006/main" xmlns:r="http://schemas.openxmlformats.org/officeDocument/2006/relationships">
+<p:sld xmlns:a="http://schemas.openxmlformats.org/drawingml/2006/main" xmlns:r="http://schemas.openxmlformats.org/officeDocument/2006/relationships" xmlns:p="http://schemas.openxmlformats.org/presentationml/2006/main">
   <p:cSld>
     <p:spTree>
       <p:nvGrpSpPr>
@@ -4367,7 +4439,14 @@
         <p:cNvGrpSpPr/>
         <p:nvPr/>
       </p:nvGrpSpPr>
-      <p:grpSpPr/>
+      <p:grpSpPr>
+        <a:xfrm>
+          <a:off x="0" y="0"/>
+          <a:ext cx="0" cy="0"/>
+          <a:chOff x="0" y="0"/>
+          <a:chExt cx="0" cy="0"/>
+        </a:xfrm>
+      </p:grpSpPr>
       <p:sp>
         <p:nvSpPr>
           <p:cNvPr id="2" name="TextBox 1"/>
@@ -4427,8 +4506,8 @@
         </p:blipFill>
         <p:spPr>
           <a:xfrm>
-            <a:off x="548640" y="1371600"/>
-            <a:ext cx="11064240" cy="6104408"/>
+            <a:off x="1133431" y="1188720"/>
+            <a:ext cx="9329007" cy="5147038"/>
           </a:xfrm>
           <a:prstGeom prst="rect">
             <a:avLst/>
@@ -4444,7 +4523,7 @@
 </file>
 
 <file path=ppt/slides/slide8.xml><?xml version="1.0" encoding="utf-8"?>
-<p:sld xmlns:a="http://schemas.openxmlformats.org/drawingml/2006/main" xmlns:p="http://schemas.openxmlformats.org/presentationml/2006/main" xmlns:r="http://schemas.openxmlformats.org/officeDocument/2006/relationships">
+<p:sld xmlns:a="http://schemas.openxmlformats.org/drawingml/2006/main" xmlns:r="http://schemas.openxmlformats.org/officeDocument/2006/relationships" xmlns:p="http://schemas.openxmlformats.org/presentationml/2006/main">
   <p:cSld>
     <p:spTree>
       <p:nvGrpSpPr>
@@ -4452,7 +4531,14 @@
         <p:cNvGrpSpPr/>
         <p:nvPr/>
       </p:nvGrpSpPr>
-      <p:grpSpPr/>
+      <p:grpSpPr>
+        <a:xfrm>
+          <a:off x="0" y="0"/>
+          <a:ext cx="0" cy="0"/>
+          <a:chOff x="0" y="0"/>
+          <a:chExt cx="0" cy="0"/>
+        </a:xfrm>
+      </p:grpSpPr>
       <p:sp>
         <p:nvSpPr>
           <p:cNvPr id="2" name="TextBox 1"/>
@@ -4512,7 +4598,7 @@
         </p:blipFill>
         <p:spPr>
           <a:xfrm>
-            <a:off x="274320" y="1371600"/>
+            <a:off x="274320" y="1427800"/>
             <a:ext cx="7406640" cy="2518258"/>
           </a:xfrm>
           <a:prstGeom prst="rect">
@@ -4601,7 +4687,7 @@
 </file>
 
 <file path=ppt/slides/slide9.xml><?xml version="1.0" encoding="utf-8"?>
-<p:sld xmlns:a="http://schemas.openxmlformats.org/drawingml/2006/main" xmlns:p="http://schemas.openxmlformats.org/presentationml/2006/main" xmlns:r="http://schemas.openxmlformats.org/officeDocument/2006/relationships">
+<p:sld xmlns:a="http://schemas.openxmlformats.org/drawingml/2006/main" xmlns:r="http://schemas.openxmlformats.org/officeDocument/2006/relationships" xmlns:p="http://schemas.openxmlformats.org/presentationml/2006/main">
   <p:cSld>
     <p:spTree>
       <p:nvGrpSpPr>
@@ -4609,7 +4695,14 @@
         <p:cNvGrpSpPr/>
         <p:nvPr/>
       </p:nvGrpSpPr>
-      <p:grpSpPr/>
+      <p:grpSpPr>
+        <a:xfrm>
+          <a:off x="0" y="0"/>
+          <a:ext cx="0" cy="0"/>
+          <a:chOff x="0" y="0"/>
+          <a:chExt cx="0" cy="0"/>
+        </a:xfrm>
+      </p:grpSpPr>
       <p:sp>
         <p:nvSpPr>
           <p:cNvPr id="2" name="TextBox 1"/>
@@ -4669,8 +4762,8 @@
         </p:blipFill>
         <p:spPr>
           <a:xfrm>
-            <a:off x="457200" y="1280160"/>
-            <a:ext cx="11247120" cy="8451978"/>
+            <a:off x="2732568" y="1478188"/>
+            <a:ext cx="6793922" cy="5105492"/>
           </a:xfrm>
           <a:prstGeom prst="rect">
             <a:avLst/>
@@ -5003,4 +5096,10 @@
   </a:objectDefaults>
   <a:extraClrSchemeLst/>
 </a:theme>
+</file>
+
+<file path=docMetadata/LabelInfo.xml><?xml version="1.0" encoding="utf-8"?>
+<clbl:labelList xmlns:clbl="http://schemas.microsoft.com/office/2020/mipLabelMetadata">
+  <clbl:label id="{7893ce20-a697-4fd6-a4da-14011f6a471d}" enabled="1" method="Standard" siteId="{a8eec281-aaa3-4dae-ac9b-9a398b9215e7}" contentBits="0" removed="0"/>
+</clbl:labelList>
 </file>
</xml_diff>

<commit_message>
efp_meirhasson: add per-subject scatter slide; drop Office lock file
- build_ppt: +"Substantial individual variability" slide (Fig 4 scatter); deck now 15 slides.
- Remove committed MS Office lock file and gitignore ~$* temp files.

Co-Authored-By: Claude Opus 4.8 (1M context) <noreply@anthropic.com>
</commit_message>
<xml_diff>
--- a/analysis/fingerprint/efp_meirhasson/efp_meirhasson_results.pptx
+++ b/analysis/fingerprint/efp_meirhasson/efp_meirhasson_results.pptx
@@ -5,22 +5,23 @@
     <p:sldMasterId id="2147483648" r:id="rId1"/>
   </p:sldMasterIdLst>
   <p:sldIdLst>
-    <p:sldId id="256" r:id="rId2"/>
-    <p:sldId id="257" r:id="rId3"/>
-    <p:sldId id="258" r:id="rId4"/>
-    <p:sldId id="259" r:id="rId5"/>
-    <p:sldId id="260" r:id="rId6"/>
-    <p:sldId id="261" r:id="rId7"/>
-    <p:sldId id="262" r:id="rId8"/>
-    <p:sldId id="263" r:id="rId9"/>
-    <p:sldId id="264" r:id="rId10"/>
-    <p:sldId id="265" r:id="rId11"/>
-    <p:sldId id="266" r:id="rId12"/>
-    <p:sldId id="267" r:id="rId13"/>
-    <p:sldId id="268" r:id="rId14"/>
-    <p:sldId id="269" r:id="rId15"/>
+    <p:sldId id="256" r:id="rId7"/>
+    <p:sldId id="257" r:id="rId8"/>
+    <p:sldId id="258" r:id="rId9"/>
+    <p:sldId id="259" r:id="rId10"/>
+    <p:sldId id="260" r:id="rId11"/>
+    <p:sldId id="261" r:id="rId12"/>
+    <p:sldId id="262" r:id="rId13"/>
+    <p:sldId id="263" r:id="rId14"/>
+    <p:sldId id="264" r:id="rId15"/>
+    <p:sldId id="265" r:id="rId16"/>
+    <p:sldId id="266" r:id="rId17"/>
+    <p:sldId id="267" r:id="rId18"/>
+    <p:sldId id="268" r:id="rId19"/>
+    <p:sldId id="269" r:id="rId20"/>
+    <p:sldId id="270" r:id="rId21"/>
   </p:sldIdLst>
-  <p:sldSz cx="12192000" cy="6858000"/>
+  <p:sldSz cx="12191695" cy="6858000" type="screen4x3"/>
   <p:notesSz cx="6858000" cy="9144000"/>
   <p:defaultTextStyle>
     <a:defPPr>
@@ -117,22 +118,6 @@
       </a:defRPr>
     </a:lvl9pPr>
   </p:defaultTextStyle>
-  <p:extLst>
-    <p:ext uri="{EFAFB233-063F-42B5-8137-9DF3F51BA10A}">
-      <p15:sldGuideLst xmlns:p15="http://schemas.microsoft.com/office/powerpoint/2012/main">
-        <p15:guide id="1" orient="horz" pos="2160">
-          <p15:clr>
-            <a:srgbClr val="A4A3A4"/>
-          </p15:clr>
-        </p15:guide>
-        <p15:guide id="2" pos="2880">
-          <p15:clr>
-            <a:srgbClr val="A4A3A4"/>
-          </p15:clr>
-        </p15:guide>
-      </p15:sldGuideLst>
-    </p:ext>
-  </p:extLst>
 </p:presentation>
 </file>
 
@@ -174,9 +159,10 @@
           <a:lstStyle/>
           <a:p>
             <a:r>
-              <a:rPr lang="en-US"/>
+              <a:rPr lang="en-US" smtClean="0"/>
               <a:t>Click to edit Master title style</a:t>
             </a:r>
+            <a:endParaRPr lang="en-US"/>
           </a:p>
         </p:txBody>
       </p:sp>
@@ -292,9 +278,10 @@
           </a:lstStyle>
           <a:p>
             <a:r>
-              <a:rPr lang="en-US"/>
+              <a:rPr lang="en-US" smtClean="0"/>
               <a:t>Click to edit Master subtitle style</a:t>
             </a:r>
+            <a:endParaRPr lang="en-US"/>
           </a:p>
         </p:txBody>
       </p:sp>
@@ -315,7 +302,7 @@
           <a:p>
             <a:fld id="{5BCAD085-E8A6-8845-BD4E-CB4CCA059FC4}" type="datetimeFigureOut">
               <a:rPr lang="en-US" smtClean="0"/>
-              <a:t>7/3/26</a:t>
+              <a:t>1/27/13</a:t>
             </a:fld>
             <a:endParaRPr lang="en-US"/>
           </a:p>
@@ -409,9 +396,10 @@
           <a:lstStyle/>
           <a:p>
             <a:r>
-              <a:rPr lang="en-US"/>
+              <a:rPr lang="en-US" smtClean="0"/>
               <a:t>Click to edit Master title style</a:t>
             </a:r>
+            <a:endParaRPr lang="en-US"/>
           </a:p>
         </p:txBody>
       </p:sp>
@@ -432,37 +420,38 @@
           <a:p>
             <a:pPr lvl="0"/>
             <a:r>
-              <a:rPr lang="en-US"/>
+              <a:rPr lang="en-US" smtClean="0"/>
               <a:t>Click to edit Master text styles</a:t>
             </a:r>
           </a:p>
           <a:p>
             <a:pPr lvl="1"/>
             <a:r>
-              <a:rPr lang="en-US"/>
+              <a:rPr lang="en-US" smtClean="0"/>
               <a:t>Second level</a:t>
             </a:r>
           </a:p>
           <a:p>
             <a:pPr lvl="2"/>
             <a:r>
-              <a:rPr lang="en-US"/>
+              <a:rPr lang="en-US" smtClean="0"/>
               <a:t>Third level</a:t>
             </a:r>
           </a:p>
           <a:p>
             <a:pPr lvl="3"/>
             <a:r>
-              <a:rPr lang="en-US"/>
+              <a:rPr lang="en-US" smtClean="0"/>
               <a:t>Fourth level</a:t>
             </a:r>
           </a:p>
           <a:p>
             <a:pPr lvl="4"/>
             <a:r>
-              <a:rPr lang="en-US"/>
+              <a:rPr lang="en-US" smtClean="0"/>
               <a:t>Fifth level</a:t>
             </a:r>
+            <a:endParaRPr lang="en-US"/>
           </a:p>
         </p:txBody>
       </p:sp>
@@ -483,7 +472,7 @@
           <a:p>
             <a:fld id="{5BCAD085-E8A6-8845-BD4E-CB4CCA059FC4}" type="datetimeFigureOut">
               <a:rPr lang="en-US" smtClean="0"/>
-              <a:t>7/3/26</a:t>
+              <a:t>1/27/13</a:t>
             </a:fld>
             <a:endParaRPr lang="en-US"/>
           </a:p>
@@ -582,9 +571,10 @@
           <a:lstStyle/>
           <a:p>
             <a:r>
-              <a:rPr lang="en-US"/>
+              <a:rPr lang="en-US" smtClean="0"/>
               <a:t>Click to edit Master title style</a:t>
             </a:r>
+            <a:endParaRPr lang="en-US"/>
           </a:p>
         </p:txBody>
       </p:sp>
@@ -610,37 +600,38 @@
           <a:p>
             <a:pPr lvl="0"/>
             <a:r>
-              <a:rPr lang="en-US"/>
+              <a:rPr lang="en-US" smtClean="0"/>
               <a:t>Click to edit Master text styles</a:t>
             </a:r>
           </a:p>
           <a:p>
             <a:pPr lvl="1"/>
             <a:r>
-              <a:rPr lang="en-US"/>
+              <a:rPr lang="en-US" smtClean="0"/>
               <a:t>Second level</a:t>
             </a:r>
           </a:p>
           <a:p>
             <a:pPr lvl="2"/>
             <a:r>
-              <a:rPr lang="en-US"/>
+              <a:rPr lang="en-US" smtClean="0"/>
               <a:t>Third level</a:t>
             </a:r>
           </a:p>
           <a:p>
             <a:pPr lvl="3"/>
             <a:r>
-              <a:rPr lang="en-US"/>
+              <a:rPr lang="en-US" smtClean="0"/>
               <a:t>Fourth level</a:t>
             </a:r>
           </a:p>
           <a:p>
             <a:pPr lvl="4"/>
             <a:r>
-              <a:rPr lang="en-US"/>
+              <a:rPr lang="en-US" smtClean="0"/>
               <a:t>Fifth level</a:t>
             </a:r>
+            <a:endParaRPr lang="en-US"/>
           </a:p>
         </p:txBody>
       </p:sp>
@@ -661,7 +652,7 @@
           <a:p>
             <a:fld id="{5BCAD085-E8A6-8845-BD4E-CB4CCA059FC4}" type="datetimeFigureOut">
               <a:rPr lang="en-US" smtClean="0"/>
-              <a:t>7/3/26</a:t>
+              <a:t>1/27/13</a:t>
             </a:fld>
             <a:endParaRPr lang="en-US"/>
           </a:p>
@@ -755,9 +746,10 @@
           <a:lstStyle/>
           <a:p>
             <a:r>
-              <a:rPr lang="en-US"/>
+              <a:rPr lang="en-US" smtClean="0"/>
               <a:t>Click to edit Master title style</a:t>
             </a:r>
+            <a:endParaRPr lang="en-US"/>
           </a:p>
         </p:txBody>
       </p:sp>
@@ -778,37 +770,38 @@
           <a:p>
             <a:pPr lvl="0"/>
             <a:r>
-              <a:rPr lang="en-US"/>
+              <a:rPr lang="en-US" smtClean="0"/>
               <a:t>Click to edit Master text styles</a:t>
             </a:r>
           </a:p>
           <a:p>
             <a:pPr lvl="1"/>
             <a:r>
-              <a:rPr lang="en-US"/>
+              <a:rPr lang="en-US" smtClean="0"/>
               <a:t>Second level</a:t>
             </a:r>
           </a:p>
           <a:p>
             <a:pPr lvl="2"/>
             <a:r>
-              <a:rPr lang="en-US"/>
+              <a:rPr lang="en-US" smtClean="0"/>
               <a:t>Third level</a:t>
             </a:r>
           </a:p>
           <a:p>
             <a:pPr lvl="3"/>
             <a:r>
-              <a:rPr lang="en-US"/>
+              <a:rPr lang="en-US" smtClean="0"/>
               <a:t>Fourth level</a:t>
             </a:r>
           </a:p>
           <a:p>
             <a:pPr lvl="4"/>
             <a:r>
-              <a:rPr lang="en-US"/>
+              <a:rPr lang="en-US" smtClean="0"/>
               <a:t>Fifth level</a:t>
             </a:r>
+            <a:endParaRPr lang="en-US"/>
           </a:p>
         </p:txBody>
       </p:sp>
@@ -829,7 +822,7 @@
           <a:p>
             <a:fld id="{5BCAD085-E8A6-8845-BD4E-CB4CCA059FC4}" type="datetimeFigureOut">
               <a:rPr lang="en-US" smtClean="0"/>
-              <a:t>7/3/26</a:t>
+              <a:t>1/27/13</a:t>
             </a:fld>
             <a:endParaRPr lang="en-US"/>
           </a:p>
@@ -932,9 +925,10 @@
           </a:lstStyle>
           <a:p>
             <a:r>
-              <a:rPr lang="en-US"/>
+              <a:rPr lang="en-US" smtClean="0"/>
               <a:t>Click to edit Master title style</a:t>
             </a:r>
+            <a:endParaRPr lang="en-US"/>
           </a:p>
         </p:txBody>
       </p:sp>
@@ -1051,7 +1045,7 @@
           <a:p>
             <a:pPr lvl="0"/>
             <a:r>
-              <a:rPr lang="en-US"/>
+              <a:rPr lang="en-US" smtClean="0"/>
               <a:t>Click to edit Master text styles</a:t>
             </a:r>
           </a:p>
@@ -1074,7 +1068,7 @@
           <a:p>
             <a:fld id="{5BCAD085-E8A6-8845-BD4E-CB4CCA059FC4}" type="datetimeFigureOut">
               <a:rPr lang="en-US" smtClean="0"/>
-              <a:t>7/3/26</a:t>
+              <a:t>1/27/13</a:t>
             </a:fld>
             <a:endParaRPr lang="en-US"/>
           </a:p>
@@ -1168,9 +1162,10 @@
           <a:lstStyle/>
           <a:p>
             <a:r>
-              <a:rPr lang="en-US"/>
+              <a:rPr lang="en-US" smtClean="0"/>
               <a:t>Click to edit Master title style</a:t>
             </a:r>
+            <a:endParaRPr lang="en-US"/>
           </a:p>
         </p:txBody>
       </p:sp>
@@ -1224,37 +1219,38 @@
           <a:p>
             <a:pPr lvl="0"/>
             <a:r>
-              <a:rPr lang="en-US"/>
+              <a:rPr lang="en-US" smtClean="0"/>
               <a:t>Click to edit Master text styles</a:t>
             </a:r>
           </a:p>
           <a:p>
             <a:pPr lvl="1"/>
             <a:r>
-              <a:rPr lang="en-US"/>
+              <a:rPr lang="en-US" smtClean="0"/>
               <a:t>Second level</a:t>
             </a:r>
           </a:p>
           <a:p>
             <a:pPr lvl="2"/>
             <a:r>
-              <a:rPr lang="en-US"/>
+              <a:rPr lang="en-US" smtClean="0"/>
               <a:t>Third level</a:t>
             </a:r>
           </a:p>
           <a:p>
             <a:pPr lvl="3"/>
             <a:r>
-              <a:rPr lang="en-US"/>
+              <a:rPr lang="en-US" smtClean="0"/>
               <a:t>Fourth level</a:t>
             </a:r>
           </a:p>
           <a:p>
             <a:pPr lvl="4"/>
             <a:r>
-              <a:rPr lang="en-US"/>
+              <a:rPr lang="en-US" smtClean="0"/>
               <a:t>Fifth level</a:t>
             </a:r>
+            <a:endParaRPr lang="en-US"/>
           </a:p>
         </p:txBody>
       </p:sp>
@@ -1308,37 +1304,38 @@
           <a:p>
             <a:pPr lvl="0"/>
             <a:r>
-              <a:rPr lang="en-US"/>
+              <a:rPr lang="en-US" smtClean="0"/>
               <a:t>Click to edit Master text styles</a:t>
             </a:r>
           </a:p>
           <a:p>
             <a:pPr lvl="1"/>
             <a:r>
-              <a:rPr lang="en-US"/>
+              <a:rPr lang="en-US" smtClean="0"/>
               <a:t>Second level</a:t>
             </a:r>
           </a:p>
           <a:p>
             <a:pPr lvl="2"/>
             <a:r>
-              <a:rPr lang="en-US"/>
+              <a:rPr lang="en-US" smtClean="0"/>
               <a:t>Third level</a:t>
             </a:r>
           </a:p>
           <a:p>
             <a:pPr lvl="3"/>
             <a:r>
-              <a:rPr lang="en-US"/>
+              <a:rPr lang="en-US" smtClean="0"/>
               <a:t>Fourth level</a:t>
             </a:r>
           </a:p>
           <a:p>
             <a:pPr lvl="4"/>
             <a:r>
-              <a:rPr lang="en-US"/>
+              <a:rPr lang="en-US" smtClean="0"/>
               <a:t>Fifth level</a:t>
             </a:r>
+            <a:endParaRPr lang="en-US"/>
           </a:p>
         </p:txBody>
       </p:sp>
@@ -1359,7 +1356,7 @@
           <a:p>
             <a:fld id="{5BCAD085-E8A6-8845-BD4E-CB4CCA059FC4}" type="datetimeFigureOut">
               <a:rPr lang="en-US" smtClean="0"/>
-              <a:t>7/3/26</a:t>
+              <a:t>1/27/13</a:t>
             </a:fld>
             <a:endParaRPr lang="en-US"/>
           </a:p>
@@ -1457,9 +1454,10 @@
           </a:lstStyle>
           <a:p>
             <a:r>
-              <a:rPr lang="en-US"/>
+              <a:rPr lang="en-US" smtClean="0"/>
               <a:t>Click to edit Master title style</a:t>
             </a:r>
+            <a:endParaRPr lang="en-US"/>
           </a:p>
         </p:txBody>
       </p:sp>
@@ -1522,7 +1520,7 @@
           <a:p>
             <a:pPr lvl="0"/>
             <a:r>
-              <a:rPr lang="en-US"/>
+              <a:rPr lang="en-US" smtClean="0"/>
               <a:t>Click to edit Master text styles</a:t>
             </a:r>
           </a:p>
@@ -1578,37 +1576,38 @@
           <a:p>
             <a:pPr lvl="0"/>
             <a:r>
-              <a:rPr lang="en-US"/>
+              <a:rPr lang="en-US" smtClean="0"/>
               <a:t>Click to edit Master text styles</a:t>
             </a:r>
           </a:p>
           <a:p>
             <a:pPr lvl="1"/>
             <a:r>
-              <a:rPr lang="en-US"/>
+              <a:rPr lang="en-US" smtClean="0"/>
               <a:t>Second level</a:t>
             </a:r>
           </a:p>
           <a:p>
             <a:pPr lvl="2"/>
             <a:r>
-              <a:rPr lang="en-US"/>
+              <a:rPr lang="en-US" smtClean="0"/>
               <a:t>Third level</a:t>
             </a:r>
           </a:p>
           <a:p>
             <a:pPr lvl="3"/>
             <a:r>
-              <a:rPr lang="en-US"/>
+              <a:rPr lang="en-US" smtClean="0"/>
               <a:t>Fourth level</a:t>
             </a:r>
           </a:p>
           <a:p>
             <a:pPr lvl="4"/>
             <a:r>
-              <a:rPr lang="en-US"/>
+              <a:rPr lang="en-US" smtClean="0"/>
               <a:t>Fifth level</a:t>
             </a:r>
+            <a:endParaRPr lang="en-US"/>
           </a:p>
         </p:txBody>
       </p:sp>
@@ -1671,7 +1670,7 @@
           <a:p>
             <a:pPr lvl="0"/>
             <a:r>
-              <a:rPr lang="en-US"/>
+              <a:rPr lang="en-US" smtClean="0"/>
               <a:t>Click to edit Master text styles</a:t>
             </a:r>
           </a:p>
@@ -1727,37 +1726,38 @@
           <a:p>
             <a:pPr lvl="0"/>
             <a:r>
-              <a:rPr lang="en-US"/>
+              <a:rPr lang="en-US" smtClean="0"/>
               <a:t>Click to edit Master text styles</a:t>
             </a:r>
           </a:p>
           <a:p>
             <a:pPr lvl="1"/>
             <a:r>
-              <a:rPr lang="en-US"/>
+              <a:rPr lang="en-US" smtClean="0"/>
               <a:t>Second level</a:t>
             </a:r>
           </a:p>
           <a:p>
             <a:pPr lvl="2"/>
             <a:r>
-              <a:rPr lang="en-US"/>
+              <a:rPr lang="en-US" smtClean="0"/>
               <a:t>Third level</a:t>
             </a:r>
           </a:p>
           <a:p>
             <a:pPr lvl="3"/>
             <a:r>
-              <a:rPr lang="en-US"/>
+              <a:rPr lang="en-US" smtClean="0"/>
               <a:t>Fourth level</a:t>
             </a:r>
           </a:p>
           <a:p>
             <a:pPr lvl="4"/>
             <a:r>
-              <a:rPr lang="en-US"/>
+              <a:rPr lang="en-US" smtClean="0"/>
               <a:t>Fifth level</a:t>
             </a:r>
+            <a:endParaRPr lang="en-US"/>
           </a:p>
         </p:txBody>
       </p:sp>
@@ -1778,7 +1778,7 @@
           <a:p>
             <a:fld id="{5BCAD085-E8A6-8845-BD4E-CB4CCA059FC4}" type="datetimeFigureOut">
               <a:rPr lang="en-US" smtClean="0"/>
-              <a:t>7/3/26</a:t>
+              <a:t>1/27/13</a:t>
             </a:fld>
             <a:endParaRPr lang="en-US"/>
           </a:p>
@@ -1872,9 +1872,10 @@
           <a:lstStyle/>
           <a:p>
             <a:r>
-              <a:rPr lang="en-US"/>
+              <a:rPr lang="en-US" smtClean="0"/>
               <a:t>Click to edit Master title style</a:t>
             </a:r>
+            <a:endParaRPr lang="en-US"/>
           </a:p>
         </p:txBody>
       </p:sp>
@@ -1895,7 +1896,7 @@
           <a:p>
             <a:fld id="{5BCAD085-E8A6-8845-BD4E-CB4CCA059FC4}" type="datetimeFigureOut">
               <a:rPr lang="en-US" smtClean="0"/>
-              <a:t>7/3/26</a:t>
+              <a:t>1/27/13</a:t>
             </a:fld>
             <a:endParaRPr lang="en-US"/>
           </a:p>
@@ -1990,7 +1991,7 @@
           <a:p>
             <a:fld id="{5BCAD085-E8A6-8845-BD4E-CB4CCA059FC4}" type="datetimeFigureOut">
               <a:rPr lang="en-US" smtClean="0"/>
-              <a:t>7/3/26</a:t>
+              <a:t>1/27/13</a:t>
             </a:fld>
             <a:endParaRPr lang="en-US"/>
           </a:p>
@@ -2093,9 +2094,10 @@
           </a:lstStyle>
           <a:p>
             <a:r>
-              <a:rPr lang="en-US"/>
+              <a:rPr lang="en-US" smtClean="0"/>
               <a:t>Click to edit Master title style</a:t>
             </a:r>
+            <a:endParaRPr lang="en-US"/>
           </a:p>
         </p:txBody>
       </p:sp>
@@ -2149,37 +2151,38 @@
           <a:p>
             <a:pPr lvl="0"/>
             <a:r>
-              <a:rPr lang="en-US"/>
+              <a:rPr lang="en-US" smtClean="0"/>
               <a:t>Click to edit Master text styles</a:t>
             </a:r>
           </a:p>
           <a:p>
             <a:pPr lvl="1"/>
             <a:r>
-              <a:rPr lang="en-US"/>
+              <a:rPr lang="en-US" smtClean="0"/>
               <a:t>Second level</a:t>
             </a:r>
           </a:p>
           <a:p>
             <a:pPr lvl="2"/>
             <a:r>
-              <a:rPr lang="en-US"/>
+              <a:rPr lang="en-US" smtClean="0"/>
               <a:t>Third level</a:t>
             </a:r>
           </a:p>
           <a:p>
             <a:pPr lvl="3"/>
             <a:r>
-              <a:rPr lang="en-US"/>
+              <a:rPr lang="en-US" smtClean="0"/>
               <a:t>Fourth level</a:t>
             </a:r>
           </a:p>
           <a:p>
             <a:pPr lvl="4"/>
             <a:r>
-              <a:rPr lang="en-US"/>
+              <a:rPr lang="en-US" smtClean="0"/>
               <a:t>Fifth level</a:t>
             </a:r>
+            <a:endParaRPr lang="en-US"/>
           </a:p>
         </p:txBody>
       </p:sp>
@@ -2242,7 +2245,7 @@
           <a:p>
             <a:pPr lvl="0"/>
             <a:r>
-              <a:rPr lang="en-US"/>
+              <a:rPr lang="en-US" smtClean="0"/>
               <a:t>Click to edit Master text styles</a:t>
             </a:r>
           </a:p>
@@ -2265,7 +2268,7 @@
           <a:p>
             <a:fld id="{5BCAD085-E8A6-8845-BD4E-CB4CCA059FC4}" type="datetimeFigureOut">
               <a:rPr lang="en-US" smtClean="0"/>
-              <a:t>7/3/26</a:t>
+              <a:t>1/27/13</a:t>
             </a:fld>
             <a:endParaRPr lang="en-US"/>
           </a:p>
@@ -2368,9 +2371,10 @@
           </a:lstStyle>
           <a:p>
             <a:r>
-              <a:rPr lang="en-US"/>
+              <a:rPr lang="en-US" smtClean="0"/>
               <a:t>Click to edit Master title style</a:t>
             </a:r>
+            <a:endParaRPr lang="en-US"/>
           </a:p>
         </p:txBody>
       </p:sp>
@@ -2494,7 +2498,7 @@
           <a:p>
             <a:pPr lvl="0"/>
             <a:r>
-              <a:rPr lang="en-US"/>
+              <a:rPr lang="en-US" smtClean="0"/>
               <a:t>Click to edit Master text styles</a:t>
             </a:r>
           </a:p>
@@ -2517,7 +2521,7 @@
           <a:p>
             <a:fld id="{5BCAD085-E8A6-8845-BD4E-CB4CCA059FC4}" type="datetimeFigureOut">
               <a:rPr lang="en-US" smtClean="0"/>
-              <a:t>7/3/26</a:t>
+              <a:t>1/27/13</a:t>
             </a:fld>
             <a:endParaRPr lang="en-US"/>
           </a:p>
@@ -2626,9 +2630,10 @@
           <a:lstStyle/>
           <a:p>
             <a:r>
-              <a:rPr lang="en-US"/>
+              <a:rPr lang="en-US" smtClean="0"/>
               <a:t>Click to edit Master title style</a:t>
             </a:r>
+            <a:endParaRPr lang="en-US"/>
           </a:p>
         </p:txBody>
       </p:sp>
@@ -2659,37 +2664,38 @@
           <a:p>
             <a:pPr lvl="0"/>
             <a:r>
-              <a:rPr lang="en-US"/>
+              <a:rPr lang="en-US" smtClean="0"/>
               <a:t>Click to edit Master text styles</a:t>
             </a:r>
           </a:p>
           <a:p>
             <a:pPr lvl="1"/>
             <a:r>
-              <a:rPr lang="en-US"/>
+              <a:rPr lang="en-US" smtClean="0"/>
               <a:t>Second level</a:t>
             </a:r>
           </a:p>
           <a:p>
             <a:pPr lvl="2"/>
             <a:r>
-              <a:rPr lang="en-US"/>
+              <a:rPr lang="en-US" smtClean="0"/>
               <a:t>Third level</a:t>
             </a:r>
           </a:p>
           <a:p>
             <a:pPr lvl="3"/>
             <a:r>
-              <a:rPr lang="en-US"/>
+              <a:rPr lang="en-US" smtClean="0"/>
               <a:t>Fourth level</a:t>
             </a:r>
           </a:p>
           <a:p>
             <a:pPr lvl="4"/>
             <a:r>
-              <a:rPr lang="en-US"/>
+              <a:rPr lang="en-US" smtClean="0"/>
               <a:t>Fifth level</a:t>
             </a:r>
+            <a:endParaRPr lang="en-US"/>
           </a:p>
         </p:txBody>
       </p:sp>
@@ -2728,7 +2734,7 @@
           <a:p>
             <a:fld id="{5BCAD085-E8A6-8845-BD4E-CB4CCA059FC4}" type="datetimeFigureOut">
               <a:rPr lang="en-US" smtClean="0"/>
-              <a:t>7/3/26</a:t>
+              <a:t>1/27/13</a:t>
             </a:fld>
             <a:endParaRPr lang="en-US"/>
           </a:p>
@@ -3087,7 +3093,7 @@
 </file>
 
 <file path=ppt/slides/slide1.xml><?xml version="1.0" encoding="utf-8"?>
-<p:sld xmlns:a="http://schemas.openxmlformats.org/drawingml/2006/main" xmlns:r="http://schemas.openxmlformats.org/officeDocument/2006/relationships" xmlns:p="http://schemas.openxmlformats.org/presentationml/2006/main">
+<p:sld xmlns:a="http://schemas.openxmlformats.org/drawingml/2006/main" xmlns:p="http://schemas.openxmlformats.org/presentationml/2006/main" xmlns:r="http://schemas.openxmlformats.org/officeDocument/2006/relationships">
   <p:cSld>
     <p:spTree>
       <p:nvGrpSpPr>
@@ -3095,14 +3101,7 @@
         <p:cNvGrpSpPr/>
         <p:nvPr/>
       </p:nvGrpSpPr>
-      <p:grpSpPr>
-        <a:xfrm>
-          <a:off x="0" y="0"/>
-          <a:ext cx="0" cy="0"/>
-          <a:chOff x="0" y="0"/>
-          <a:chExt cx="0" cy="0"/>
-        </a:xfrm>
-      </p:grpSpPr>
+      <p:grpSpPr/>
       <p:sp>
         <p:nvSpPr>
           <p:cNvPr id="2" name="TextBox 1"/>
@@ -3165,7 +3164,7 @@
 </file>
 
 <file path=ppt/slides/slide10.xml><?xml version="1.0" encoding="utf-8"?>
-<p:sld xmlns:a="http://schemas.openxmlformats.org/drawingml/2006/main" xmlns:r="http://schemas.openxmlformats.org/officeDocument/2006/relationships" xmlns:p="http://schemas.openxmlformats.org/presentationml/2006/main">
+<p:sld xmlns:a="http://schemas.openxmlformats.org/drawingml/2006/main" xmlns:p="http://schemas.openxmlformats.org/presentationml/2006/main" xmlns:r="http://schemas.openxmlformats.org/officeDocument/2006/relationships">
   <p:cSld>
     <p:spTree>
       <p:nvGrpSpPr>
@@ -3173,14 +3172,92 @@
         <p:cNvGrpSpPr/>
         <p:nvPr/>
       </p:nvGrpSpPr>
-      <p:grpSpPr>
-        <a:xfrm>
-          <a:off x="0" y="0"/>
-          <a:ext cx="0" cy="0"/>
-          <a:chOff x="0" y="0"/>
-          <a:chExt cx="0" cy="0"/>
-        </a:xfrm>
-      </p:grpSpPr>
+      <p:grpSpPr/>
+      <p:sp>
+        <p:nvSpPr>
+          <p:cNvPr id="2" name="TextBox 1"/>
+          <p:cNvSpPr txBox="1"/>
+          <p:nvPr/>
+        </p:nvSpPr>
+        <p:spPr>
+          <a:xfrm>
+            <a:off x="457200" y="274320"/>
+            <a:ext cx="11247120" cy="914400"/>
+          </a:xfrm>
+          <a:prstGeom prst="rect">
+            <a:avLst/>
+          </a:prstGeom>
+          <a:noFill/>
+        </p:spPr>
+        <p:txBody>
+          <a:bodyPr wrap="square">
+            <a:spAutoFit/>
+          </a:bodyPr>
+          <a:lstStyle/>
+          <a:p>
+            <a:r>
+              <a:rPr sz="3000" b="1">
+                <a:solidFill>
+                  <a:srgbClr val="1F3A5F"/>
+                </a:solidFill>
+              </a:rPr>
+              <a:t>Paper-style figures III — post-processing (Fig 2 analog)</a:t>
+            </a:r>
+          </a:p>
+          <a:p>
+            <a:r>
+              <a:rPr sz="1500">
+                <a:solidFill>
+                  <a:srgbClr val="555555"/>
+                </a:solidFill>
+              </a:rPr>
+              <a:t>EEG → S-transform → 4 Hz → data-driven bands → band-averaged TF → sliding window; fMRI ROI → 4 Hz + normalized</a:t>
+            </a:r>
+          </a:p>
+        </p:txBody>
+      </p:sp>
+      <p:pic>
+        <p:nvPicPr>
+          <p:cNvPr id="3" name="Picture 2" descr="paper_fig2_schematic_PDA_tr.png"/>
+          <p:cNvPicPr>
+            <a:picLocks noChangeAspect="1"/>
+          </p:cNvPicPr>
+          <p:nvPr/>
+        </p:nvPicPr>
+        <p:blipFill>
+          <a:blip r:embed="rId2"/>
+          <a:stretch>
+            <a:fillRect/>
+          </a:stretch>
+        </p:blipFill>
+        <p:spPr>
+          <a:xfrm>
+            <a:off x="457200" y="1280160"/>
+            <a:ext cx="11247120" cy="8451978"/>
+          </a:xfrm>
+          <a:prstGeom prst="rect">
+            <a:avLst/>
+          </a:prstGeom>
+        </p:spPr>
+      </p:pic>
+    </p:spTree>
+  </p:cSld>
+  <p:clrMapOvr>
+    <a:masterClrMapping/>
+  </p:clrMapOvr>
+</p:sld>
+</file>
+
+<file path=ppt/slides/slide11.xml><?xml version="1.0" encoding="utf-8"?>
+<p:sld xmlns:a="http://schemas.openxmlformats.org/drawingml/2006/main" xmlns:p="http://schemas.openxmlformats.org/presentationml/2006/main" xmlns:r="http://schemas.openxmlformats.org/officeDocument/2006/relationships">
+  <p:cSld>
+    <p:spTree>
+      <p:nvGrpSpPr>
+        <p:cNvPr id="1" name=""/>
+        <p:cNvGrpSpPr/>
+        <p:nvPr/>
+      </p:nvGrpSpPr>
+      <p:grpSpPr/>
       <p:sp>
         <p:nvSpPr>
           <p:cNvPr id="2" name="TextBox 1"/>
@@ -3240,8 +3317,8 @@
         </p:blipFill>
         <p:spPr>
           <a:xfrm>
-            <a:off x="2385946" y="1305504"/>
-            <a:ext cx="7619291" cy="5450504"/>
+            <a:off x="365760" y="1280160"/>
+            <a:ext cx="11430000" cy="8176517"/>
           </a:xfrm>
           <a:prstGeom prst="rect">
             <a:avLst/>
@@ -3256,8 +3333,8 @@
 </p:sld>
 </file>
 
-<file path=ppt/slides/slide11.xml><?xml version="1.0" encoding="utf-8"?>
-<p:sld xmlns:a="http://schemas.openxmlformats.org/drawingml/2006/main" xmlns:r="http://schemas.openxmlformats.org/officeDocument/2006/relationships" xmlns:p="http://schemas.openxmlformats.org/presentationml/2006/main">
+<file path=ppt/slides/slide12.xml><?xml version="1.0" encoding="utf-8"?>
+<p:sld xmlns:a="http://schemas.openxmlformats.org/drawingml/2006/main" xmlns:p="http://schemas.openxmlformats.org/presentationml/2006/main" xmlns:r="http://schemas.openxmlformats.org/officeDocument/2006/relationships">
   <p:cSld>
     <p:spTree>
       <p:nvGrpSpPr>
@@ -3265,14 +3342,7 @@
         <p:cNvGrpSpPr/>
         <p:nvPr/>
       </p:nvGrpSpPr>
-      <p:grpSpPr>
-        <a:xfrm>
-          <a:off x="0" y="0"/>
-          <a:ext cx="0" cy="0"/>
-          <a:chOff x="0" y="0"/>
-          <a:chExt cx="0" cy="0"/>
-        </a:xfrm>
-      </p:grpSpPr>
+      <p:grpSpPr/>
       <p:sp>
         <p:nvSpPr>
           <p:cNvPr id="2" name="TextBox 1"/>
@@ -3332,8 +3402,8 @@
         </p:blipFill>
         <p:spPr>
           <a:xfrm>
-            <a:off x="1981908" y="1264969"/>
-            <a:ext cx="7746882" cy="5508253"/>
+            <a:off x="365760" y="1280160"/>
+            <a:ext cx="11430000" cy="8127054"/>
           </a:xfrm>
           <a:prstGeom prst="rect">
             <a:avLst/>
@@ -3348,8 +3418,8 @@
 </p:sld>
 </file>
 
-<file path=ppt/slides/slide12.xml><?xml version="1.0" encoding="utf-8"?>
-<p:sld xmlns:a="http://schemas.openxmlformats.org/drawingml/2006/main" xmlns:r="http://schemas.openxmlformats.org/officeDocument/2006/relationships" xmlns:p="http://schemas.openxmlformats.org/presentationml/2006/main">
+<file path=ppt/slides/slide13.xml><?xml version="1.0" encoding="utf-8"?>
+<p:sld xmlns:a="http://schemas.openxmlformats.org/drawingml/2006/main" xmlns:p="http://schemas.openxmlformats.org/presentationml/2006/main" xmlns:r="http://schemas.openxmlformats.org/officeDocument/2006/relationships">
   <p:cSld>
     <p:spTree>
       <p:nvGrpSpPr>
@@ -3357,14 +3427,7 @@
         <p:cNvGrpSpPr/>
         <p:nvPr/>
       </p:nvGrpSpPr>
-      <p:grpSpPr>
-        <a:xfrm>
-          <a:off x="0" y="0"/>
-          <a:ext cx="0" cy="0"/>
-          <a:chOff x="0" y="0"/>
-          <a:chExt cx="0" cy="0"/>
-        </a:xfrm>
-      </p:grpSpPr>
+      <p:grpSpPr/>
       <p:sp>
         <p:nvSpPr>
           <p:cNvPr id="2" name="TextBox 1"/>
@@ -3424,8 +3487,8 @@
         </p:blipFill>
         <p:spPr>
           <a:xfrm>
-            <a:off x="2056337" y="1188720"/>
-            <a:ext cx="7757514" cy="5515812"/>
+            <a:off x="365760" y="1280160"/>
+            <a:ext cx="11430000" cy="8127054"/>
           </a:xfrm>
           <a:prstGeom prst="rect">
             <a:avLst/>
@@ -3440,8 +3503,8 @@
 </p:sld>
 </file>
 
-<file path=ppt/slides/slide13.xml><?xml version="1.0" encoding="utf-8"?>
-<p:sld xmlns:a="http://schemas.openxmlformats.org/drawingml/2006/main" xmlns:r="http://schemas.openxmlformats.org/officeDocument/2006/relationships" xmlns:p="http://schemas.openxmlformats.org/presentationml/2006/main">
+<file path=ppt/slides/slide14.xml><?xml version="1.0" encoding="utf-8"?>
+<p:sld xmlns:a="http://schemas.openxmlformats.org/drawingml/2006/main" xmlns:p="http://schemas.openxmlformats.org/presentationml/2006/main" xmlns:r="http://schemas.openxmlformats.org/officeDocument/2006/relationships">
   <p:cSld>
     <p:spTree>
       <p:nvGrpSpPr>
@@ -3449,14 +3512,7 @@
         <p:cNvGrpSpPr/>
         <p:nvPr/>
       </p:nvGrpSpPr>
-      <p:grpSpPr>
-        <a:xfrm>
-          <a:off x="0" y="0"/>
-          <a:ext cx="0" cy="0"/>
-          <a:chOff x="0" y="0"/>
-          <a:chExt cx="0" cy="0"/>
-        </a:xfrm>
-      </p:grpSpPr>
+      <p:grpSpPr/>
       <p:sp>
         <p:nvSpPr>
           <p:cNvPr id="2" name="TextBox 1"/>
@@ -3516,8 +3572,8 @@
         </p:blipFill>
         <p:spPr>
           <a:xfrm>
-            <a:off x="457200" y="1450330"/>
-            <a:ext cx="7219613" cy="5133350"/>
+            <a:off x="274320" y="1371600"/>
+            <a:ext cx="8595360" cy="6111545"/>
           </a:xfrm>
           <a:prstGeom prst="rect">
             <a:avLst/>
@@ -3556,8 +3612,8 @@
 </p:sld>
 </file>
 
-<file path=ppt/slides/slide14.xml><?xml version="1.0" encoding="utf-8"?>
-<p:sld xmlns:a="http://schemas.openxmlformats.org/drawingml/2006/main" xmlns:r="http://schemas.openxmlformats.org/officeDocument/2006/relationships" xmlns:p="http://schemas.openxmlformats.org/presentationml/2006/main">
+<file path=ppt/slides/slide15.xml><?xml version="1.0" encoding="utf-8"?>
+<p:sld xmlns:a="http://schemas.openxmlformats.org/drawingml/2006/main" xmlns:p="http://schemas.openxmlformats.org/presentationml/2006/main" xmlns:r="http://schemas.openxmlformats.org/officeDocument/2006/relationships">
   <p:cSld>
     <p:spTree>
       <p:nvGrpSpPr>
@@ -3565,14 +3621,7 @@
         <p:cNvGrpSpPr/>
         <p:nvPr/>
       </p:nvGrpSpPr>
-      <p:grpSpPr>
-        <a:xfrm>
-          <a:off x="0" y="0"/>
-          <a:ext cx="0" cy="0"/>
-          <a:chOff x="0" y="0"/>
-          <a:chExt cx="0" cy="0"/>
-        </a:xfrm>
-      </p:grpSpPr>
+      <p:grpSpPr/>
       <p:sp>
         <p:nvSpPr>
           <p:cNvPr id="2" name="TextBox 1"/>
@@ -3723,7 +3772,7 @@
 </file>
 
 <file path=ppt/slides/slide2.xml><?xml version="1.0" encoding="utf-8"?>
-<p:sld xmlns:a="http://schemas.openxmlformats.org/drawingml/2006/main" xmlns:r="http://schemas.openxmlformats.org/officeDocument/2006/relationships" xmlns:p="http://schemas.openxmlformats.org/presentationml/2006/main">
+<p:sld xmlns:a="http://schemas.openxmlformats.org/drawingml/2006/main" xmlns:p="http://schemas.openxmlformats.org/presentationml/2006/main" xmlns:r="http://schemas.openxmlformats.org/officeDocument/2006/relationships">
   <p:cSld>
     <p:spTree>
       <p:nvGrpSpPr>
@@ -3731,14 +3780,7 @@
         <p:cNvGrpSpPr/>
         <p:nvPr/>
       </p:nvGrpSpPr>
-      <p:grpSpPr>
-        <a:xfrm>
-          <a:off x="0" y="0"/>
-          <a:ext cx="0" cy="0"/>
-          <a:chOff x="0" y="0"/>
-          <a:chExt cx="0" cy="0"/>
-        </a:xfrm>
-      </p:grpSpPr>
+      <p:grpSpPr/>
       <p:sp>
         <p:nvSpPr>
           <p:cNvPr id="2" name="TextBox 1"/>
@@ -3885,7 +3927,7 @@
 </file>
 
 <file path=ppt/slides/slide3.xml><?xml version="1.0" encoding="utf-8"?>
-<p:sld xmlns:a="http://schemas.openxmlformats.org/drawingml/2006/main" xmlns:r="http://schemas.openxmlformats.org/officeDocument/2006/relationships" xmlns:p="http://schemas.openxmlformats.org/presentationml/2006/main">
+<p:sld xmlns:a="http://schemas.openxmlformats.org/drawingml/2006/main" xmlns:p="http://schemas.openxmlformats.org/presentationml/2006/main" xmlns:r="http://schemas.openxmlformats.org/officeDocument/2006/relationships">
   <p:cSld>
     <p:spTree>
       <p:nvGrpSpPr>
@@ -3893,14 +3935,7 @@
         <p:cNvGrpSpPr/>
         <p:nvPr/>
       </p:nvGrpSpPr>
-      <p:grpSpPr>
-        <a:xfrm>
-          <a:off x="0" y="0"/>
-          <a:ext cx="0" cy="0"/>
-          <a:chOff x="0" y="0"/>
-          <a:chExt cx="0" cy="0"/>
-        </a:xfrm>
-      </p:grpSpPr>
+      <p:grpSpPr/>
       <p:sp>
         <p:nvSpPr>
           <p:cNvPr id="2" name="TextBox 1"/>
@@ -4001,7 +4036,7 @@
 </file>
 
 <file path=ppt/slides/slide4.xml><?xml version="1.0" encoding="utf-8"?>
-<p:sld xmlns:a="http://schemas.openxmlformats.org/drawingml/2006/main" xmlns:r="http://schemas.openxmlformats.org/officeDocument/2006/relationships" xmlns:p="http://schemas.openxmlformats.org/presentationml/2006/main">
+<p:sld xmlns:a="http://schemas.openxmlformats.org/drawingml/2006/main" xmlns:p="http://schemas.openxmlformats.org/presentationml/2006/main" xmlns:r="http://schemas.openxmlformats.org/officeDocument/2006/relationships">
   <p:cSld>
     <p:spTree>
       <p:nvGrpSpPr>
@@ -4009,14 +4044,92 @@
         <p:cNvGrpSpPr/>
         <p:nvPr/>
       </p:nvGrpSpPr>
-      <p:grpSpPr>
-        <a:xfrm>
-          <a:off x="0" y="0"/>
-          <a:ext cx="0" cy="0"/>
-          <a:chOff x="0" y="0"/>
-          <a:chExt cx="0" cy="0"/>
-        </a:xfrm>
-      </p:grpSpPr>
+      <p:grpSpPr/>
+      <p:sp>
+        <p:nvSpPr>
+          <p:cNvPr id="2" name="TextBox 1"/>
+          <p:cNvSpPr txBox="1"/>
+          <p:nvPr/>
+        </p:nvSpPr>
+        <p:spPr>
+          <a:xfrm>
+            <a:off x="457200" y="274320"/>
+            <a:ext cx="11247120" cy="914400"/>
+          </a:xfrm>
+          <a:prstGeom prst="rect">
+            <a:avLst/>
+          </a:prstGeom>
+          <a:noFill/>
+        </p:spPr>
+        <p:txBody>
+          <a:bodyPr wrap="square">
+            <a:spAutoFit/>
+          </a:bodyPr>
+          <a:lstStyle/>
+          <a:p>
+            <a:r>
+              <a:rPr sz="3000" b="1">
+                <a:solidFill>
+                  <a:srgbClr val="1F3A5F"/>
+                </a:solidFill>
+              </a:rPr>
+              <a:t>Substantial individual variability</a:t>
+            </a:r>
+          </a:p>
+          <a:p>
+            <a:r>
+              <a:rPr sz="1500">
+                <a:solidFill>
+                  <a:srgbClr val="555555"/>
+                </a:solidFill>
+              </a:rPr>
+              <a:t>Per-subject EFP r by target (bar = group mean, band = 95% CI). Every target's CI excludes zero, but spread is wide — motivates the subject-specific electrode selection.</a:t>
+            </a:r>
+          </a:p>
+        </p:txBody>
+      </p:sp>
+      <p:pic>
+        <p:nvPicPr>
+          <p:cNvPr id="3" name="Picture 2" descr="paper_fig_persubject_scatter_tr.png"/>
+          <p:cNvPicPr>
+            <a:picLocks noChangeAspect="1"/>
+          </p:cNvPicPr>
+          <p:nvPr/>
+        </p:nvPicPr>
+        <p:blipFill>
+          <a:blip r:embed="rId2"/>
+          <a:stretch>
+            <a:fillRect/>
+          </a:stretch>
+        </p:blipFill>
+        <p:spPr>
+          <a:xfrm>
+            <a:off x="1280160" y="1554480"/>
+            <a:ext cx="9601200" cy="4907280"/>
+          </a:xfrm>
+          <a:prstGeom prst="rect">
+            <a:avLst/>
+          </a:prstGeom>
+        </p:spPr>
+      </p:pic>
+    </p:spTree>
+  </p:cSld>
+  <p:clrMapOvr>
+    <a:masterClrMapping/>
+  </p:clrMapOvr>
+</p:sld>
+</file>
+
+<file path=ppt/slides/slide5.xml><?xml version="1.0" encoding="utf-8"?>
+<p:sld xmlns:a="http://schemas.openxmlformats.org/drawingml/2006/main" xmlns:p="http://schemas.openxmlformats.org/presentationml/2006/main" xmlns:r="http://schemas.openxmlformats.org/officeDocument/2006/relationships">
+  <p:cSld>
+    <p:spTree>
+      <p:nvGrpSpPr>
+        <p:cNvPr id="1" name=""/>
+        <p:cNvGrpSpPr/>
+        <p:nvPr/>
+      </p:nvGrpSpPr>
+      <p:grpSpPr/>
       <p:sp>
         <p:nvSpPr>
           <p:cNvPr id="2" name="TextBox 1"/>
@@ -4140,8 +4253,8 @@
 </p:sld>
 </file>
 
-<file path=ppt/slides/slide5.xml><?xml version="1.0" encoding="utf-8"?>
-<p:sld xmlns:a="http://schemas.openxmlformats.org/drawingml/2006/main" xmlns:r="http://schemas.openxmlformats.org/officeDocument/2006/relationships" xmlns:p="http://schemas.openxmlformats.org/presentationml/2006/main">
+<file path=ppt/slides/slide6.xml><?xml version="1.0" encoding="utf-8"?>
+<p:sld xmlns:a="http://schemas.openxmlformats.org/drawingml/2006/main" xmlns:p="http://schemas.openxmlformats.org/presentationml/2006/main" xmlns:r="http://schemas.openxmlformats.org/officeDocument/2006/relationships">
   <p:cSld>
     <p:spTree>
       <p:nvGrpSpPr>
@@ -4149,14 +4262,7 @@
         <p:cNvGrpSpPr/>
         <p:nvPr/>
       </p:nvGrpSpPr>
-      <p:grpSpPr>
-        <a:xfrm>
-          <a:off x="0" y="0"/>
-          <a:ext cx="0" cy="0"/>
-          <a:chOff x="0" y="0"/>
-          <a:chExt cx="0" cy="0"/>
-        </a:xfrm>
-      </p:grpSpPr>
+      <p:grpSpPr/>
       <p:sp>
         <p:nvSpPr>
           <p:cNvPr id="2" name="TextBox 1"/>
@@ -4271,8 +4377,8 @@
 </p:sld>
 </file>
 
-<file path=ppt/slides/slide6.xml><?xml version="1.0" encoding="utf-8"?>
-<p:sld xmlns:a="http://schemas.openxmlformats.org/drawingml/2006/main" xmlns:r="http://schemas.openxmlformats.org/officeDocument/2006/relationships" xmlns:p="http://schemas.openxmlformats.org/presentationml/2006/main">
+<file path=ppt/slides/slide7.xml><?xml version="1.0" encoding="utf-8"?>
+<p:sld xmlns:a="http://schemas.openxmlformats.org/drawingml/2006/main" xmlns:p="http://schemas.openxmlformats.org/presentationml/2006/main" xmlns:r="http://schemas.openxmlformats.org/officeDocument/2006/relationships">
   <p:cSld>
     <p:spTree>
       <p:nvGrpSpPr>
@@ -4280,14 +4386,7 @@
         <p:cNvGrpSpPr/>
         <p:nvPr/>
       </p:nvGrpSpPr>
-      <p:grpSpPr>
-        <a:xfrm>
-          <a:off x="0" y="0"/>
-          <a:ext cx="0" cy="0"/>
-          <a:chOff x="0" y="0"/>
-          <a:chExt cx="0" cy="0"/>
-        </a:xfrm>
-      </p:grpSpPr>
+      <p:grpSpPr/>
       <p:sp>
         <p:nvSpPr>
           <p:cNvPr id="2" name="TextBox 1"/>
@@ -4430,8 +4529,8 @@
 </p:sld>
 </file>
 
-<file path=ppt/slides/slide7.xml><?xml version="1.0" encoding="utf-8"?>
-<p:sld xmlns:a="http://schemas.openxmlformats.org/drawingml/2006/main" xmlns:r="http://schemas.openxmlformats.org/officeDocument/2006/relationships" xmlns:p="http://schemas.openxmlformats.org/presentationml/2006/main">
+<file path=ppt/slides/slide8.xml><?xml version="1.0" encoding="utf-8"?>
+<p:sld xmlns:a="http://schemas.openxmlformats.org/drawingml/2006/main" xmlns:p="http://schemas.openxmlformats.org/presentationml/2006/main" xmlns:r="http://schemas.openxmlformats.org/officeDocument/2006/relationships">
   <p:cSld>
     <p:spTree>
       <p:nvGrpSpPr>
@@ -4439,14 +4538,7 @@
         <p:cNvGrpSpPr/>
         <p:nvPr/>
       </p:nvGrpSpPr>
-      <p:grpSpPr>
-        <a:xfrm>
-          <a:off x="0" y="0"/>
-          <a:ext cx="0" cy="0"/>
-          <a:chOff x="0" y="0"/>
-          <a:chExt cx="0" cy="0"/>
-        </a:xfrm>
-      </p:grpSpPr>
+      <p:grpSpPr/>
       <p:sp>
         <p:nvSpPr>
           <p:cNvPr id="2" name="TextBox 1"/>
@@ -4506,8 +4598,8 @@
         </p:blipFill>
         <p:spPr>
           <a:xfrm>
-            <a:off x="1133431" y="1188720"/>
-            <a:ext cx="9329007" cy="5147038"/>
+            <a:off x="548640" y="1371600"/>
+            <a:ext cx="11064240" cy="6104408"/>
           </a:xfrm>
           <a:prstGeom prst="rect">
             <a:avLst/>
@@ -4522,8 +4614,8 @@
 </p:sld>
 </file>
 
-<file path=ppt/slides/slide8.xml><?xml version="1.0" encoding="utf-8"?>
-<p:sld xmlns:a="http://schemas.openxmlformats.org/drawingml/2006/main" xmlns:r="http://schemas.openxmlformats.org/officeDocument/2006/relationships" xmlns:p="http://schemas.openxmlformats.org/presentationml/2006/main">
+<file path=ppt/slides/slide9.xml><?xml version="1.0" encoding="utf-8"?>
+<p:sld xmlns:a="http://schemas.openxmlformats.org/drawingml/2006/main" xmlns:p="http://schemas.openxmlformats.org/presentationml/2006/main" xmlns:r="http://schemas.openxmlformats.org/officeDocument/2006/relationships">
   <p:cSld>
     <p:spTree>
       <p:nvGrpSpPr>
@@ -4531,14 +4623,7 @@
         <p:cNvGrpSpPr/>
         <p:nvPr/>
       </p:nvGrpSpPr>
-      <p:grpSpPr>
-        <a:xfrm>
-          <a:off x="0" y="0"/>
-          <a:ext cx="0" cy="0"/>
-          <a:chOff x="0" y="0"/>
-          <a:chExt cx="0" cy="0"/>
-        </a:xfrm>
-      </p:grpSpPr>
+      <p:grpSpPr/>
       <p:sp>
         <p:nvSpPr>
           <p:cNvPr id="2" name="TextBox 1"/>
@@ -4598,7 +4683,7 @@
         </p:blipFill>
         <p:spPr>
           <a:xfrm>
-            <a:off x="274320" y="1427800"/>
+            <a:off x="274320" y="1371600"/>
             <a:ext cx="7406640" cy="2518258"/>
           </a:xfrm>
           <a:prstGeom prst="rect">
@@ -4672,98 +4757,6 @@
           <a:xfrm>
             <a:off x="7955279" y="3840480"/>
             <a:ext cx="2926080" cy="2813538"/>
-          </a:xfrm>
-          <a:prstGeom prst="rect">
-            <a:avLst/>
-          </a:prstGeom>
-        </p:spPr>
-      </p:pic>
-    </p:spTree>
-  </p:cSld>
-  <p:clrMapOvr>
-    <a:masterClrMapping/>
-  </p:clrMapOvr>
-</p:sld>
-</file>
-
-<file path=ppt/slides/slide9.xml><?xml version="1.0" encoding="utf-8"?>
-<p:sld xmlns:a="http://schemas.openxmlformats.org/drawingml/2006/main" xmlns:r="http://schemas.openxmlformats.org/officeDocument/2006/relationships" xmlns:p="http://schemas.openxmlformats.org/presentationml/2006/main">
-  <p:cSld>
-    <p:spTree>
-      <p:nvGrpSpPr>
-        <p:cNvPr id="1" name=""/>
-        <p:cNvGrpSpPr/>
-        <p:nvPr/>
-      </p:nvGrpSpPr>
-      <p:grpSpPr>
-        <a:xfrm>
-          <a:off x="0" y="0"/>
-          <a:ext cx="0" cy="0"/>
-          <a:chOff x="0" y="0"/>
-          <a:chExt cx="0" cy="0"/>
-        </a:xfrm>
-      </p:grpSpPr>
-      <p:sp>
-        <p:nvSpPr>
-          <p:cNvPr id="2" name="TextBox 1"/>
-          <p:cNvSpPr txBox="1"/>
-          <p:nvPr/>
-        </p:nvSpPr>
-        <p:spPr>
-          <a:xfrm>
-            <a:off x="457200" y="274320"/>
-            <a:ext cx="11247120" cy="914400"/>
-          </a:xfrm>
-          <a:prstGeom prst="rect">
-            <a:avLst/>
-          </a:prstGeom>
-          <a:noFill/>
-        </p:spPr>
-        <p:txBody>
-          <a:bodyPr wrap="square">
-            <a:spAutoFit/>
-          </a:bodyPr>
-          <a:lstStyle/>
-          <a:p>
-            <a:r>
-              <a:rPr sz="3000" b="1">
-                <a:solidFill>
-                  <a:srgbClr val="1F3A5F"/>
-                </a:solidFill>
-              </a:rPr>
-              <a:t>Paper-style figures III — post-processing (Fig 2 analog)</a:t>
-            </a:r>
-          </a:p>
-          <a:p>
-            <a:r>
-              <a:rPr sz="1500">
-                <a:solidFill>
-                  <a:srgbClr val="555555"/>
-                </a:solidFill>
-              </a:rPr>
-              <a:t>EEG → S-transform → 4 Hz → data-driven bands → band-averaged TF → sliding window; fMRI ROI → 4 Hz + normalized</a:t>
-            </a:r>
-          </a:p>
-        </p:txBody>
-      </p:sp>
-      <p:pic>
-        <p:nvPicPr>
-          <p:cNvPr id="3" name="Picture 2" descr="paper_fig2_schematic_PDA_tr.png"/>
-          <p:cNvPicPr>
-            <a:picLocks noChangeAspect="1"/>
-          </p:cNvPicPr>
-          <p:nvPr/>
-        </p:nvPicPr>
-        <p:blipFill>
-          <a:blip r:embed="rId2"/>
-          <a:stretch>
-            <a:fillRect/>
-          </a:stretch>
-        </p:blipFill>
-        <p:spPr>
-          <a:xfrm>
-            <a:off x="2732568" y="1478188"/>
-            <a:ext cx="6793922" cy="5105492"/>
           </a:xfrm>
           <a:prstGeom prst="rect">
             <a:avLst/>
@@ -5096,10 +5089,4 @@
   </a:objectDefaults>
   <a:extraClrSchemeLst/>
 </a:theme>
-</file>
-
-<file path=docMetadata/LabelInfo.xml><?xml version="1.0" encoding="utf-8"?>
-<clbl:labelList xmlns:clbl="http://schemas.microsoft.com/office/2020/mipLabelMetadata">
-  <clbl:label id="{7893ce20-a697-4fd6-a4da-14011f6a471d}" enabled="1" method="Standard" siteId="{a8eec281-aaa3-4dae-ac9b-9a398b9215e7}" contentBits="0" removed="0"/>
-</clbl:labelList>
 </file>
</xml_diff>

<commit_message>
efp deck (v3) + eeg_bold_coupling cross-cohort double-replication scaffolding
- efp_meirhasson: rewrite build_ppt.py in the pedagogical eeg_bold_coupling
  style (20 slides, step-by-step methods -> honest v3 results -> generalization
  ladder -> positive control). Numbers read live from the v3 CSVs.
- eeg_bold_coupling: add cross_cohort_coupling.py — train the DMNELF general
  band-power group model, predict rtBPD nf1 & nf2 (double replication), the
  band-power analogue of cross_cohort_efp.py. Adds config_rtbpd{,_nf2}.yaml,
  submit_cc_coupling.sh, and generalizes bandpower.gather_subject to honor
  session_eeg (rtBPD EEG lives in ses-nf/ses-nf2, fMRI in ses-nf1/ses-nf2).

Co-Authored-By: Claude Opus 4.8 <noreply@anthropic.com>
</commit_message>
<xml_diff>
--- a/analysis/fingerprint/efp_meirhasson/efp_meirhasson_results.pptx
+++ b/analysis/fingerprint/efp_meirhasson/efp_meirhasson_results.pptx
@@ -5,23 +5,28 @@
     <p:sldMasterId id="2147483648" r:id="rId1"/>
   </p:sldMasterIdLst>
   <p:sldIdLst>
-    <p:sldId id="256" r:id="rId7"/>
-    <p:sldId id="257" r:id="rId8"/>
-    <p:sldId id="258" r:id="rId9"/>
-    <p:sldId id="259" r:id="rId10"/>
-    <p:sldId id="260" r:id="rId11"/>
-    <p:sldId id="261" r:id="rId12"/>
-    <p:sldId id="262" r:id="rId13"/>
-    <p:sldId id="263" r:id="rId14"/>
-    <p:sldId id="264" r:id="rId15"/>
-    <p:sldId id="265" r:id="rId16"/>
-    <p:sldId id="266" r:id="rId17"/>
-    <p:sldId id="267" r:id="rId18"/>
-    <p:sldId id="268" r:id="rId19"/>
-    <p:sldId id="269" r:id="rId20"/>
-    <p:sldId id="270" r:id="rId21"/>
+    <p:sldId id="256" r:id="rId2"/>
+    <p:sldId id="257" r:id="rId3"/>
+    <p:sldId id="258" r:id="rId4"/>
+    <p:sldId id="259" r:id="rId5"/>
+    <p:sldId id="260" r:id="rId6"/>
+    <p:sldId id="261" r:id="rId7"/>
+    <p:sldId id="262" r:id="rId8"/>
+    <p:sldId id="263" r:id="rId9"/>
+    <p:sldId id="264" r:id="rId10"/>
+    <p:sldId id="265" r:id="rId11"/>
+    <p:sldId id="266" r:id="rId12"/>
+    <p:sldId id="267" r:id="rId13"/>
+    <p:sldId id="268" r:id="rId14"/>
+    <p:sldId id="269" r:id="rId15"/>
+    <p:sldId id="270" r:id="rId16"/>
+    <p:sldId id="271" r:id="rId17"/>
+    <p:sldId id="272" r:id="rId18"/>
+    <p:sldId id="273" r:id="rId19"/>
+    <p:sldId id="274" r:id="rId20"/>
+    <p:sldId id="275" r:id="rId21"/>
   </p:sldIdLst>
-  <p:sldSz cx="12191695" cy="6858000" type="screen4x3"/>
+  <p:sldSz cx="12192000" cy="6858000"/>
   <p:notesSz cx="6858000" cy="9144000"/>
   <p:defaultTextStyle>
     <a:defPPr>
@@ -118,6 +123,22 @@
       </a:defRPr>
     </a:lvl9pPr>
   </p:defaultTextStyle>
+  <p:extLst>
+    <p:ext uri="{EFAFB233-063F-42B5-8137-9DF3F51BA10A}">
+      <p15:sldGuideLst xmlns:p15="http://schemas.microsoft.com/office/powerpoint/2012/main">
+        <p15:guide id="1" orient="horz" pos="2160">
+          <p15:clr>
+            <a:srgbClr val="A4A3A4"/>
+          </p15:clr>
+        </p15:guide>
+        <p15:guide id="2" pos="2880">
+          <p15:clr>
+            <a:srgbClr val="A4A3A4"/>
+          </p15:clr>
+        </p15:guide>
+      </p15:sldGuideLst>
+    </p:ext>
+  </p:extLst>
 </p:presentation>
 </file>
 
@@ -159,10 +180,9 @@
           <a:lstStyle/>
           <a:p>
             <a:r>
-              <a:rPr lang="en-US" smtClean="0"/>
+              <a:rPr lang="en-US"/>
               <a:t>Click to edit Master title style</a:t>
             </a:r>
-            <a:endParaRPr lang="en-US"/>
           </a:p>
         </p:txBody>
       </p:sp>
@@ -278,10 +298,9 @@
           </a:lstStyle>
           <a:p>
             <a:r>
-              <a:rPr lang="en-US" smtClean="0"/>
+              <a:rPr lang="en-US"/>
               <a:t>Click to edit Master subtitle style</a:t>
             </a:r>
-            <a:endParaRPr lang="en-US"/>
           </a:p>
         </p:txBody>
       </p:sp>
@@ -302,7 +321,7 @@
           <a:p>
             <a:fld id="{5BCAD085-E8A6-8845-BD4E-CB4CCA059FC4}" type="datetimeFigureOut">
               <a:rPr lang="en-US" smtClean="0"/>
-              <a:t>1/27/13</a:t>
+              <a:t>7/8/26</a:t>
             </a:fld>
             <a:endParaRPr lang="en-US"/>
           </a:p>
@@ -396,10 +415,9 @@
           <a:lstStyle/>
           <a:p>
             <a:r>
-              <a:rPr lang="en-US" smtClean="0"/>
+              <a:rPr lang="en-US"/>
               <a:t>Click to edit Master title style</a:t>
             </a:r>
-            <a:endParaRPr lang="en-US"/>
           </a:p>
         </p:txBody>
       </p:sp>
@@ -420,38 +438,37 @@
           <a:p>
             <a:pPr lvl="0"/>
             <a:r>
-              <a:rPr lang="en-US" smtClean="0"/>
+              <a:rPr lang="en-US"/>
               <a:t>Click to edit Master text styles</a:t>
             </a:r>
           </a:p>
           <a:p>
             <a:pPr lvl="1"/>
             <a:r>
-              <a:rPr lang="en-US" smtClean="0"/>
+              <a:rPr lang="en-US"/>
               <a:t>Second level</a:t>
             </a:r>
           </a:p>
           <a:p>
             <a:pPr lvl="2"/>
             <a:r>
-              <a:rPr lang="en-US" smtClean="0"/>
+              <a:rPr lang="en-US"/>
               <a:t>Third level</a:t>
             </a:r>
           </a:p>
           <a:p>
             <a:pPr lvl="3"/>
             <a:r>
-              <a:rPr lang="en-US" smtClean="0"/>
+              <a:rPr lang="en-US"/>
               <a:t>Fourth level</a:t>
             </a:r>
           </a:p>
           <a:p>
             <a:pPr lvl="4"/>
             <a:r>
-              <a:rPr lang="en-US" smtClean="0"/>
+              <a:rPr lang="en-US"/>
               <a:t>Fifth level</a:t>
             </a:r>
-            <a:endParaRPr lang="en-US"/>
           </a:p>
         </p:txBody>
       </p:sp>
@@ -472,7 +489,7 @@
           <a:p>
             <a:fld id="{5BCAD085-E8A6-8845-BD4E-CB4CCA059FC4}" type="datetimeFigureOut">
               <a:rPr lang="en-US" smtClean="0"/>
-              <a:t>1/27/13</a:t>
+              <a:t>7/8/26</a:t>
             </a:fld>
             <a:endParaRPr lang="en-US"/>
           </a:p>
@@ -571,10 +588,9 @@
           <a:lstStyle/>
           <a:p>
             <a:r>
-              <a:rPr lang="en-US" smtClean="0"/>
+              <a:rPr lang="en-US"/>
               <a:t>Click to edit Master title style</a:t>
             </a:r>
-            <a:endParaRPr lang="en-US"/>
           </a:p>
         </p:txBody>
       </p:sp>
@@ -600,38 +616,37 @@
           <a:p>
             <a:pPr lvl="0"/>
             <a:r>
-              <a:rPr lang="en-US" smtClean="0"/>
+              <a:rPr lang="en-US"/>
               <a:t>Click to edit Master text styles</a:t>
             </a:r>
           </a:p>
           <a:p>
             <a:pPr lvl="1"/>
             <a:r>
-              <a:rPr lang="en-US" smtClean="0"/>
+              <a:rPr lang="en-US"/>
               <a:t>Second level</a:t>
             </a:r>
           </a:p>
           <a:p>
             <a:pPr lvl="2"/>
             <a:r>
-              <a:rPr lang="en-US" smtClean="0"/>
+              <a:rPr lang="en-US"/>
               <a:t>Third level</a:t>
             </a:r>
           </a:p>
           <a:p>
             <a:pPr lvl="3"/>
             <a:r>
-              <a:rPr lang="en-US" smtClean="0"/>
+              <a:rPr lang="en-US"/>
               <a:t>Fourth level</a:t>
             </a:r>
           </a:p>
           <a:p>
             <a:pPr lvl="4"/>
             <a:r>
-              <a:rPr lang="en-US" smtClean="0"/>
+              <a:rPr lang="en-US"/>
               <a:t>Fifth level</a:t>
             </a:r>
-            <a:endParaRPr lang="en-US"/>
           </a:p>
         </p:txBody>
       </p:sp>
@@ -652,7 +667,7 @@
           <a:p>
             <a:fld id="{5BCAD085-E8A6-8845-BD4E-CB4CCA059FC4}" type="datetimeFigureOut">
               <a:rPr lang="en-US" smtClean="0"/>
-              <a:t>1/27/13</a:t>
+              <a:t>7/8/26</a:t>
             </a:fld>
             <a:endParaRPr lang="en-US"/>
           </a:p>
@@ -746,10 +761,9 @@
           <a:lstStyle/>
           <a:p>
             <a:r>
-              <a:rPr lang="en-US" smtClean="0"/>
+              <a:rPr lang="en-US"/>
               <a:t>Click to edit Master title style</a:t>
             </a:r>
-            <a:endParaRPr lang="en-US"/>
           </a:p>
         </p:txBody>
       </p:sp>
@@ -770,38 +784,37 @@
           <a:p>
             <a:pPr lvl="0"/>
             <a:r>
-              <a:rPr lang="en-US" smtClean="0"/>
+              <a:rPr lang="en-US"/>
               <a:t>Click to edit Master text styles</a:t>
             </a:r>
           </a:p>
           <a:p>
             <a:pPr lvl="1"/>
             <a:r>
-              <a:rPr lang="en-US" smtClean="0"/>
+              <a:rPr lang="en-US"/>
               <a:t>Second level</a:t>
             </a:r>
           </a:p>
           <a:p>
             <a:pPr lvl="2"/>
             <a:r>
-              <a:rPr lang="en-US" smtClean="0"/>
+              <a:rPr lang="en-US"/>
               <a:t>Third level</a:t>
             </a:r>
           </a:p>
           <a:p>
             <a:pPr lvl="3"/>
             <a:r>
-              <a:rPr lang="en-US" smtClean="0"/>
+              <a:rPr lang="en-US"/>
               <a:t>Fourth level</a:t>
             </a:r>
           </a:p>
           <a:p>
             <a:pPr lvl="4"/>
             <a:r>
-              <a:rPr lang="en-US" smtClean="0"/>
+              <a:rPr lang="en-US"/>
               <a:t>Fifth level</a:t>
             </a:r>
-            <a:endParaRPr lang="en-US"/>
           </a:p>
         </p:txBody>
       </p:sp>
@@ -822,7 +835,7 @@
           <a:p>
             <a:fld id="{5BCAD085-E8A6-8845-BD4E-CB4CCA059FC4}" type="datetimeFigureOut">
               <a:rPr lang="en-US" smtClean="0"/>
-              <a:t>1/27/13</a:t>
+              <a:t>7/8/26</a:t>
             </a:fld>
             <a:endParaRPr lang="en-US"/>
           </a:p>
@@ -925,10 +938,9 @@
           </a:lstStyle>
           <a:p>
             <a:r>
-              <a:rPr lang="en-US" smtClean="0"/>
+              <a:rPr lang="en-US"/>
               <a:t>Click to edit Master title style</a:t>
             </a:r>
-            <a:endParaRPr lang="en-US"/>
           </a:p>
         </p:txBody>
       </p:sp>
@@ -1045,7 +1057,7 @@
           <a:p>
             <a:pPr lvl="0"/>
             <a:r>
-              <a:rPr lang="en-US" smtClean="0"/>
+              <a:rPr lang="en-US"/>
               <a:t>Click to edit Master text styles</a:t>
             </a:r>
           </a:p>
@@ -1068,7 +1080,7 @@
           <a:p>
             <a:fld id="{5BCAD085-E8A6-8845-BD4E-CB4CCA059FC4}" type="datetimeFigureOut">
               <a:rPr lang="en-US" smtClean="0"/>
-              <a:t>1/27/13</a:t>
+              <a:t>7/8/26</a:t>
             </a:fld>
             <a:endParaRPr lang="en-US"/>
           </a:p>
@@ -1162,10 +1174,9 @@
           <a:lstStyle/>
           <a:p>
             <a:r>
-              <a:rPr lang="en-US" smtClean="0"/>
+              <a:rPr lang="en-US"/>
               <a:t>Click to edit Master title style</a:t>
             </a:r>
-            <a:endParaRPr lang="en-US"/>
           </a:p>
         </p:txBody>
       </p:sp>
@@ -1219,38 +1230,37 @@
           <a:p>
             <a:pPr lvl="0"/>
             <a:r>
-              <a:rPr lang="en-US" smtClean="0"/>
+              <a:rPr lang="en-US"/>
               <a:t>Click to edit Master text styles</a:t>
             </a:r>
           </a:p>
           <a:p>
             <a:pPr lvl="1"/>
             <a:r>
-              <a:rPr lang="en-US" smtClean="0"/>
+              <a:rPr lang="en-US"/>
               <a:t>Second level</a:t>
             </a:r>
           </a:p>
           <a:p>
             <a:pPr lvl="2"/>
             <a:r>
-              <a:rPr lang="en-US" smtClean="0"/>
+              <a:rPr lang="en-US"/>
               <a:t>Third level</a:t>
             </a:r>
           </a:p>
           <a:p>
             <a:pPr lvl="3"/>
             <a:r>
-              <a:rPr lang="en-US" smtClean="0"/>
+              <a:rPr lang="en-US"/>
               <a:t>Fourth level</a:t>
             </a:r>
           </a:p>
           <a:p>
             <a:pPr lvl="4"/>
             <a:r>
-              <a:rPr lang="en-US" smtClean="0"/>
+              <a:rPr lang="en-US"/>
               <a:t>Fifth level</a:t>
             </a:r>
-            <a:endParaRPr lang="en-US"/>
           </a:p>
         </p:txBody>
       </p:sp>
@@ -1304,38 +1314,37 @@
           <a:p>
             <a:pPr lvl="0"/>
             <a:r>
-              <a:rPr lang="en-US" smtClean="0"/>
+              <a:rPr lang="en-US"/>
               <a:t>Click to edit Master text styles</a:t>
             </a:r>
           </a:p>
           <a:p>
             <a:pPr lvl="1"/>
             <a:r>
-              <a:rPr lang="en-US" smtClean="0"/>
+              <a:rPr lang="en-US"/>
               <a:t>Second level</a:t>
             </a:r>
           </a:p>
           <a:p>
             <a:pPr lvl="2"/>
             <a:r>
-              <a:rPr lang="en-US" smtClean="0"/>
+              <a:rPr lang="en-US"/>
               <a:t>Third level</a:t>
             </a:r>
           </a:p>
           <a:p>
             <a:pPr lvl="3"/>
             <a:r>
-              <a:rPr lang="en-US" smtClean="0"/>
+              <a:rPr lang="en-US"/>
               <a:t>Fourth level</a:t>
             </a:r>
           </a:p>
           <a:p>
             <a:pPr lvl="4"/>
             <a:r>
-              <a:rPr lang="en-US" smtClean="0"/>
+              <a:rPr lang="en-US"/>
               <a:t>Fifth level</a:t>
             </a:r>
-            <a:endParaRPr lang="en-US"/>
           </a:p>
         </p:txBody>
       </p:sp>
@@ -1356,7 +1365,7 @@
           <a:p>
             <a:fld id="{5BCAD085-E8A6-8845-BD4E-CB4CCA059FC4}" type="datetimeFigureOut">
               <a:rPr lang="en-US" smtClean="0"/>
-              <a:t>1/27/13</a:t>
+              <a:t>7/8/26</a:t>
             </a:fld>
             <a:endParaRPr lang="en-US"/>
           </a:p>
@@ -1454,10 +1463,9 @@
           </a:lstStyle>
           <a:p>
             <a:r>
-              <a:rPr lang="en-US" smtClean="0"/>
+              <a:rPr lang="en-US"/>
               <a:t>Click to edit Master title style</a:t>
             </a:r>
-            <a:endParaRPr lang="en-US"/>
           </a:p>
         </p:txBody>
       </p:sp>
@@ -1520,7 +1528,7 @@
           <a:p>
             <a:pPr lvl="0"/>
             <a:r>
-              <a:rPr lang="en-US" smtClean="0"/>
+              <a:rPr lang="en-US"/>
               <a:t>Click to edit Master text styles</a:t>
             </a:r>
           </a:p>
@@ -1576,38 +1584,37 @@
           <a:p>
             <a:pPr lvl="0"/>
             <a:r>
-              <a:rPr lang="en-US" smtClean="0"/>
+              <a:rPr lang="en-US"/>
               <a:t>Click to edit Master text styles</a:t>
             </a:r>
           </a:p>
           <a:p>
             <a:pPr lvl="1"/>
             <a:r>
-              <a:rPr lang="en-US" smtClean="0"/>
+              <a:rPr lang="en-US"/>
               <a:t>Second level</a:t>
             </a:r>
           </a:p>
           <a:p>
             <a:pPr lvl="2"/>
             <a:r>
-              <a:rPr lang="en-US" smtClean="0"/>
+              <a:rPr lang="en-US"/>
               <a:t>Third level</a:t>
             </a:r>
           </a:p>
           <a:p>
             <a:pPr lvl="3"/>
             <a:r>
-              <a:rPr lang="en-US" smtClean="0"/>
+              <a:rPr lang="en-US"/>
               <a:t>Fourth level</a:t>
             </a:r>
           </a:p>
           <a:p>
             <a:pPr lvl="4"/>
             <a:r>
-              <a:rPr lang="en-US" smtClean="0"/>
+              <a:rPr lang="en-US"/>
               <a:t>Fifth level</a:t>
             </a:r>
-            <a:endParaRPr lang="en-US"/>
           </a:p>
         </p:txBody>
       </p:sp>
@@ -1670,7 +1677,7 @@
           <a:p>
             <a:pPr lvl="0"/>
             <a:r>
-              <a:rPr lang="en-US" smtClean="0"/>
+              <a:rPr lang="en-US"/>
               <a:t>Click to edit Master text styles</a:t>
             </a:r>
           </a:p>
@@ -1726,38 +1733,37 @@
           <a:p>
             <a:pPr lvl="0"/>
             <a:r>
-              <a:rPr lang="en-US" smtClean="0"/>
+              <a:rPr lang="en-US"/>
               <a:t>Click to edit Master text styles</a:t>
             </a:r>
           </a:p>
           <a:p>
             <a:pPr lvl="1"/>
             <a:r>
-              <a:rPr lang="en-US" smtClean="0"/>
+              <a:rPr lang="en-US"/>
               <a:t>Second level</a:t>
             </a:r>
           </a:p>
           <a:p>
             <a:pPr lvl="2"/>
             <a:r>
-              <a:rPr lang="en-US" smtClean="0"/>
+              <a:rPr lang="en-US"/>
               <a:t>Third level</a:t>
             </a:r>
           </a:p>
           <a:p>
             <a:pPr lvl="3"/>
             <a:r>
-              <a:rPr lang="en-US" smtClean="0"/>
+              <a:rPr lang="en-US"/>
               <a:t>Fourth level</a:t>
             </a:r>
           </a:p>
           <a:p>
             <a:pPr lvl="4"/>
             <a:r>
-              <a:rPr lang="en-US" smtClean="0"/>
+              <a:rPr lang="en-US"/>
               <a:t>Fifth level</a:t>
             </a:r>
-            <a:endParaRPr lang="en-US"/>
           </a:p>
         </p:txBody>
       </p:sp>
@@ -1778,7 +1784,7 @@
           <a:p>
             <a:fld id="{5BCAD085-E8A6-8845-BD4E-CB4CCA059FC4}" type="datetimeFigureOut">
               <a:rPr lang="en-US" smtClean="0"/>
-              <a:t>1/27/13</a:t>
+              <a:t>7/8/26</a:t>
             </a:fld>
             <a:endParaRPr lang="en-US"/>
           </a:p>
@@ -1872,10 +1878,9 @@
           <a:lstStyle/>
           <a:p>
             <a:r>
-              <a:rPr lang="en-US" smtClean="0"/>
+              <a:rPr lang="en-US"/>
               <a:t>Click to edit Master title style</a:t>
             </a:r>
-            <a:endParaRPr lang="en-US"/>
           </a:p>
         </p:txBody>
       </p:sp>
@@ -1896,7 +1901,7 @@
           <a:p>
             <a:fld id="{5BCAD085-E8A6-8845-BD4E-CB4CCA059FC4}" type="datetimeFigureOut">
               <a:rPr lang="en-US" smtClean="0"/>
-              <a:t>1/27/13</a:t>
+              <a:t>7/8/26</a:t>
             </a:fld>
             <a:endParaRPr lang="en-US"/>
           </a:p>
@@ -1991,7 +1996,7 @@
           <a:p>
             <a:fld id="{5BCAD085-E8A6-8845-BD4E-CB4CCA059FC4}" type="datetimeFigureOut">
               <a:rPr lang="en-US" smtClean="0"/>
-              <a:t>1/27/13</a:t>
+              <a:t>7/8/26</a:t>
             </a:fld>
             <a:endParaRPr lang="en-US"/>
           </a:p>
@@ -2094,10 +2099,9 @@
           </a:lstStyle>
           <a:p>
             <a:r>
-              <a:rPr lang="en-US" smtClean="0"/>
+              <a:rPr lang="en-US"/>
               <a:t>Click to edit Master title style</a:t>
             </a:r>
-            <a:endParaRPr lang="en-US"/>
           </a:p>
         </p:txBody>
       </p:sp>
@@ -2151,38 +2155,37 @@
           <a:p>
             <a:pPr lvl="0"/>
             <a:r>
-              <a:rPr lang="en-US" smtClean="0"/>
+              <a:rPr lang="en-US"/>
               <a:t>Click to edit Master text styles</a:t>
             </a:r>
           </a:p>
           <a:p>
             <a:pPr lvl="1"/>
             <a:r>
-              <a:rPr lang="en-US" smtClean="0"/>
+              <a:rPr lang="en-US"/>
               <a:t>Second level</a:t>
             </a:r>
           </a:p>
           <a:p>
             <a:pPr lvl="2"/>
             <a:r>
-              <a:rPr lang="en-US" smtClean="0"/>
+              <a:rPr lang="en-US"/>
               <a:t>Third level</a:t>
             </a:r>
           </a:p>
           <a:p>
             <a:pPr lvl="3"/>
             <a:r>
-              <a:rPr lang="en-US" smtClean="0"/>
+              <a:rPr lang="en-US"/>
               <a:t>Fourth level</a:t>
             </a:r>
           </a:p>
           <a:p>
             <a:pPr lvl="4"/>
             <a:r>
-              <a:rPr lang="en-US" smtClean="0"/>
+              <a:rPr lang="en-US"/>
               <a:t>Fifth level</a:t>
             </a:r>
-            <a:endParaRPr lang="en-US"/>
           </a:p>
         </p:txBody>
       </p:sp>
@@ -2245,7 +2248,7 @@
           <a:p>
             <a:pPr lvl="0"/>
             <a:r>
-              <a:rPr lang="en-US" smtClean="0"/>
+              <a:rPr lang="en-US"/>
               <a:t>Click to edit Master text styles</a:t>
             </a:r>
           </a:p>
@@ -2268,7 +2271,7 @@
           <a:p>
             <a:fld id="{5BCAD085-E8A6-8845-BD4E-CB4CCA059FC4}" type="datetimeFigureOut">
               <a:rPr lang="en-US" smtClean="0"/>
-              <a:t>1/27/13</a:t>
+              <a:t>7/8/26</a:t>
             </a:fld>
             <a:endParaRPr lang="en-US"/>
           </a:p>
@@ -2371,10 +2374,9 @@
           </a:lstStyle>
           <a:p>
             <a:r>
-              <a:rPr lang="en-US" smtClean="0"/>
+              <a:rPr lang="en-US"/>
               <a:t>Click to edit Master title style</a:t>
             </a:r>
-            <a:endParaRPr lang="en-US"/>
           </a:p>
         </p:txBody>
       </p:sp>
@@ -2498,7 +2500,7 @@
           <a:p>
             <a:pPr lvl="0"/>
             <a:r>
-              <a:rPr lang="en-US" smtClean="0"/>
+              <a:rPr lang="en-US"/>
               <a:t>Click to edit Master text styles</a:t>
             </a:r>
           </a:p>
@@ -2521,7 +2523,7 @@
           <a:p>
             <a:fld id="{5BCAD085-E8A6-8845-BD4E-CB4CCA059FC4}" type="datetimeFigureOut">
               <a:rPr lang="en-US" smtClean="0"/>
-              <a:t>1/27/13</a:t>
+              <a:t>7/8/26</a:t>
             </a:fld>
             <a:endParaRPr lang="en-US"/>
           </a:p>
@@ -2630,10 +2632,9 @@
           <a:lstStyle/>
           <a:p>
             <a:r>
-              <a:rPr lang="en-US" smtClean="0"/>
+              <a:rPr lang="en-US"/>
               <a:t>Click to edit Master title style</a:t>
             </a:r>
-            <a:endParaRPr lang="en-US"/>
           </a:p>
         </p:txBody>
       </p:sp>
@@ -2664,38 +2665,37 @@
           <a:p>
             <a:pPr lvl="0"/>
             <a:r>
-              <a:rPr lang="en-US" smtClean="0"/>
+              <a:rPr lang="en-US"/>
               <a:t>Click to edit Master text styles</a:t>
             </a:r>
           </a:p>
           <a:p>
             <a:pPr lvl="1"/>
             <a:r>
-              <a:rPr lang="en-US" smtClean="0"/>
+              <a:rPr lang="en-US"/>
               <a:t>Second level</a:t>
             </a:r>
           </a:p>
           <a:p>
             <a:pPr lvl="2"/>
             <a:r>
-              <a:rPr lang="en-US" smtClean="0"/>
+              <a:rPr lang="en-US"/>
               <a:t>Third level</a:t>
             </a:r>
           </a:p>
           <a:p>
             <a:pPr lvl="3"/>
             <a:r>
-              <a:rPr lang="en-US" smtClean="0"/>
+              <a:rPr lang="en-US"/>
               <a:t>Fourth level</a:t>
             </a:r>
           </a:p>
           <a:p>
             <a:pPr lvl="4"/>
             <a:r>
-              <a:rPr lang="en-US" smtClean="0"/>
+              <a:rPr lang="en-US"/>
               <a:t>Fifth level</a:t>
             </a:r>
-            <a:endParaRPr lang="en-US"/>
           </a:p>
         </p:txBody>
       </p:sp>
@@ -2734,7 +2734,7 @@
           <a:p>
             <a:fld id="{5BCAD085-E8A6-8845-BD4E-CB4CCA059FC4}" type="datetimeFigureOut">
               <a:rPr lang="en-US" smtClean="0"/>
-              <a:t>1/27/13</a:t>
+              <a:t>7/8/26</a:t>
             </a:fld>
             <a:endParaRPr lang="en-US"/>
           </a:p>
@@ -3093,7 +3093,7 @@
 </file>
 
 <file path=ppt/slides/slide1.xml><?xml version="1.0" encoding="utf-8"?>
-<p:sld xmlns:a="http://schemas.openxmlformats.org/drawingml/2006/main" xmlns:p="http://schemas.openxmlformats.org/presentationml/2006/main" xmlns:r="http://schemas.openxmlformats.org/officeDocument/2006/relationships">
+<p:sld xmlns:a="http://schemas.openxmlformats.org/drawingml/2006/main" xmlns:r="http://schemas.openxmlformats.org/officeDocument/2006/relationships" xmlns:p="http://schemas.openxmlformats.org/presentationml/2006/main">
   <p:cSld>
     <p:spTree>
       <p:nvGrpSpPr>
@@ -3101,7 +3101,14 @@
         <p:cNvGrpSpPr/>
         <p:nvPr/>
       </p:nvGrpSpPr>
-      <p:grpSpPr/>
+      <p:grpSpPr>
+        <a:xfrm>
+          <a:off x="0" y="0"/>
+          <a:ext cx="0" cy="0"/>
+          <a:chOff x="0" y="0"/>
+          <a:chExt cx="0" cy="0"/>
+        </a:xfrm>
+      </p:grpSpPr>
       <p:sp>
         <p:nvSpPr>
           <p:cNvPr id="2" name="TextBox 1"/>
@@ -3110,8 +3117,8 @@
         </p:nvSpPr>
         <p:spPr>
           <a:xfrm>
-            <a:off x="731520" y="2286000"/>
-            <a:ext cx="10698480" cy="2286000"/>
+            <a:off x="731520" y="2194560"/>
+            <a:ext cx="10698480" cy="2560320"/>
           </a:xfrm>
           <a:prstGeom prst="rect">
             <a:avLst/>
@@ -3125,12 +3132,12 @@
           <a:lstStyle/>
           <a:p>
             <a:r>
-              <a:rPr sz="3600" b="1">
+              <a:rPr sz="3400" b="1">
                 <a:solidFill>
                   <a:srgbClr val="1F3A5F"/>
                 </a:solidFill>
               </a:rPr>
-              <a:t>EEG Finger-Print (EFP) for DMN / CEN / PDA</a:t>
+              <a:t>EEG Finger-Print (EFP) → fMRI Network Decoding</a:t>
             </a:r>
           </a:p>
           <a:p>
@@ -3140,7 +3147,7 @@
                   <a:srgbClr val="555555"/>
                 </a:solidFill>
               </a:rPr>
-              <a:t>Replicating Meir-Hasson et al. 2014 on the DMNELF simultaneous EEG–fMRI cohort</a:t>
+              <a:t>Replicating &amp; extending Meir-Hasson et al. (2014) to DMN / CEN / PDA</a:t>
             </a:r>
           </a:p>
           <a:p>
@@ -3150,7 +3157,17 @@
                   <a:srgbClr val="555555"/>
                 </a:solidFill>
               </a:rPr>
-              <a:t>Single electrode · Stockwell time-frequency · data-driven bands · sliding-delay ridge · n=17</a:t>
+              <a:t>Single electrode · Stockwell time-frequency · data-driven bands · sliding-delay ridge</a:t>
+            </a:r>
+          </a:p>
+          <a:p>
+            <a:r>
+              <a:rPr sz="1400">
+                <a:solidFill>
+                  <a:srgbClr val="555555"/>
+                </a:solidFill>
+              </a:rPr>
+              <a:t>DMNELF simultaneous EEG–fMRI cohort · n=17 · nested cross-validation (v3, bulletproofed)</a:t>
             </a:r>
           </a:p>
         </p:txBody>
@@ -3164,7 +3181,7 @@
 </file>
 
 <file path=ppt/slides/slide10.xml><?xml version="1.0" encoding="utf-8"?>
-<p:sld xmlns:a="http://schemas.openxmlformats.org/drawingml/2006/main" xmlns:p="http://schemas.openxmlformats.org/presentationml/2006/main" xmlns:r="http://schemas.openxmlformats.org/officeDocument/2006/relationships">
+<p:sld xmlns:a="http://schemas.openxmlformats.org/drawingml/2006/main" xmlns:r="http://schemas.openxmlformats.org/officeDocument/2006/relationships" xmlns:p="http://schemas.openxmlformats.org/presentationml/2006/main">
   <p:cSld>
     <p:spTree>
       <p:nvGrpSpPr>
@@ -3172,7 +3189,14 @@
         <p:cNvGrpSpPr/>
         <p:nvPr/>
       </p:nvGrpSpPr>
-      <p:grpSpPr/>
+      <p:grpSpPr>
+        <a:xfrm>
+          <a:off x="0" y="0"/>
+          <a:ext cx="0" cy="0"/>
+          <a:chOff x="0" y="0"/>
+          <a:chExt cx="0" cy="0"/>
+        </a:xfrm>
+      </p:grpSpPr>
       <p:sp>
         <p:nvSpPr>
           <p:cNvPr id="2" name="TextBox 1"/>
@@ -3196,29 +3220,185 @@
           <a:lstStyle/>
           <a:p>
             <a:r>
-              <a:rPr sz="3000" b="1">
+              <a:rPr sz="2800" b="1">
                 <a:solidFill>
                   <a:srgbClr val="1F3A5F"/>
                 </a:solidFill>
               </a:rPr>
-              <a:t>Paper-style figures III — post-processing (Fig 2 analog)</a:t>
-            </a:r>
-          </a:p>
-          <a:p>
-            <a:r>
-              <a:rPr sz="1500">
+              <a:t>Bulletproofing — two artifacts caught &amp; fixed</a:t>
+            </a:r>
+          </a:p>
+          <a:p>
+            <a:r>
+              <a:rPr sz="1400">
                 <a:solidFill>
                   <a:srgbClr val="555555"/>
                 </a:solidFill>
               </a:rPr>
-              <a:t>EEG → S-transform → 4 Hz → data-driven bands → band-averaged TF → sliding window; fMRI ROI → 4 Hz + normalized</a:t>
+              <a:t>Full adversarial audit before write-up (VALIDATION.md). The story SURVIVED honest re-analysis.</a:t>
+            </a:r>
+          </a:p>
+        </p:txBody>
+      </p:sp>
+      <p:sp>
+        <p:nvSpPr>
+          <p:cNvPr id="3" name="TextBox 2"/>
+          <p:cNvSpPr txBox="1"/>
+          <p:nvPr/>
+        </p:nvSpPr>
+        <p:spPr>
+          <a:xfrm>
+            <a:off x="548640" y="1417320"/>
+            <a:ext cx="11064240" cy="5029200"/>
+          </a:xfrm>
+          <a:prstGeom prst="rect">
+            <a:avLst/>
+          </a:prstGeom>
+          <a:noFill/>
+        </p:spPr>
+        <p:txBody>
+          <a:bodyPr wrap="square">
+            <a:spAutoFit/>
+          </a:bodyPr>
+          <a:lstStyle/>
+          <a:p>
+            <a:pPr>
+              <a:spcAft>
+                <a:spcPts val="600"/>
+              </a:spcAft>
+            </a:pPr>
+            <a:r>
+              <a:rPr sz="1600" b="1">
+                <a:solidFill>
+                  <a:srgbClr val="B03A2E"/>
+                </a:solidFill>
+              </a:rPr>
+              <a:t>• ① Selection bias — v1 picked the best of ~31 electrodes on the same folds it scored on → within-subject r inflated ~0.05–0.15.</a:t>
+            </a:r>
+          </a:p>
+          <a:p>
+            <a:pPr lvl="1">
+              <a:spcAft>
+                <a:spcPts val="600"/>
+              </a:spcAft>
+            </a:pPr>
+            <a:r>
+              <a:rPr sz="1400" b="0">
+                <a:solidFill>
+                  <a:srgbClr val="2E7D32"/>
+                </a:solidFill>
+              </a:rPr>
+              <a:t>–    Fix: nested CV (above). Within-subject numbers now de-biased.</a:t>
+            </a:r>
+          </a:p>
+          <a:p>
+            <a:pPr>
+              <a:spcAft>
+                <a:spcPts val="600"/>
+              </a:spcAft>
+            </a:pPr>
+            <a:r>
+              <a:rPr sz="1600" b="1">
+                <a:solidFill>
+                  <a:srgbClr val="B03A2E"/>
+                </a:solidFill>
+              </a:rPr>
+              <a:t>• ② Normalization asymmetry — EFP features were raw while HRF/T-A were per-run z-scored, deflating EFP's 110 heterogeneous features.</a:t>
+            </a:r>
+          </a:p>
+          <a:p>
+            <a:pPr lvl="1">
+              <a:spcAft>
+                <a:spcPts val="600"/>
+              </a:spcAft>
+            </a:pPr>
+            <a:r>
+              <a:rPr sz="1400" b="0">
+                <a:solidFill>
+                  <a:srgbClr val="2E7D32"/>
+                </a:solidFill>
+              </a:rPr>
+              <a:t>–    Fix: per-run standardize the EFP design too. EFP recovered (CEN 0.089 → 0.159; cross-cohort roughly doubled).</a:t>
+            </a:r>
+          </a:p>
+          <a:p>
+            <a:pPr>
+              <a:spcAft>
+                <a:spcPts val="600"/>
+              </a:spcAft>
+            </a:pPr>
+            <a:r>
+              <a:rPr sz="1600" b="1">
+                <a:solidFill>
+                  <a:srgbClr val="1F3A5F"/>
+                </a:solidFill>
+              </a:rPr>
+              <a:t>• Net effect: the bulletproofing STRENGTHENED the EFP result — it did not depend on the bugs.</a:t>
+            </a:r>
+          </a:p>
+        </p:txBody>
+      </p:sp>
+    </p:spTree>
+  </p:cSld>
+  <p:clrMapOvr>
+    <a:masterClrMapping/>
+  </p:clrMapOvr>
+</p:sld>
+</file>
+
+<file path=ppt/slides/slide11.xml><?xml version="1.0" encoding="utf-8"?>
+<p:sld xmlns:a="http://schemas.openxmlformats.org/drawingml/2006/main" xmlns:r="http://schemas.openxmlformats.org/officeDocument/2006/relationships" xmlns:p="http://schemas.openxmlformats.org/presentationml/2006/main">
+  <p:cSld>
+    <p:spTree>
+      <p:nvGrpSpPr>
+        <p:cNvPr id="1" name=""/>
+        <p:cNvGrpSpPr/>
+        <p:nvPr/>
+      </p:nvGrpSpPr>
+      <p:grpSpPr>
+        <a:xfrm>
+          <a:off x="0" y="0"/>
+          <a:ext cx="0" cy="0"/>
+          <a:chOff x="0" y="0"/>
+          <a:chExt cx="0" cy="0"/>
+        </a:xfrm>
+      </p:grpSpPr>
+      <p:sp>
+        <p:nvSpPr>
+          <p:cNvPr id="2" name="TextBox 1"/>
+          <p:cNvSpPr txBox="1"/>
+          <p:nvPr/>
+        </p:nvSpPr>
+        <p:spPr>
+          <a:xfrm>
+            <a:off x="457200" y="274320"/>
+            <a:ext cx="11247120" cy="914400"/>
+          </a:xfrm>
+          <a:prstGeom prst="rect">
+            <a:avLst/>
+          </a:prstGeom>
+          <a:noFill/>
+        </p:spPr>
+        <p:txBody>
+          <a:bodyPr wrap="square">
+            <a:spAutoFit/>
+          </a:bodyPr>
+          <a:lstStyle/>
+          <a:p>
+            <a:r>
+              <a:rPr sz="2800" b="1">
+                <a:solidFill>
+                  <a:srgbClr val="1F3A5F"/>
+                </a:solidFill>
+              </a:rPr>
+              <a:t>Result 1 — Within-subject: EFP wins the task-relevant targets</a:t>
             </a:r>
           </a:p>
         </p:txBody>
       </p:sp>
       <p:pic>
         <p:nvPicPr>
-          <p:cNvPr id="3" name="Picture 2" descr="paper_fig2_schematic_PDA_tr.png"/>
+          <p:cNvPr id="3" name="Picture 2" descr="ppt_within_bars.png"/>
           <p:cNvPicPr>
             <a:picLocks noChangeAspect="1"/>
           </p:cNvPicPr>
@@ -3232,14 +3412,63 @@
         </p:blipFill>
         <p:spPr>
           <a:xfrm>
-            <a:off x="457200" y="1280160"/>
-            <a:ext cx="11247120" cy="8451978"/>
+            <a:off x="1463040" y="1371600"/>
+            <a:ext cx="9235440" cy="4416950"/>
           </a:xfrm>
           <a:prstGeom prst="rect">
             <a:avLst/>
           </a:prstGeom>
         </p:spPr>
       </p:pic>
+      <p:sp>
+        <p:nvSpPr>
+          <p:cNvPr id="4" name="TextBox 3"/>
+          <p:cNvSpPr txBox="1"/>
+          <p:nvPr/>
+        </p:nvSpPr>
+        <p:spPr>
+          <a:xfrm>
+            <a:off x="548640" y="5760720"/>
+            <a:ext cx="11064240" cy="5029200"/>
+          </a:xfrm>
+          <a:prstGeom prst="rect">
+            <a:avLst/>
+          </a:prstGeom>
+          <a:noFill/>
+        </p:spPr>
+        <p:txBody>
+          <a:bodyPr wrap="square">
+            <a:spAutoFit/>
+          </a:bodyPr>
+          <a:lstStyle/>
+          <a:p>
+            <a:pPr>
+              <a:spcAft>
+                <a:spcPts val="600"/>
+              </a:spcAft>
+            </a:pPr>
+            <a:r>
+              <a:rPr sz="1300" b="1">
+                <a:solidFill>
+                  <a:srgbClr val="2E7D32"/>
+                </a:solidFill>
+              </a:rPr>
+              <a:t>• EFP leads on CEN (0.159), PDA (0.169), GSR_CEN (0.171), GSR_PDA (0.141) — including PDA, the neurofeedback target.</a:t>
+            </a:r>
+          </a:p>
+          <a:p>
+            <a:pPr>
+              <a:spcAft>
+                <a:spcPts val="600"/>
+              </a:spcAft>
+            </a:pPr>
+            <a:r>
+              <a:rPr sz="1300" b="0"/>
+              <a:t>• T/A edges DMN; HRF edges the two hardest (VIS, GSR_DMN). Honest, fair, nested numbers.</a:t>
+            </a:r>
+          </a:p>
+        </p:txBody>
+      </p:sp>
     </p:spTree>
   </p:cSld>
   <p:clrMapOvr>
@@ -3248,8 +3477,8 @@
 </p:sld>
 </file>
 
-<file path=ppt/slides/slide11.xml><?xml version="1.0" encoding="utf-8"?>
-<p:sld xmlns:a="http://schemas.openxmlformats.org/drawingml/2006/main" xmlns:p="http://schemas.openxmlformats.org/presentationml/2006/main" xmlns:r="http://schemas.openxmlformats.org/officeDocument/2006/relationships">
+<file path=ppt/slides/slide12.xml><?xml version="1.0" encoding="utf-8"?>
+<p:sld xmlns:a="http://schemas.openxmlformats.org/drawingml/2006/main" xmlns:r="http://schemas.openxmlformats.org/officeDocument/2006/relationships" xmlns:p="http://schemas.openxmlformats.org/presentationml/2006/main">
   <p:cSld>
     <p:spTree>
       <p:nvGrpSpPr>
@@ -3257,7 +3486,14 @@
         <p:cNvGrpSpPr/>
         <p:nvPr/>
       </p:nvGrpSpPr>
-      <p:grpSpPr/>
+      <p:grpSpPr>
+        <a:xfrm>
+          <a:off x="0" y="0"/>
+          <a:ext cx="0" cy="0"/>
+          <a:chOff x="0" y="0"/>
+          <a:chExt cx="0" cy="0"/>
+        </a:xfrm>
+      </p:grpSpPr>
       <p:sp>
         <p:nvSpPr>
           <p:cNvPr id="2" name="TextBox 1"/>
@@ -3281,29 +3517,29 @@
           <a:lstStyle/>
           <a:p>
             <a:r>
-              <a:rPr sz="3000" b="1">
+              <a:rPr sz="2800" b="1">
                 <a:solidFill>
                   <a:srgbClr val="1F3A5F"/>
                 </a:solidFill>
               </a:rPr>
-              <a:t>Paper-style figures IV — prediction I/O, PDA (Fig 3 analog)</a:t>
-            </a:r>
-          </a:p>
-          <a:p>
-            <a:r>
-              <a:rPr sz="1500">
+              <a:t>Result 1b — Substantial individual variability</a:t>
+            </a:r>
+          </a:p>
+          <a:p>
+            <a:r>
+              <a:rPr sz="1400">
                 <a:solidFill>
                   <a:srgbClr val="555555"/>
                 </a:solidFill>
               </a:rPr>
-              <a:t>a) ROI signal + ROI mask  b) bottom/top-25% EEG TF  c) EFP  d) predictor vs fMRI  e) per-electrode r</a:t>
+              <a:t>Per-subject EFP r by target (bar = group mean, band = 95% CI). Wide spread motivates the subject-specific electrode/band selection.</a:t>
             </a:r>
           </a:p>
         </p:txBody>
       </p:sp>
       <p:pic>
         <p:nvPicPr>
-          <p:cNvPr id="3" name="Picture 2" descr="paper_fig3_composite_PDA_tr.png"/>
+          <p:cNvPr id="3" name="Picture 2" descr="paper_fig_persubject_scatter_tr.png"/>
           <p:cNvPicPr>
             <a:picLocks noChangeAspect="1"/>
           </p:cNvPicPr>
@@ -3317,8 +3553,8 @@
         </p:blipFill>
         <p:spPr>
           <a:xfrm>
-            <a:off x="365760" y="1280160"/>
-            <a:ext cx="11430000" cy="8176517"/>
+            <a:off x="1371600" y="1554480"/>
+            <a:ext cx="9418320" cy="4813808"/>
           </a:xfrm>
           <a:prstGeom prst="rect">
             <a:avLst/>
@@ -3333,8 +3569,8 @@
 </p:sld>
 </file>
 
-<file path=ppt/slides/slide12.xml><?xml version="1.0" encoding="utf-8"?>
-<p:sld xmlns:a="http://schemas.openxmlformats.org/drawingml/2006/main" xmlns:p="http://schemas.openxmlformats.org/presentationml/2006/main" xmlns:r="http://schemas.openxmlformats.org/officeDocument/2006/relationships">
+<file path=ppt/slides/slide13.xml><?xml version="1.0" encoding="utf-8"?>
+<p:sld xmlns:a="http://schemas.openxmlformats.org/drawingml/2006/main" xmlns:r="http://schemas.openxmlformats.org/officeDocument/2006/relationships" xmlns:p="http://schemas.openxmlformats.org/presentationml/2006/main">
   <p:cSld>
     <p:spTree>
       <p:nvGrpSpPr>
@@ -3342,7 +3578,14 @@
         <p:cNvGrpSpPr/>
         <p:nvPr/>
       </p:nvGrpSpPr>
-      <p:grpSpPr/>
+      <p:grpSpPr>
+        <a:xfrm>
+          <a:off x="0" y="0"/>
+          <a:ext cx="0" cy="0"/>
+          <a:chOff x="0" y="0"/>
+          <a:chExt cx="0" cy="0"/>
+        </a:xfrm>
+      </p:grpSpPr>
       <p:sp>
         <p:nvSpPr>
           <p:cNvPr id="2" name="TextBox 1"/>
@@ -3366,29 +3609,19 @@
           <a:lstStyle/>
           <a:p>
             <a:r>
-              <a:rPr sz="3000" b="1">
+              <a:rPr sz="2800" b="1">
                 <a:solidFill>
                   <a:srgbClr val="1F3A5F"/>
                 </a:solidFill>
               </a:rPr>
-              <a:t>Paper-style figures IV — prediction I/O, CEN (Fig 3 analog)</a:t>
-            </a:r>
-          </a:p>
-          <a:p>
-            <a:r>
-              <a:rPr sz="1500">
-                <a:solidFill>
-                  <a:srgbClr val="555555"/>
-                </a:solidFill>
-              </a:rPr>
-              <a:t>a) ROI signal + ROI mask  b) bottom/top-25% EEG TF  c) EFP  d) predictor vs fMRI  e) per-electrode r</a:t>
+              <a:t>Result 2 — Same electrode, matched CV: the design itself wins</a:t>
             </a:r>
           </a:p>
         </p:txBody>
       </p:sp>
       <p:pic>
         <p:nvPicPr>
-          <p:cNvPr id="3" name="Picture 2" descr="paper_fig3_composite_CEN_tr.png"/>
+          <p:cNvPr id="3" name="Picture 2" descr="ppt_panel_bars.png"/>
           <p:cNvPicPr>
             <a:picLocks noChangeAspect="1"/>
           </p:cNvPicPr>
@@ -3402,14 +3635,63 @@
         </p:blipFill>
         <p:spPr>
           <a:xfrm>
-            <a:off x="365760" y="1280160"/>
-            <a:ext cx="11430000" cy="8127054"/>
+            <a:off x="1463040" y="1371600"/>
+            <a:ext cx="9235440" cy="4416950"/>
           </a:xfrm>
           <a:prstGeom prst="rect">
             <a:avLst/>
           </a:prstGeom>
         </p:spPr>
       </p:pic>
+      <p:sp>
+        <p:nvSpPr>
+          <p:cNvPr id="4" name="TextBox 3"/>
+          <p:cNvSpPr txBox="1"/>
+          <p:nvPr/>
+        </p:nvSpPr>
+        <p:spPr>
+          <a:xfrm>
+            <a:off x="548640" y="5760720"/>
+            <a:ext cx="11064240" cy="5029200"/>
+          </a:xfrm>
+          <a:prstGeom prst="rect">
+            <a:avLst/>
+          </a:prstGeom>
+          <a:noFill/>
+        </p:spPr>
+        <p:txBody>
+          <a:bodyPr wrap="square">
+            <a:spAutoFit/>
+          </a:bodyPr>
+          <a:lstStyle/>
+          <a:p>
+            <a:pPr>
+              <a:spcAft>
+                <a:spcPts val="600"/>
+              </a:spcAft>
+            </a:pPr>
+            <a:r>
+              <a:rPr sz="1300" b="1">
+                <a:solidFill>
+                  <a:srgbClr val="2E7D32"/>
+                </a:solidFill>
+              </a:rPr>
+              <a:t>• At each network's group-peak electrode, with identical estimator, the sliding-delay EFP beats the fixed-HRF design on 6 of 7 targets.</a:t>
+            </a:r>
+          </a:p>
+          <a:p>
+            <a:pPr>
+              <a:spcAft>
+                <a:spcPts val="600"/>
+              </a:spcAft>
+            </a:pPr>
+            <a:r>
+              <a:rPr sz="1300" b="0"/>
+              <a:t>• Isolates the [freq × delay] design from electrode selection — HRF only edges CEN.</a:t>
+            </a:r>
+          </a:p>
+        </p:txBody>
+      </p:sp>
     </p:spTree>
   </p:cSld>
   <p:clrMapOvr>
@@ -3418,8 +3700,8 @@
 </p:sld>
 </file>
 
-<file path=ppt/slides/slide13.xml><?xml version="1.0" encoding="utf-8"?>
-<p:sld xmlns:a="http://schemas.openxmlformats.org/drawingml/2006/main" xmlns:p="http://schemas.openxmlformats.org/presentationml/2006/main" xmlns:r="http://schemas.openxmlformats.org/officeDocument/2006/relationships">
+<file path=ppt/slides/slide14.xml><?xml version="1.0" encoding="utf-8"?>
+<p:sld xmlns:a="http://schemas.openxmlformats.org/drawingml/2006/main" xmlns:r="http://schemas.openxmlformats.org/officeDocument/2006/relationships" xmlns:p="http://schemas.openxmlformats.org/presentationml/2006/main">
   <p:cSld>
     <p:spTree>
       <p:nvGrpSpPr>
@@ -3427,7 +3709,14 @@
         <p:cNvGrpSpPr/>
         <p:nvPr/>
       </p:nvGrpSpPr>
-      <p:grpSpPr/>
+      <p:grpSpPr>
+        <a:xfrm>
+          <a:off x="0" y="0"/>
+          <a:ext cx="0" cy="0"/>
+          <a:chOff x="0" y="0"/>
+          <a:chExt cx="0" cy="0"/>
+        </a:xfrm>
+      </p:grpSpPr>
       <p:sp>
         <p:nvSpPr>
           <p:cNvPr id="2" name="TextBox 1"/>
@@ -3451,29 +3740,19 @@
           <a:lstStyle/>
           <a:p>
             <a:r>
-              <a:rPr sz="3000" b="1">
+              <a:rPr sz="2800" b="1">
                 <a:solidFill>
                   <a:srgbClr val="1F3A5F"/>
                 </a:solidFill>
               </a:rPr>
-              <a:t>Paper-style figures IV — prediction I/O, GSR_CEN (Fig 3 analog)</a:t>
-            </a:r>
-          </a:p>
-          <a:p>
-            <a:r>
-              <a:rPr sz="1500">
-                <a:solidFill>
-                  <a:srgbClr val="555555"/>
-                </a:solidFill>
-              </a:rPr>
-              <a:t>a) ROI signal + ROI mask  b) bottom/top-25% EEG TF  c) EFP  d) predictor vs fMRI  e) per-electrode r</a:t>
+              <a:t>Result 3 — Interpretable fingerprints (a learned HRF per frequency)</a:t>
             </a:r>
           </a:p>
         </p:txBody>
       </p:sp>
       <p:pic>
         <p:nvPicPr>
-          <p:cNvPr id="3" name="Picture 2" descr="paper_fig3_composite_GSR_CEN_tr.png"/>
+          <p:cNvPr id="3" name="Picture 2" descr="paper_fig_fingerprints_tr.png"/>
           <p:cNvPicPr>
             <a:picLocks noChangeAspect="1"/>
           </p:cNvPicPr>
@@ -3487,8 +3766,8 @@
         </p:blipFill>
         <p:spPr>
           <a:xfrm>
-            <a:off x="365760" y="1280160"/>
-            <a:ext cx="11430000" cy="8127054"/>
+            <a:off x="1598964" y="972610"/>
+            <a:ext cx="9448264" cy="5212835"/>
           </a:xfrm>
           <a:prstGeom prst="rect">
             <a:avLst/>
@@ -3503,8 +3782,8 @@
 </p:sld>
 </file>
 
-<file path=ppt/slides/slide14.xml><?xml version="1.0" encoding="utf-8"?>
-<p:sld xmlns:a="http://schemas.openxmlformats.org/drawingml/2006/main" xmlns:p="http://schemas.openxmlformats.org/presentationml/2006/main" xmlns:r="http://schemas.openxmlformats.org/officeDocument/2006/relationships">
+<file path=ppt/slides/slide15.xml><?xml version="1.0" encoding="utf-8"?>
+<p:sld xmlns:a="http://schemas.openxmlformats.org/drawingml/2006/main" xmlns:r="http://schemas.openxmlformats.org/officeDocument/2006/relationships" xmlns:p="http://schemas.openxmlformats.org/presentationml/2006/main">
   <p:cSld>
     <p:spTree>
       <p:nvGrpSpPr>
@@ -3512,7 +3791,14 @@
         <p:cNvGrpSpPr/>
         <p:nvPr/>
       </p:nvGrpSpPr>
-      <p:grpSpPr/>
+      <p:grpSpPr>
+        <a:xfrm>
+          <a:off x="0" y="0"/>
+          <a:ext cx="0" cy="0"/>
+          <a:chOff x="0" y="0"/>
+          <a:chExt cx="0" cy="0"/>
+        </a:xfrm>
+      </p:grpSpPr>
       <p:sp>
         <p:nvSpPr>
           <p:cNvPr id="2" name="TextBox 1"/>
@@ -3536,22 +3822,590 @@
           <a:lstStyle/>
           <a:p>
             <a:r>
-              <a:rPr sz="3000" b="1">
+              <a:rPr sz="2800" b="1">
                 <a:solidFill>
                   <a:srgbClr val="1F3A5F"/>
                 </a:solidFill>
               </a:rPr>
-              <a:t>Positive control — visual cortex (Fig 5 analog)</a:t>
-            </a:r>
-          </a:p>
-          <a:p>
-            <a:r>
-              <a:rPr sz="1500">
+              <a:t>Result 4 — Electrode topography with per-electrode FDR</a:t>
+            </a:r>
+          </a:p>
+          <a:p>
+            <a:r>
+              <a:rPr sz="1400">
                 <a:solidFill>
                   <a:srgbClr val="555555"/>
                 </a:solidFill>
               </a:rPr>
-              <a:t>Focal 6mm calcarine sphere (MNI -1,-86,13 ~ V1). Blind EFP localizes posteriorly (group-mean peak Pz; LOSO best O2) with alpha modulation — recovers occipital topography, validating the method</a:t>
+              <a:t>Per-electrode CV r; black dots = BH-FDR-significant electrodes ('mark, don't mask')</a:t>
+            </a:r>
+          </a:p>
+        </p:txBody>
+      </p:sp>
+      <p:pic>
+        <p:nvPicPr>
+          <p:cNvPr id="3" name="Picture 2" descr="paper_fig_r_topomap_PDA_tr.png"/>
+          <p:cNvPicPr>
+            <a:picLocks noChangeAspect="1"/>
+          </p:cNvPicPr>
+          <p:nvPr/>
+        </p:nvPicPr>
+        <p:blipFill>
+          <a:blip r:embed="rId2"/>
+          <a:stretch>
+            <a:fillRect/>
+          </a:stretch>
+        </p:blipFill>
+        <p:spPr>
+          <a:xfrm>
+            <a:off x="548640" y="1554480"/>
+            <a:ext cx="3566160" cy="3429000"/>
+          </a:xfrm>
+          <a:prstGeom prst="rect">
+            <a:avLst/>
+          </a:prstGeom>
+        </p:spPr>
+      </p:pic>
+      <p:pic>
+        <p:nvPicPr>
+          <p:cNvPr id="4" name="Picture 3" descr="paper_fig_r_topomap_CEN_tr.png"/>
+          <p:cNvPicPr>
+            <a:picLocks noChangeAspect="1"/>
+          </p:cNvPicPr>
+          <p:nvPr/>
+        </p:nvPicPr>
+        <p:blipFill>
+          <a:blip r:embed="rId3"/>
+          <a:stretch>
+            <a:fillRect/>
+          </a:stretch>
+        </p:blipFill>
+        <p:spPr>
+          <a:xfrm>
+            <a:off x="4297680" y="1554480"/>
+            <a:ext cx="3566160" cy="3429000"/>
+          </a:xfrm>
+          <a:prstGeom prst="rect">
+            <a:avLst/>
+          </a:prstGeom>
+        </p:spPr>
+      </p:pic>
+      <p:pic>
+        <p:nvPicPr>
+          <p:cNvPr id="5" name="Picture 4" descr="paper_fig_r_topomap_GSR_CEN_tr.png"/>
+          <p:cNvPicPr>
+            <a:picLocks noChangeAspect="1"/>
+          </p:cNvPicPr>
+          <p:nvPr/>
+        </p:nvPicPr>
+        <p:blipFill>
+          <a:blip r:embed="rId4"/>
+          <a:stretch>
+            <a:fillRect/>
+          </a:stretch>
+        </p:blipFill>
+        <p:spPr>
+          <a:xfrm>
+            <a:off x="8046720" y="1554480"/>
+            <a:ext cx="3566160" cy="3429000"/>
+          </a:xfrm>
+          <a:prstGeom prst="rect">
+            <a:avLst/>
+          </a:prstGeom>
+        </p:spPr>
+      </p:pic>
+      <p:sp>
+        <p:nvSpPr>
+          <p:cNvPr id="6" name="TextBox 5"/>
+          <p:cNvSpPr txBox="1"/>
+          <p:nvPr/>
+        </p:nvSpPr>
+        <p:spPr>
+          <a:xfrm>
+            <a:off x="548640" y="5394960"/>
+            <a:ext cx="11064240" cy="5029200"/>
+          </a:xfrm>
+          <a:prstGeom prst="rect">
+            <a:avLst/>
+          </a:prstGeom>
+          <a:noFill/>
+        </p:spPr>
+        <p:txBody>
+          <a:bodyPr wrap="square">
+            <a:spAutoFit/>
+          </a:bodyPr>
+          <a:lstStyle/>
+          <a:p>
+            <a:pPr>
+              <a:spcAft>
+                <a:spcPts val="600"/>
+              </a:spcAft>
+            </a:pPr>
+            <a:r>
+              <a:rPr sz="1300" b="0"/>
+              <a:t>• PDA peaks parietally (Pz); CEN centrally; sensible, spatially-focal topographies survive FDR — not a diffuse everywhere-significant artifact.</a:t>
+            </a:r>
+          </a:p>
+        </p:txBody>
+      </p:sp>
+    </p:spTree>
+  </p:cSld>
+  <p:clrMapOvr>
+    <a:masterClrMapping/>
+  </p:clrMapOvr>
+</p:sld>
+</file>
+
+<file path=ppt/slides/slide16.xml><?xml version="1.0" encoding="utf-8"?>
+<p:sld xmlns:a="http://schemas.openxmlformats.org/drawingml/2006/main" xmlns:r="http://schemas.openxmlformats.org/officeDocument/2006/relationships" xmlns:p="http://schemas.openxmlformats.org/presentationml/2006/main">
+  <p:cSld>
+    <p:spTree>
+      <p:nvGrpSpPr>
+        <p:cNvPr id="1" name=""/>
+        <p:cNvGrpSpPr/>
+        <p:nvPr/>
+      </p:nvGrpSpPr>
+      <p:grpSpPr>
+        <a:xfrm>
+          <a:off x="0" y="0"/>
+          <a:ext cx="0" cy="0"/>
+          <a:chOff x="0" y="0"/>
+          <a:chExt cx="0" cy="0"/>
+        </a:xfrm>
+      </p:grpSpPr>
+      <p:sp>
+        <p:nvSpPr>
+          <p:cNvPr id="2" name="TextBox 1"/>
+          <p:cNvSpPr txBox="1"/>
+          <p:nvPr/>
+        </p:nvSpPr>
+        <p:spPr>
+          <a:xfrm>
+            <a:off x="457200" y="274320"/>
+            <a:ext cx="11247120" cy="914400"/>
+          </a:xfrm>
+          <a:prstGeom prst="rect">
+            <a:avLst/>
+          </a:prstGeom>
+          <a:noFill/>
+        </p:spPr>
+        <p:txBody>
+          <a:bodyPr wrap="square">
+            <a:spAutoFit/>
+          </a:bodyPr>
+          <a:lstStyle/>
+          <a:p>
+            <a:r>
+              <a:rPr sz="2800" b="1">
+                <a:solidFill>
+                  <a:srgbClr val="1F3A5F"/>
+                </a:solidFill>
+              </a:rPr>
+              <a:t>Result 5 — Cross-subject generalization (LOSO, n=17)</a:t>
+            </a:r>
+          </a:p>
+        </p:txBody>
+      </p:sp>
+      <p:sp>
+        <p:nvSpPr>
+          <p:cNvPr id="3" name="TextBox 2"/>
+          <p:cNvSpPr txBox="1"/>
+          <p:nvPr/>
+        </p:nvSpPr>
+        <p:spPr>
+          <a:xfrm>
+            <a:off x="548640" y="1463040"/>
+            <a:ext cx="11064240" cy="5029200"/>
+          </a:xfrm>
+          <a:prstGeom prst="rect">
+            <a:avLst/>
+          </a:prstGeom>
+          <a:noFill/>
+        </p:spPr>
+        <p:txBody>
+          <a:bodyPr wrap="square">
+            <a:spAutoFit/>
+          </a:bodyPr>
+          <a:lstStyle/>
+          <a:p>
+            <a:pPr>
+              <a:spcAft>
+                <a:spcPts val="600"/>
+              </a:spcAft>
+            </a:pPr>
+            <a:r>
+              <a:rPr sz="1700" b="1">
+                <a:solidFill>
+                  <a:srgbClr val="1F3A5F"/>
+                </a:solidFill>
+              </a:rPr>
+              <a:t>• General fingerprint: train on N−1 subjects at the group-peak electrode, predict the held-out subject (leak-free electrode selection).</a:t>
+            </a:r>
+          </a:p>
+          <a:p>
+            <a:pPr lvl="1">
+              <a:spcAft>
+                <a:spcPts val="600"/>
+              </a:spcAft>
+            </a:pPr>
+            <a:r>
+              <a:rPr sz="1500" b="0">
+                <a:solidFill>
+                  <a:srgbClr val="2E7D32"/>
+                </a:solidFill>
+              </a:rPr>
+              <a:t>– PDA: r=+0.161 (p=0.008, Pz)</a:t>
+            </a:r>
+          </a:p>
+          <a:p>
+            <a:pPr lvl="1">
+              <a:spcAft>
+                <a:spcPts val="600"/>
+              </a:spcAft>
+            </a:pPr>
+            <a:r>
+              <a:rPr sz="1500" b="0">
+                <a:solidFill>
+                  <a:srgbClr val="2E7D32"/>
+                </a:solidFill>
+              </a:rPr>
+              <a:t>– GSR_PDA: r=+0.161 (p=0.005)   ·   GSR_CEN: r=+0.153 (p=0.011)</a:t>
+            </a:r>
+          </a:p>
+          <a:p>
+            <a:pPr lvl="1">
+              <a:spcAft>
+                <a:spcPts val="600"/>
+              </a:spcAft>
+            </a:pPr>
+            <a:r>
+              <a:rPr sz="1500" b="0"/>
+              <a:t>– CEN: r=+0.124 (p=0.001)   ·   DMN: r=+0.096 (p=0.011)   ·   VIS: r=+0.050 (p=0.031)</a:t>
+            </a:r>
+          </a:p>
+          <a:p>
+            <a:pPr lvl="1">
+              <a:spcAft>
+                <a:spcPts val="600"/>
+              </a:spcAft>
+            </a:pPr>
+            <a:r>
+              <a:rPr sz="1500" b="0">
+                <a:solidFill>
+                  <a:srgbClr val="B03A2E"/>
+                </a:solidFill>
+              </a:rPr>
+              <a:t>– GSR_DMN: r=-0.012 (p=0.653) — the only target that fails to transfer.</a:t>
+            </a:r>
+          </a:p>
+          <a:p>
+            <a:pPr>
+              <a:spcAft>
+                <a:spcPts val="600"/>
+              </a:spcAft>
+            </a:pPr>
+            <a:r>
+              <a:rPr sz="1700" b="1">
+                <a:solidFill>
+                  <a:srgbClr val="2E7D32"/>
+                </a:solidFill>
+              </a:rPr>
+              <a:t>• 6 of 7 targets transfer across subjects — a genuinely general EEG fingerprint.</a:t>
+            </a:r>
+          </a:p>
+        </p:txBody>
+      </p:sp>
+    </p:spTree>
+  </p:cSld>
+  <p:clrMapOvr>
+    <a:masterClrMapping/>
+  </p:clrMapOvr>
+</p:sld>
+</file>
+
+<file path=ppt/slides/slide17.xml><?xml version="1.0" encoding="utf-8"?>
+<p:sld xmlns:a="http://schemas.openxmlformats.org/drawingml/2006/main" xmlns:r="http://schemas.openxmlformats.org/officeDocument/2006/relationships" xmlns:p="http://schemas.openxmlformats.org/presentationml/2006/main">
+  <p:cSld>
+    <p:spTree>
+      <p:nvGrpSpPr>
+        <p:cNvPr id="1" name=""/>
+        <p:cNvGrpSpPr/>
+        <p:nvPr/>
+      </p:nvGrpSpPr>
+      <p:grpSpPr>
+        <a:xfrm>
+          <a:off x="0" y="0"/>
+          <a:ext cx="0" cy="0"/>
+          <a:chOff x="0" y="0"/>
+          <a:chExt cx="0" cy="0"/>
+        </a:xfrm>
+      </p:grpSpPr>
+      <p:sp>
+        <p:nvSpPr>
+          <p:cNvPr id="2" name="TextBox 1"/>
+          <p:cNvSpPr txBox="1"/>
+          <p:nvPr/>
+        </p:nvSpPr>
+        <p:spPr>
+          <a:xfrm>
+            <a:off x="457200" y="274320"/>
+            <a:ext cx="11247120" cy="914400"/>
+          </a:xfrm>
+          <a:prstGeom prst="rect">
+            <a:avLst/>
+          </a:prstGeom>
+          <a:noFill/>
+        </p:spPr>
+        <p:txBody>
+          <a:bodyPr wrap="square">
+            <a:spAutoFit/>
+          </a:bodyPr>
+          <a:lstStyle/>
+          <a:p>
+            <a:r>
+              <a:rPr sz="2800" b="1">
+                <a:solidFill>
+                  <a:srgbClr val="1F3A5F"/>
+                </a:solidFill>
+              </a:rPr>
+              <a:t>Result 6 — External validation: transfers to an independent cohort</a:t>
+            </a:r>
+          </a:p>
+          <a:p>
+            <a:r>
+              <a:rPr sz="1400">
+                <a:solidFill>
+                  <a:srgbClr val="555555"/>
+                </a:solidFill>
+              </a:rPr>
+              <a:t>Train the DMNELF general fingerprint (n=17), predict the rtBPD cohort — no rtBPD data in training/selection</a:t>
+            </a:r>
+          </a:p>
+        </p:txBody>
+      </p:sp>
+      <p:pic>
+        <p:nvPicPr>
+          <p:cNvPr id="3" name="Picture 2" descr="ppt_gen_ladder.png"/>
+          <p:cNvPicPr>
+            <a:picLocks noChangeAspect="1"/>
+          </p:cNvPicPr>
+          <p:nvPr/>
+        </p:nvPicPr>
+        <p:blipFill>
+          <a:blip r:embed="rId2"/>
+          <a:stretch>
+            <a:fillRect/>
+          </a:stretch>
+        </p:blipFill>
+        <p:spPr>
+          <a:xfrm>
+            <a:off x="457200" y="1417320"/>
+            <a:ext cx="6766560" cy="3171825"/>
+          </a:xfrm>
+          <a:prstGeom prst="rect">
+            <a:avLst/>
+          </a:prstGeom>
+        </p:spPr>
+      </p:pic>
+      <p:sp>
+        <p:nvSpPr>
+          <p:cNvPr id="4" name="TextBox 3"/>
+          <p:cNvSpPr txBox="1"/>
+          <p:nvPr/>
+        </p:nvSpPr>
+        <p:spPr>
+          <a:xfrm>
+            <a:off x="7406640" y="1463040"/>
+            <a:ext cx="4480560" cy="5029200"/>
+          </a:xfrm>
+          <a:prstGeom prst="rect">
+            <a:avLst/>
+          </a:prstGeom>
+          <a:noFill/>
+        </p:spPr>
+        <p:txBody>
+          <a:bodyPr wrap="square">
+            <a:spAutoFit/>
+          </a:bodyPr>
+          <a:lstStyle/>
+          <a:p>
+            <a:pPr>
+              <a:spcAft>
+                <a:spcPts val="600"/>
+              </a:spcAft>
+            </a:pPr>
+            <a:r>
+              <a:rPr sz="1400" b="1">
+                <a:solidFill>
+                  <a:srgbClr val="1F3A5F"/>
+                </a:solidFill>
+              </a:rPr>
+              <a:t>• Double replication:</a:t>
+            </a:r>
+          </a:p>
+          <a:p>
+            <a:pPr lvl="1">
+              <a:spcAft>
+                <a:spcPts val="600"/>
+              </a:spcAft>
+            </a:pPr>
+            <a:r>
+              <a:rPr sz="1200" b="1">
+                <a:solidFill>
+                  <a:srgbClr val="2E7D32"/>
+                </a:solidFill>
+              </a:rPr>
+              <a:t>– nf1: 7/7 targets significant</a:t>
+            </a:r>
+          </a:p>
+          <a:p>
+            <a:pPr lvl="1">
+              <a:spcAft>
+                <a:spcPts val="600"/>
+              </a:spcAft>
+            </a:pPr>
+            <a:r>
+              <a:rPr sz="1200" b="1">
+                <a:solidFill>
+                  <a:srgbClr val="2E7D32"/>
+                </a:solidFill>
+              </a:rPr>
+              <a:t>– nf2: 6/7 significant (GSR_DMN only miss)</a:t>
+            </a:r>
+          </a:p>
+          <a:p>
+            <a:pPr lvl="1">
+              <a:spcAft>
+                <a:spcPts val="600"/>
+              </a:spcAft>
+            </a:pPr>
+            <a:r>
+              <a:rPr sz="1200" b="0"/>
+              <a:t>– CEN +0.138/+0.113</a:t>
+            </a:r>
+          </a:p>
+          <a:p>
+            <a:pPr lvl="1">
+              <a:spcAft>
+                <a:spcPts val="600"/>
+              </a:spcAft>
+            </a:pPr>
+            <a:r>
+              <a:rPr sz="1200" b="0">
+                <a:solidFill>
+                  <a:srgbClr val="2E7D32"/>
+                </a:solidFill>
+              </a:rPr>
+              <a:t>– PDA +0.067/+0.153</a:t>
+            </a:r>
+          </a:p>
+          <a:p>
+            <a:pPr lvl="1">
+              <a:spcAft>
+                <a:spcPts val="600"/>
+              </a:spcAft>
+            </a:pPr>
+            <a:r>
+              <a:rPr sz="1200" b="0"/>
+              <a:t>– VIS +0.145/+0.121</a:t>
+            </a:r>
+          </a:p>
+          <a:p>
+            <a:pPr lvl="1">
+              <a:spcAft>
+                <a:spcPts val="600"/>
+              </a:spcAft>
+            </a:pPr>
+            <a:r>
+              <a:rPr sz="1200" b="0">
+                <a:solidFill>
+                  <a:srgbClr val="2E7D32"/>
+                </a:solidFill>
+              </a:rPr>
+              <a:t>– GSR_PDA +0.064/+0.136</a:t>
+            </a:r>
+          </a:p>
+          <a:p>
+            <a:pPr>
+              <a:spcAft>
+                <a:spcPts val="600"/>
+              </a:spcAft>
+            </a:pPr>
+            <a:r>
+              <a:rPr sz="1400" b="1">
+                <a:solidFill>
+                  <a:srgbClr val="1F3A5F"/>
+                </a:solidFill>
+              </a:rPr>
+              <a:t>• Strongest evidence the EFP captures a real, transferable EEG→BOLD mapping.</a:t>
+            </a:r>
+          </a:p>
+        </p:txBody>
+      </p:sp>
+    </p:spTree>
+  </p:cSld>
+  <p:clrMapOvr>
+    <a:masterClrMapping/>
+  </p:clrMapOvr>
+</p:sld>
+</file>
+
+<file path=ppt/slides/slide18.xml><?xml version="1.0" encoding="utf-8"?>
+<p:sld xmlns:a="http://schemas.openxmlformats.org/drawingml/2006/main" xmlns:r="http://schemas.openxmlformats.org/officeDocument/2006/relationships" xmlns:p="http://schemas.openxmlformats.org/presentationml/2006/main">
+  <p:cSld>
+    <p:spTree>
+      <p:nvGrpSpPr>
+        <p:cNvPr id="1" name=""/>
+        <p:cNvGrpSpPr/>
+        <p:nvPr/>
+      </p:nvGrpSpPr>
+      <p:grpSpPr>
+        <a:xfrm>
+          <a:off x="0" y="0"/>
+          <a:ext cx="0" cy="0"/>
+          <a:chOff x="0" y="0"/>
+          <a:chExt cx="0" cy="0"/>
+        </a:xfrm>
+      </p:grpSpPr>
+      <p:sp>
+        <p:nvSpPr>
+          <p:cNvPr id="2" name="TextBox 1"/>
+          <p:cNvSpPr txBox="1"/>
+          <p:nvPr/>
+        </p:nvSpPr>
+        <p:spPr>
+          <a:xfrm>
+            <a:off x="457200" y="274320"/>
+            <a:ext cx="11247120" cy="914400"/>
+          </a:xfrm>
+          <a:prstGeom prst="rect">
+            <a:avLst/>
+          </a:prstGeom>
+          <a:noFill/>
+        </p:spPr>
+        <p:txBody>
+          <a:bodyPr wrap="square">
+            <a:spAutoFit/>
+          </a:bodyPr>
+          <a:lstStyle/>
+          <a:p>
+            <a:r>
+              <a:rPr sz="2800" b="1">
+                <a:solidFill>
+                  <a:srgbClr val="1F3A5F"/>
+                </a:solidFill>
+              </a:rPr>
+              <a:t>Positive control — visual cortex (Meir-Hasson Fig 5 analog)</a:t>
+            </a:r>
+          </a:p>
+          <a:p>
+            <a:r>
+              <a:rPr sz="1400">
+                <a:solidFill>
+                  <a:srgbClr val="555555"/>
+                </a:solidFill>
+              </a:rPr>
+              <a:t>Focal 6 mm calcarine sphere (≈V1). The blind EFP localizes posteriorly (peak Oz) with alpha modulation — recovering occipital topography validates the method.</a:t>
             </a:r>
           </a:p>
         </p:txBody>
@@ -3572,8 +4426,8 @@
         </p:blipFill>
         <p:spPr>
           <a:xfrm>
-            <a:off x="274320" y="1371600"/>
-            <a:ext cx="8595360" cy="6111545"/>
+            <a:off x="810201" y="1396838"/>
+            <a:ext cx="6923922" cy="4923105"/>
           </a:xfrm>
           <a:prstGeom prst="rect">
             <a:avLst/>
@@ -3596,7 +4450,7 @@
         </p:blipFill>
         <p:spPr>
           <a:xfrm>
-            <a:off x="9052560" y="1737360"/>
+            <a:off x="9052560" y="1828800"/>
             <a:ext cx="2926080" cy="2709333"/>
           </a:xfrm>
           <a:prstGeom prst="rect">
@@ -3612,8 +4466,8 @@
 </p:sld>
 </file>
 
-<file path=ppt/slides/slide15.xml><?xml version="1.0" encoding="utf-8"?>
-<p:sld xmlns:a="http://schemas.openxmlformats.org/drawingml/2006/main" xmlns:p="http://schemas.openxmlformats.org/presentationml/2006/main" xmlns:r="http://schemas.openxmlformats.org/officeDocument/2006/relationships">
+<file path=ppt/slides/slide19.xml><?xml version="1.0" encoding="utf-8"?>
+<p:sld xmlns:a="http://schemas.openxmlformats.org/drawingml/2006/main" xmlns:r="http://schemas.openxmlformats.org/officeDocument/2006/relationships" xmlns:p="http://schemas.openxmlformats.org/presentationml/2006/main">
   <p:cSld>
     <p:spTree>
       <p:nvGrpSpPr>
@@ -3621,7 +4475,14 @@
         <p:cNvGrpSpPr/>
         <p:nvPr/>
       </p:nvGrpSpPr>
-      <p:grpSpPr/>
+      <p:grpSpPr>
+        <a:xfrm>
+          <a:off x="0" y="0"/>
+          <a:ext cx="0" cy="0"/>
+          <a:chOff x="0" y="0"/>
+          <a:chExt cx="0" cy="0"/>
+        </a:xfrm>
+      </p:grpSpPr>
       <p:sp>
         <p:nvSpPr>
           <p:cNvPr id="2" name="TextBox 1"/>
@@ -3645,12 +4506,12 @@
           <a:lstStyle/>
           <a:p>
             <a:r>
-              <a:rPr sz="3000" b="1">
+              <a:rPr sz="2800" b="1">
                 <a:solidFill>
                   <a:srgbClr val="1F3A5F"/>
                 </a:solidFill>
               </a:rPr>
-              <a:t>Verdict</a:t>
+              <a:t>Bottom Line</a:t>
             </a:r>
           </a:p>
         </p:txBody>
@@ -3663,7 +4524,7 @@
         </p:nvSpPr>
         <p:spPr>
           <a:xfrm>
-            <a:off x="548640" y="1371600"/>
+            <a:off x="548640" y="1417320"/>
             <a:ext cx="11064240" cy="5029200"/>
           </a:xfrm>
           <a:prstGeom prst="rect">
@@ -3688,7 +4549,7 @@
                   <a:srgbClr val="1F3A5F"/>
                 </a:solidFill>
               </a:rPr>
-              <a:t>• Faithful EFP replication succeeds on DMNELF.</a:t>
+              <a:t>• A faithful, bulletproofed EFP replication succeeds on DMNELF.</a:t>
             </a:r>
           </a:p>
           <a:p>
@@ -3698,8 +4559,12 @@
               </a:spcAft>
             </a:pPr>
             <a:r>
-              <a:rPr sz="1400" b="0"/>
-              <a:t>– The sliding-delay single-electrode fingerprint is our best DMN/CEN/PDA decoder to date, within-subject (PDA r≈0.26, CEN r≈0.28).</a:t>
+              <a:rPr sz="1400" b="0">
+                <a:solidFill>
+                  <a:srgbClr val="2E7D32"/>
+                </a:solidFill>
+              </a:rPr>
+              <a:t>– Within-subject: EFP is our best single-electrode decoder — PDA 0.169, CEN 0.159, GSR_CEN 0.171.</a:t>
             </a:r>
           </a:p>
           <a:p>
@@ -3710,7 +4575,7 @@
             </a:pPr>
             <a:r>
               <a:rPr sz="1400" b="0"/>
-              <a:t>– A general (LOSO) PDA fingerprint transfers across subjects (r≈0.13, p=0.01) — promising for EEG-only neurofeedback.</a:t>
+              <a:t>– Same-electrode panel: the sliding-delay design beats fixed-HRF 6/7 — the design, not electrode luck, drives it.</a:t>
             </a:r>
           </a:p>
           <a:p>
@@ -3720,8 +4585,27 @@
               </a:spcAft>
             </a:pPr>
             <a:r>
-              <a:rPr sz="1400" b="0"/>
-              <a:t>– Interpretable [freq × delay] fingerprints show HRF-plausible per-frequency delays — good paper figures.</a:t>
+              <a:rPr sz="1400" b="0">
+                <a:solidFill>
+                  <a:srgbClr val="2E7D32"/>
+                </a:solidFill>
+              </a:rPr>
+              <a:t>– LOSO: 6/7 targets transfer across subjects (PDA +0.161, p=0.008).</a:t>
+            </a:r>
+          </a:p>
+          <a:p>
+            <a:pPr lvl="1">
+              <a:spcAft>
+                <a:spcPts val="600"/>
+              </a:spcAft>
+            </a:pPr>
+            <a:r>
+              <a:rPr sz="1400" b="1">
+                <a:solidFill>
+                  <a:srgbClr val="2E7D32"/>
+                </a:solidFill>
+              </a:rPr>
+              <a:t>– Cross-cohort: 7/7 (nf1) &amp; 6/7 (nf2) replicate in an independent cohort — a general, transferable fingerprint.</a:t>
             </a:r>
           </a:p>
           <a:p>
@@ -3736,7 +4620,7 @@
                   <a:srgbClr val="1F3A5F"/>
                 </a:solidFill>
               </a:rPr>
-              <a:t>• Caveats</a:t>
+              <a:t>• Rigor</a:t>
             </a:r>
           </a:p>
           <a:p>
@@ -3747,18 +4631,7 @@
             </a:pPr>
             <a:r>
               <a:rPr sz="1400" b="0"/>
-              <a:t>– GSR_DMN remains hard (within and across subjects).</a:t>
-            </a:r>
-          </a:p>
-          <a:p>
-            <a:pPr lvl="1">
-              <a:spcAft>
-                <a:spcPts val="600"/>
-              </a:spcAft>
-            </a:pPr>
-            <a:r>
-              <a:rPr sz="1400" b="0"/>
-              <a:t>– LOSO uses band-index alignment across per-subject data-driven bands (approximation); a fixed-band group model is the natural next step.</a:t>
+              <a:t>– Two audit artifacts (selection bias, normalization) caught and fixed; the result held on honest numbers. v1 frozen at tag efp-preprint-v1.</a:t>
             </a:r>
           </a:p>
         </p:txBody>
@@ -3772,7 +4645,7 @@
 </file>
 
 <file path=ppt/slides/slide2.xml><?xml version="1.0" encoding="utf-8"?>
-<p:sld xmlns:a="http://schemas.openxmlformats.org/drawingml/2006/main" xmlns:p="http://schemas.openxmlformats.org/presentationml/2006/main" xmlns:r="http://schemas.openxmlformats.org/officeDocument/2006/relationships">
+<p:sld xmlns:a="http://schemas.openxmlformats.org/drawingml/2006/main" xmlns:r="http://schemas.openxmlformats.org/officeDocument/2006/relationships" xmlns:p="http://schemas.openxmlformats.org/presentationml/2006/main">
   <p:cSld>
     <p:spTree>
       <p:nvGrpSpPr>
@@ -3780,7 +4653,14 @@
         <p:cNvGrpSpPr/>
         <p:nvPr/>
       </p:nvGrpSpPr>
-      <p:grpSpPr/>
+      <p:grpSpPr>
+        <a:xfrm>
+          <a:off x="0" y="0"/>
+          <a:ext cx="0" cy="0"/>
+          <a:chOff x="0" y="0"/>
+          <a:chExt cx="0" cy="0"/>
+        </a:xfrm>
+      </p:grpSpPr>
       <p:sp>
         <p:nvSpPr>
           <p:cNvPr id="2" name="TextBox 1"/>
@@ -3804,12 +4684,12 @@
           <a:lstStyle/>
           <a:p>
             <a:r>
-              <a:rPr sz="3000" b="1">
+              <a:rPr sz="2800" b="1">
                 <a:solidFill>
                   <a:srgbClr val="1F3A5F"/>
                 </a:solidFill>
               </a:rPr>
-              <a:t>The EFP method (what makes it different)</a:t>
+              <a:t>The Goal</a:t>
             </a:r>
           </a:p>
         </p:txBody>
@@ -3822,8 +4702,8 @@
         </p:nvSpPr>
         <p:spPr>
           <a:xfrm>
-            <a:off x="548640" y="1371600"/>
-            <a:ext cx="11064240" cy="5029200"/>
+            <a:off x="548640" y="1463040"/>
+            <a:ext cx="11064240" cy="2262158"/>
           </a:xfrm>
           <a:prstGeom prst="rect">
             <a:avLst/>
@@ -3842,8 +4722,8 @@
               </a:spcAft>
             </a:pPr>
             <a:r>
-              <a:rPr sz="1600" b="0"/>
-              <a:t>• Single electrode (data-driven best, by validation NMSE) — not multivariate.</a:t>
+              <a:rPr sz="1800" b="0" dirty="0"/>
+              <a:t>• Decode fMRI network activity (DMN, CEN) and the PDA neurofeedback target from simultaneous scalp EEG.</a:t>
             </a:r>
           </a:p>
           <a:p>
@@ -3853,8 +4733,12 @@
               </a:spcAft>
             </a:pPr>
             <a:r>
-              <a:rPr sz="1600" b="0"/>
-              <a:t>• Stockwell (S-)transform time-frequency at 1 Hz (implemented from scratch, FFT-based).</a:t>
+              <a:rPr sz="1800" b="1" dirty="0">
+                <a:solidFill>
+                  <a:srgbClr val="1F77B4"/>
+                </a:solidFill>
+              </a:rPr>
+              <a:t>• Why? So EEG alone — cheap, portable, no scanner — can drive real-time neurofeedback once a mapping is learned.</a:t>
             </a:r>
           </a:p>
           <a:p>
@@ -3864,8 +4748,28 @@
               </a:spcAft>
             </a:pPr>
             <a:r>
-              <a:rPr sz="1600" b="0"/>
-              <a:t>• 10 data-driven equal-energy frequency bands (not fixed delta/theta/alpha).</a:t>
+              <a:rPr sz="1800" b="0" dirty="0"/>
+              <a:t>• PDA = the actual DMNELF neurofeedback target (personalized </a:t>
+            </a:r>
+            <a:r>
+              <a:rPr sz="1800" b="0" dirty="0">
+                <a:highlight>
+                  <a:srgbClr val="FFFF00"/>
+                </a:highlight>
+              </a:rPr>
+              <a:t>DMN–CEN </a:t>
+            </a:r>
+            <a:r>
+              <a:rPr sz="1800" b="0" dirty="0"/>
+              <a:t>differential). </a:t>
+            </a:r>
+            <a:r>
+              <a:rPr sz="1800" b="0" dirty="0" err="1"/>
+              <a:t>GSR'd</a:t>
+            </a:r>
+            <a:r>
+              <a:rPr sz="1800" b="0" dirty="0"/>
+              <a:t> targets remove the shared global-arousal signal — the hard, network-specific test.</a:t>
             </a:r>
           </a:p>
           <a:p>
@@ -3875,14 +4779,91 @@
               </a:spcAft>
             </a:pPr>
             <a:r>
-              <a:rPr sz="1600" b="1">
+              <a:rPr sz="1800" b="0" dirty="0"/>
+              <a:t>• Meir-Hasson's EFP is a single-electrode, HRF-free time-frequency fingerprint. We ask: does it replicate here, beat standard baselines, and generalize to new subjects &amp; a new cohort?</a:t>
+            </a:r>
+          </a:p>
+        </p:txBody>
+      </p:sp>
+    </p:spTree>
+  </p:cSld>
+  <p:clrMapOvr>
+    <a:masterClrMapping/>
+  </p:clrMapOvr>
+</p:sld>
+</file>
+
+<file path=ppt/slides/slide20.xml><?xml version="1.0" encoding="utf-8"?>
+<p:sld xmlns:a="http://schemas.openxmlformats.org/drawingml/2006/main" xmlns:r="http://schemas.openxmlformats.org/officeDocument/2006/relationships" xmlns:p="http://schemas.openxmlformats.org/presentationml/2006/main">
+  <p:cSld>
+    <p:spTree>
+      <p:nvGrpSpPr>
+        <p:cNvPr id="1" name=""/>
+        <p:cNvGrpSpPr/>
+        <p:nvPr/>
+      </p:nvGrpSpPr>
+      <p:grpSpPr>
+        <a:xfrm>
+          <a:off x="0" y="0"/>
+          <a:ext cx="0" cy="0"/>
+          <a:chOff x="0" y="0"/>
+          <a:chExt cx="0" cy="0"/>
+        </a:xfrm>
+      </p:grpSpPr>
+      <p:sp>
+        <p:nvSpPr>
+          <p:cNvPr id="2" name="TextBox 1"/>
+          <p:cNvSpPr txBox="1"/>
+          <p:nvPr/>
+        </p:nvSpPr>
+        <p:spPr>
+          <a:xfrm>
+            <a:off x="457200" y="274320"/>
+            <a:ext cx="11247120" cy="914400"/>
+          </a:xfrm>
+          <a:prstGeom prst="rect">
+            <a:avLst/>
+          </a:prstGeom>
+          <a:noFill/>
+        </p:spPr>
+        <p:txBody>
+          <a:bodyPr wrap="square">
+            <a:spAutoFit/>
+          </a:bodyPr>
+          <a:lstStyle/>
+          <a:p>
+            <a:r>
+              <a:rPr sz="2800" b="1">
                 <a:solidFill>
                   <a:srgbClr val="1F3A5F"/>
                 </a:solidFill>
               </a:rPr>
-              <a:t>• KEY: a [frequency × sliding time-delay] design (0..−12 s) → ridge learns a SEPARATE delay for each frequency. No assumed HRF shape.</a:t>
-            </a:r>
-          </a:p>
+              <a:t>Next Steps</a:t>
+            </a:r>
+          </a:p>
+        </p:txBody>
+      </p:sp>
+      <p:sp>
+        <p:nvSpPr>
+          <p:cNvPr id="3" name="TextBox 2"/>
+          <p:cNvSpPr txBox="1"/>
+          <p:nvPr/>
+        </p:nvSpPr>
+        <p:spPr>
+          <a:xfrm>
+            <a:off x="548640" y="1463040"/>
+            <a:ext cx="11064240" cy="5029200"/>
+          </a:xfrm>
+          <a:prstGeom prst="rect">
+            <a:avLst/>
+          </a:prstGeom>
+          <a:noFill/>
+        </p:spPr>
+        <p:txBody>
+          <a:bodyPr wrap="square">
+            <a:spAutoFit/>
+          </a:bodyPr>
+          <a:lstStyle/>
           <a:p>
             <a:pPr>
               <a:spcAft>
@@ -3890,8 +4871,8 @@
               </a:spcAft>
             </a:pPr>
             <a:r>
-              <a:rPr sz="1600" b="0"/>
-              <a:t>• Double cross-validation: outer m-k-fold block CV (k=5,m=2) + inner RidgeCV for λ.</a:t>
+              <a:rPr sz="1800" b="0"/>
+              <a:t>• Deferred controls: purged/gapped CV folds; fixed-band group transfer model (removes the band-index-alignment approximation).</a:t>
             </a:r>
           </a:p>
           <a:p>
@@ -3901,8 +4882,8 @@
               </a:spcAft>
             </a:pPr>
             <a:r>
-              <a:rPr sz="1600" b="0"/>
-              <a:t>• Baselines on same folds: Theta/Alpha ratio (traditional) and fixed-HRF predictor.</a:t>
+              <a:rPr sz="1800" b="0"/>
+              <a:t>• 4 Hz (native rate) as supplementary + null-target upsampling control; motion-regression control on base targets.</a:t>
             </a:r>
           </a:p>
           <a:p>
@@ -3912,8 +4893,23 @@
               </a:spcAft>
             </a:pPr>
             <a:r>
-              <a:rPr sz="1600" b="0"/>
-              <a:t>• Built at both native-TR and 4 Hz-upsampled resolution to test the paper's up-sampling claim.</a:t>
+              <a:rPr sz="1800" b="1">
+                <a:solidFill>
+                  <a:srgbClr val="1F77B4"/>
+                </a:solidFill>
+              </a:rPr>
+              <a:t>• Real-time path: the LOSO/cross-cohort fingerprint is ready to test as an EEG-only neurofeedback signal for PDA.</a:t>
+            </a:r>
+          </a:p>
+          <a:p>
+            <a:pPr>
+              <a:spcAft>
+                <a:spcPts val="600"/>
+              </a:spcAft>
+            </a:pPr>
+            <a:r>
+              <a:rPr sz="1800" b="0"/>
+              <a:t>• Revisit the excluded/miscoded subjects, then extend n before submission.</a:t>
             </a:r>
           </a:p>
         </p:txBody>
@@ -3927,7 +4923,7 @@
 </file>
 
 <file path=ppt/slides/slide3.xml><?xml version="1.0" encoding="utf-8"?>
-<p:sld xmlns:a="http://schemas.openxmlformats.org/drawingml/2006/main" xmlns:p="http://schemas.openxmlformats.org/presentationml/2006/main" xmlns:r="http://schemas.openxmlformats.org/officeDocument/2006/relationships">
+<p:sld xmlns:a="http://schemas.openxmlformats.org/drawingml/2006/main" xmlns:r="http://schemas.openxmlformats.org/officeDocument/2006/relationships" xmlns:p="http://schemas.openxmlformats.org/presentationml/2006/main">
   <p:cSld>
     <p:spTree>
       <p:nvGrpSpPr>
@@ -3935,7 +4931,14 @@
         <p:cNvGrpSpPr/>
         <p:nvPr/>
       </p:nvGrpSpPr>
-      <p:grpSpPr/>
+      <p:grpSpPr>
+        <a:xfrm>
+          <a:off x="0" y="0"/>
+          <a:ext cx="0" cy="0"/>
+          <a:chOff x="0" y="0"/>
+          <a:chExt cx="0" cy="0"/>
+        </a:xfrm>
+      </p:grpSpPr>
       <p:sp>
         <p:nvSpPr>
           <p:cNvPr id="2" name="TextBox 1"/>
@@ -3959,19 +4962,29 @@
           <a:lstStyle/>
           <a:p>
             <a:r>
-              <a:rPr sz="3000" b="1">
+              <a:rPr sz="2800" b="1">
                 <a:solidFill>
                   <a:srgbClr val="1F3A5F"/>
                 </a:solidFill>
               </a:rPr>
-              <a:t>Within-subject: EFP beats both baselines (EFP ≥ HRF ≥ T/A)</a:t>
+              <a:t>Methods Overview — the EFP pipeline</a:t>
+            </a:r>
+          </a:p>
+          <a:p>
+            <a:r>
+              <a:rPr sz="1400">
+                <a:solidFill>
+                  <a:srgbClr val="555555"/>
+                </a:solidFill>
+              </a:rPr>
+              <a:t>EEG → S-transform → data-driven bands → [frequency × sliding-delay] design → ridge → fMRI ROI</a:t>
             </a:r>
           </a:p>
         </p:txBody>
       </p:sp>
       <p:pic>
         <p:nvPicPr>
-          <p:cNvPr id="3" name="Picture 2" descr="fig_efp_vs_baselines.png"/>
+          <p:cNvPr id="3" name="Picture 2" descr="paper_fig2_schematic_PDA_tr.png"/>
           <p:cNvPicPr>
             <a:picLocks noChangeAspect="1"/>
           </p:cNvPicPr>
@@ -3985,48 +4998,14 @@
         </p:blipFill>
         <p:spPr>
           <a:xfrm>
-            <a:off x="1371600" y="1371600"/>
-            <a:ext cx="9418320" cy="4499864"/>
+            <a:off x="2275367" y="1188720"/>
+            <a:ext cx="7123813" cy="5353397"/>
           </a:xfrm>
           <a:prstGeom prst="rect">
             <a:avLst/>
           </a:prstGeom>
         </p:spPr>
       </p:pic>
-      <p:sp>
-        <p:nvSpPr>
-          <p:cNvPr id="4" name="TextBox 3"/>
-          <p:cNvSpPr txBox="1"/>
-          <p:nvPr/>
-        </p:nvSpPr>
-        <p:spPr>
-          <a:xfrm>
-            <a:off x="548640" y="5852160"/>
-            <a:ext cx="11064240" cy="5029200"/>
-          </a:xfrm>
-          <a:prstGeom prst="rect">
-            <a:avLst/>
-          </a:prstGeom>
-          <a:noFill/>
-        </p:spPr>
-        <p:txBody>
-          <a:bodyPr wrap="square">
-            <a:spAutoFit/>
-          </a:bodyPr>
-          <a:lstStyle/>
-          <a:p>
-            <a:pPr>
-              <a:spcAft>
-                <a:spcPts val="600"/>
-              </a:spcAft>
-            </a:pPr>
-            <a:r>
-              <a:rPr sz="1300" b="0"/>
-              <a:t>• Replicates the paper's ordering across every target; strongest for CEN, PDA, GSR_CEN, GSR_PDA (r≈0.25–0.28). GSR_DMN weakest (r≈0.11–0.17), consistent with our other pipelines.</a:t>
-            </a:r>
-          </a:p>
-        </p:txBody>
-      </p:sp>
     </p:spTree>
   </p:cSld>
   <p:clrMapOvr>
@@ -4036,7 +5015,7 @@
 </file>
 
 <file path=ppt/slides/slide4.xml><?xml version="1.0" encoding="utf-8"?>
-<p:sld xmlns:a="http://schemas.openxmlformats.org/drawingml/2006/main" xmlns:p="http://schemas.openxmlformats.org/presentationml/2006/main" xmlns:r="http://schemas.openxmlformats.org/officeDocument/2006/relationships">
+<p:sld xmlns:a="http://schemas.openxmlformats.org/drawingml/2006/main" xmlns:r="http://schemas.openxmlformats.org/officeDocument/2006/relationships" xmlns:p="http://schemas.openxmlformats.org/presentationml/2006/main">
   <p:cSld>
     <p:spTree>
       <p:nvGrpSpPr>
@@ -4044,7 +5023,14 @@
         <p:cNvGrpSpPr/>
         <p:nvPr/>
       </p:nvGrpSpPr>
-      <p:grpSpPr/>
+      <p:grpSpPr>
+        <a:xfrm>
+          <a:off x="0" y="0"/>
+          <a:ext cx="0" cy="0"/>
+          <a:chOff x="0" y="0"/>
+          <a:chExt cx="0" cy="0"/>
+        </a:xfrm>
+      </p:grpSpPr>
       <p:sp>
         <p:nvSpPr>
           <p:cNvPr id="2" name="TextBox 1"/>
@@ -4068,50 +5054,76 @@
           <a:lstStyle/>
           <a:p>
             <a:r>
-              <a:rPr sz="3000" b="1">
+              <a:rPr sz="2800" b="1">
                 <a:solidFill>
                   <a:srgbClr val="1F3A5F"/>
                 </a:solidFill>
               </a:rPr>
-              <a:t>Substantial individual variability</a:t>
-            </a:r>
-          </a:p>
-          <a:p>
-            <a:r>
-              <a:rPr sz="1500">
-                <a:solidFill>
-                  <a:srgbClr val="555555"/>
-                </a:solidFill>
-              </a:rPr>
-              <a:t>Per-subject EFP r by target (bar = group mean, band = 95% CI). Every target's CI excludes zero, but spread is wide — motivates the subject-specific electrode selection.</a:t>
-            </a:r>
-          </a:p>
-        </p:txBody>
-      </p:sp>
-      <p:pic>
-        <p:nvPicPr>
-          <p:cNvPr id="3" name="Picture 2" descr="paper_fig_persubject_scatter_tr.png"/>
-          <p:cNvPicPr>
-            <a:picLocks noChangeAspect="1"/>
-          </p:cNvPicPr>
+              <a:t>Step 1 — Single electrode + Stockwell time-frequency</a:t>
+            </a:r>
+          </a:p>
+        </p:txBody>
+      </p:sp>
+      <p:sp>
+        <p:nvSpPr>
+          <p:cNvPr id="3" name="TextBox 2"/>
+          <p:cNvSpPr txBox="1"/>
           <p:nvPr/>
-        </p:nvPicPr>
-        <p:blipFill>
-          <a:blip r:embed="rId2"/>
-          <a:stretch>
-            <a:fillRect/>
-          </a:stretch>
-        </p:blipFill>
-        <p:spPr>
-          <a:xfrm>
-            <a:off x="1280160" y="1554480"/>
-            <a:ext cx="9601200" cy="4907280"/>
+        </p:nvSpPr>
+        <p:spPr>
+          <a:xfrm>
+            <a:off x="548640" y="1463040"/>
+            <a:ext cx="11064240" cy="5029200"/>
           </a:xfrm>
           <a:prstGeom prst="rect">
             <a:avLst/>
           </a:prstGeom>
-        </p:spPr>
-      </p:pic>
+          <a:noFill/>
+        </p:spPr>
+        <p:txBody>
+          <a:bodyPr wrap="square">
+            <a:spAutoFit/>
+          </a:bodyPr>
+          <a:lstStyle/>
+          <a:p>
+            <a:pPr>
+              <a:spcAft>
+                <a:spcPts val="600"/>
+              </a:spcAft>
+            </a:pPr>
+            <a:r>
+              <a:rPr sz="1800" b="0"/>
+              <a:t>• EFP uses ONE electrode (data-driven), not a multivariate montage — a deliberately minimal, interpretable model.</a:t>
+            </a:r>
+          </a:p>
+          <a:p>
+            <a:pPr>
+              <a:spcAft>
+                <a:spcPts val="600"/>
+              </a:spcAft>
+            </a:pPr>
+            <a:r>
+              <a:rPr sz="1800" b="0"/>
+              <a:t>• Per electrode: Stockwell (S-)transform at 1 Hz resolution (FFT-based, implemented from scratch) → an instantaneous time-frequency power map.</a:t>
+            </a:r>
+          </a:p>
+          <a:p>
+            <a:pPr>
+              <a:spcAft>
+                <a:spcPts val="600"/>
+              </a:spcAft>
+            </a:pPr>
+            <a:r>
+              <a:rPr sz="1800" b="0">
+                <a:solidFill>
+                  <a:srgbClr val="555555"/>
+                </a:solidFill>
+              </a:rPr>
+              <a:t>• Contrast with our band-power decoder (eeg_bold_coupling): that used 31-channel Hilbert envelopes; EFP trades spatial breadth for temporal-spectral depth at one site.</a:t>
+            </a:r>
+          </a:p>
+        </p:txBody>
+      </p:sp>
     </p:spTree>
   </p:cSld>
   <p:clrMapOvr>
@@ -4121,7 +5133,7 @@
 </file>
 
 <file path=ppt/slides/slide5.xml><?xml version="1.0" encoding="utf-8"?>
-<p:sld xmlns:a="http://schemas.openxmlformats.org/drawingml/2006/main" xmlns:p="http://schemas.openxmlformats.org/presentationml/2006/main" xmlns:r="http://schemas.openxmlformats.org/officeDocument/2006/relationships">
+<p:sld xmlns:a="http://schemas.openxmlformats.org/drawingml/2006/main" xmlns:r="http://schemas.openxmlformats.org/officeDocument/2006/relationships" xmlns:p="http://schemas.openxmlformats.org/presentationml/2006/main">
   <p:cSld>
     <p:spTree>
       <p:nvGrpSpPr>
@@ -4129,7 +5141,14 @@
         <p:cNvGrpSpPr/>
         <p:nvPr/>
       </p:nvGrpSpPr>
-      <p:grpSpPr/>
+      <p:grpSpPr>
+        <a:xfrm>
+          <a:off x="0" y="0"/>
+          <a:ext cx="0" cy="0"/>
+          <a:chOff x="0" y="0"/>
+          <a:chExt cx="0" cy="0"/>
+        </a:xfrm>
+      </p:grpSpPr>
       <p:sp>
         <p:nvSpPr>
           <p:cNvPr id="2" name="TextBox 1"/>
@@ -4153,73 +5172,25 @@
           <a:lstStyle/>
           <a:p>
             <a:r>
-              <a:rPr sz="3000" b="1">
+              <a:rPr sz="2800" b="1">
                 <a:solidFill>
                   <a:srgbClr val="1F3A5F"/>
                 </a:solidFill>
               </a:rPr>
-              <a:t>Interpretable fingerprints — a learned HRF per frequency</a:t>
-            </a:r>
-          </a:p>
-        </p:txBody>
-      </p:sp>
-      <p:pic>
-        <p:nvPicPr>
-          <p:cNvPr id="3" name="Picture 2" descr="efp_group_fingerprint_PDA_tr.png"/>
-          <p:cNvPicPr>
-            <a:picLocks noChangeAspect="1"/>
-          </p:cNvPicPr>
-          <p:nvPr/>
-        </p:nvPicPr>
-        <p:blipFill>
-          <a:blip r:embed="rId2"/>
-          <a:stretch>
-            <a:fillRect/>
-          </a:stretch>
-        </p:blipFill>
-        <p:spPr>
-          <a:xfrm>
-            <a:off x="274320" y="1280160"/>
-            <a:ext cx="5852160" cy="3344091"/>
-          </a:xfrm>
-          <a:prstGeom prst="rect">
-            <a:avLst/>
-          </a:prstGeom>
-        </p:spPr>
-      </p:pic>
-      <p:pic>
-        <p:nvPicPr>
-          <p:cNvPr id="4" name="Picture 3" descr="efp_group_fingerprint_GSR_CEN_tr.png"/>
-          <p:cNvPicPr>
-            <a:picLocks noChangeAspect="1"/>
-          </p:cNvPicPr>
-          <p:nvPr/>
-        </p:nvPicPr>
-        <p:blipFill>
-          <a:blip r:embed="rId3"/>
-          <a:stretch>
-            <a:fillRect/>
-          </a:stretch>
-        </p:blipFill>
-        <p:spPr>
-          <a:xfrm>
-            <a:off x="6126480" y="1280160"/>
-            <a:ext cx="5852160" cy="3344091"/>
-          </a:xfrm>
-          <a:prstGeom prst="rect">
-            <a:avLst/>
-          </a:prstGeom>
-        </p:spPr>
-      </p:pic>
-      <p:sp>
-        <p:nvSpPr>
-          <p:cNvPr id="5" name="TextBox 4"/>
+              <a:t>Step 2 — Data-driven equal-energy frequency bands</a:t>
+            </a:r>
+          </a:p>
+        </p:txBody>
+      </p:sp>
+      <p:sp>
+        <p:nvSpPr>
+          <p:cNvPr id="3" name="TextBox 2"/>
           <p:cNvSpPr txBox="1"/>
           <p:nvPr/>
         </p:nvSpPr>
         <p:spPr>
           <a:xfrm>
-            <a:off x="548640" y="5120640"/>
+            <a:off x="548640" y="1463040"/>
             <a:ext cx="11064240" cy="5029200"/>
           </a:xfrm>
           <a:prstGeom prst="rect">
@@ -4239,8 +5210,34 @@
               </a:spcAft>
             </a:pPr>
             <a:r>
-              <a:rPr sz="1300" b="0"/>
-              <a:t>• Group-averaged [band × delay] EFP. Weights peak at ~−4 to −7 s delay — an HRF-plausible lag learned data-drivenly, differing across frequency bands.</a:t>
+              <a:rPr sz="1800" b="0"/>
+              <a:t>• Instead of fixed δ/θ/α/β/γ, the spectrum is split into 10 bands of equal cumulative log-power — each carries the same energy.</a:t>
+            </a:r>
+          </a:p>
+          <a:p>
+            <a:pPr>
+              <a:spcAft>
+                <a:spcPts val="600"/>
+              </a:spcAft>
+            </a:pPr>
+            <a:r>
+              <a:rPr sz="1800" b="0"/>
+              <a:t>• Bands are learned per subject/electrode from the data, then power is averaged within each band and standardized.</a:t>
+            </a:r>
+          </a:p>
+          <a:p>
+            <a:pPr>
+              <a:spcAft>
+                <a:spcPts val="600"/>
+              </a:spcAft>
+            </a:pPr>
+            <a:r>
+              <a:rPr sz="1800" b="1">
+                <a:solidFill>
+                  <a:srgbClr val="1F77B4"/>
+                </a:solidFill>
+              </a:rPr>
+              <a:t>• This adapts the frequency axis to each person's spectral profile — part of why it is a personalized 'fingerprint'.</a:t>
             </a:r>
           </a:p>
         </p:txBody>
@@ -4254,7 +5251,7 @@
 </file>
 
 <file path=ppt/slides/slide6.xml><?xml version="1.0" encoding="utf-8"?>
-<p:sld xmlns:a="http://schemas.openxmlformats.org/drawingml/2006/main" xmlns:p="http://schemas.openxmlformats.org/presentationml/2006/main" xmlns:r="http://schemas.openxmlformats.org/officeDocument/2006/relationships">
+<p:sld xmlns:a="http://schemas.openxmlformats.org/drawingml/2006/main" xmlns:r="http://schemas.openxmlformats.org/officeDocument/2006/relationships" xmlns:p="http://schemas.openxmlformats.org/presentationml/2006/main">
   <p:cSld>
     <p:spTree>
       <p:nvGrpSpPr>
@@ -4262,7 +5259,14 @@
         <p:cNvGrpSpPr/>
         <p:nvPr/>
       </p:nvGrpSpPr>
-      <p:grpSpPr/>
+      <p:grpSpPr>
+        <a:xfrm>
+          <a:off x="0" y="0"/>
+          <a:ext cx="0" cy="0"/>
+          <a:chOff x="0" y="0"/>
+          <a:chExt cx="0" cy="0"/>
+        </a:xfrm>
+      </p:grpSpPr>
       <p:sp>
         <p:nvSpPr>
           <p:cNvPr id="2" name="TextBox 1"/>
@@ -4286,49 +5290,25 @@
           <a:lstStyle/>
           <a:p>
             <a:r>
-              <a:rPr sz="3000" b="1">
+              <a:rPr sz="2800" b="1">
                 <a:solidFill>
                   <a:srgbClr val="1F3A5F"/>
                 </a:solidFill>
               </a:rPr>
-              <a:t>EFP vs our prior methods — a clear improvement</a:t>
-            </a:r>
-          </a:p>
-        </p:txBody>
-      </p:sp>
-      <p:pic>
-        <p:nvPicPr>
-          <p:cNvPr id="3" name="Picture 2" descr="fig_benchmark.png"/>
-          <p:cNvPicPr>
-            <a:picLocks noChangeAspect="1"/>
-          </p:cNvPicPr>
-          <p:nvPr/>
-        </p:nvPicPr>
-        <p:blipFill>
-          <a:blip r:embed="rId2"/>
-          <a:stretch>
-            <a:fillRect/>
-          </a:stretch>
-        </p:blipFill>
-        <p:spPr>
-          <a:xfrm>
-            <a:off x="1371600" y="1371600"/>
-            <a:ext cx="9418320" cy="4499864"/>
-          </a:xfrm>
-          <a:prstGeom prst="rect">
-            <a:avLst/>
-          </a:prstGeom>
-        </p:spPr>
-      </p:pic>
-      <p:sp>
-        <p:nvSpPr>
-          <p:cNvPr id="4" name="TextBox 3"/>
+              <a:t>Step 3 — [frequency × sliding-delay] design  (the KEY idea)</a:t>
+            </a:r>
+          </a:p>
+        </p:txBody>
+      </p:sp>
+      <p:sp>
+        <p:nvSpPr>
+          <p:cNvPr id="3" name="TextBox 2"/>
           <p:cNvSpPr txBox="1"/>
           <p:nvPr/>
         </p:nvSpPr>
         <p:spPr>
           <a:xfrm>
-            <a:off x="548640" y="5669280"/>
+            <a:off x="548640" y="1463040"/>
             <a:ext cx="11064240" cy="5029200"/>
           </a:xfrm>
           <a:prstGeom prst="rect">
@@ -4348,12 +5328,8 @@
               </a:spcAft>
             </a:pPr>
             <a:r>
-              <a:rPr sz="1300" b="1">
-                <a:solidFill>
-                  <a:srgbClr val="2E7D32"/>
-                </a:solidFill>
-              </a:rPr>
-              <a:t>• Within-subject EFP roughly doubles PDA decoding (r=0.26 vs DWT 0.11, HMM 0.10) and improves GSR_CEN (0.26 vs 0.17).</a:t>
+              <a:rPr sz="1800" b="0"/>
+              <a:t>• For each of the 10 bands, build lagged copies over a sliding delay window 0 … −12 s (11 delays at TR).</a:t>
             </a:r>
           </a:p>
           <a:p>
@@ -4363,8 +5339,38 @@
               </a:spcAft>
             </a:pPr>
             <a:r>
-              <a:rPr sz="1300" b="0"/>
-              <a:t>• Even cross-subject (LOSO) EFP transfers for PDA (r=0.13, p=0.01) — a general fingerprint.</a:t>
+              <a:rPr sz="1800" b="1">
+                <a:solidFill>
+                  <a:srgbClr val="1F3A5F"/>
+                </a:solidFill>
+              </a:rPr>
+              <a:t>• Ridge then learns a SEPARATE weight per (band × delay) — i.e. a separate temporal response for every frequency. No canonical HRF is assumed.</a:t>
+            </a:r>
+          </a:p>
+          <a:p>
+            <a:pPr>
+              <a:spcAft>
+                <a:spcPts val="600"/>
+              </a:spcAft>
+            </a:pPr>
+            <a:r>
+              <a:rPr sz="1800" b="0"/>
+              <a:t>• The learned weight matrix IS the fingerprint: an HRF-like lag profile that can differ across frequency bands (see Results).</a:t>
+            </a:r>
+          </a:p>
+          <a:p>
+            <a:pPr>
+              <a:spcAft>
+                <a:spcPts val="600"/>
+              </a:spcAft>
+            </a:pPr>
+            <a:r>
+              <a:rPr sz="1800" b="0">
+                <a:solidFill>
+                  <a:srgbClr val="555555"/>
+                </a:solidFill>
+              </a:rPr>
+              <a:t>• Design size ≈ 10 bands × 11 delays = 110 features from one electrode.</a:t>
             </a:r>
           </a:p>
         </p:txBody>
@@ -4378,7 +5384,7 @@
 </file>
 
 <file path=ppt/slides/slide7.xml><?xml version="1.0" encoding="utf-8"?>
-<p:sld xmlns:a="http://schemas.openxmlformats.org/drawingml/2006/main" xmlns:p="http://schemas.openxmlformats.org/presentationml/2006/main" xmlns:r="http://schemas.openxmlformats.org/officeDocument/2006/relationships">
+<p:sld xmlns:a="http://schemas.openxmlformats.org/drawingml/2006/main" xmlns:r="http://schemas.openxmlformats.org/officeDocument/2006/relationships" xmlns:p="http://schemas.openxmlformats.org/presentationml/2006/main">
   <p:cSld>
     <p:spTree>
       <p:nvGrpSpPr>
@@ -4386,7 +5392,14 @@
         <p:cNvGrpSpPr/>
         <p:nvPr/>
       </p:nvGrpSpPr>
-      <p:grpSpPr/>
+      <p:grpSpPr>
+        <a:xfrm>
+          <a:off x="0" y="0"/>
+          <a:ext cx="0" cy="0"/>
+          <a:chOff x="0" y="0"/>
+          <a:chExt cx="0" cy="0"/>
+        </a:xfrm>
+      </p:grpSpPr>
       <p:sp>
         <p:nvSpPr>
           <p:cNvPr id="2" name="TextBox 1"/>
@@ -4410,12 +5423,12 @@
           <a:lstStyle/>
           <a:p>
             <a:r>
-              <a:rPr sz="3000" b="1">
+              <a:rPr sz="2800" b="1">
                 <a:solidFill>
                   <a:srgbClr val="1F3A5F"/>
                 </a:solidFill>
               </a:rPr>
-              <a:t>Cross-subject generalization &amp; TR vs 4 Hz</a:t>
+              <a:t>Step 4 — fMRI targets &amp; global-signal regression</a:t>
             </a:r>
           </a:p>
         </p:txBody>
@@ -4428,8 +5441,8 @@
         </p:nvSpPr>
         <p:spPr>
           <a:xfrm>
-            <a:off x="548640" y="1371600"/>
-            <a:ext cx="11064240" cy="5029200"/>
+            <a:off x="548640" y="1463040"/>
+            <a:ext cx="11064240" cy="1908215"/>
           </a:xfrm>
           <a:prstGeom prst="rect">
             <a:avLst/>
@@ -4448,64 +5461,28 @@
               </a:spcAft>
             </a:pPr>
             <a:r>
-              <a:rPr sz="1600" b="1">
-                <a:solidFill>
-                  <a:srgbClr val="1F3A5F"/>
-                </a:solidFill>
-              </a:rPr>
-              <a:t>• LOSO general fingerprint (train N−1, predict held-out), TR resolution:</a:t>
-            </a:r>
-          </a:p>
-          <a:p>
-            <a:pPr lvl="1">
-              <a:spcAft>
-                <a:spcPts val="600"/>
-              </a:spcAft>
-            </a:pPr>
-            <a:r>
-              <a:rPr sz="1400" b="0">
-                <a:solidFill>
-                  <a:srgbClr val="2E7D32"/>
-                </a:solidFill>
-              </a:rPr>
-              <a:t>– PDA: r=+0.127 (p=0.010, ch Pz)</a:t>
-            </a:r>
-          </a:p>
-          <a:p>
-            <a:pPr lvl="1">
-              <a:spcAft>
-                <a:spcPts val="600"/>
-              </a:spcAft>
-            </a:pPr>
-            <a:r>
-              <a:rPr sz="1400" b="0"/>
-              <a:t>– CEN: r=+0.084 (p=0.001)</a:t>
-            </a:r>
-          </a:p>
-          <a:p>
-            <a:pPr lvl="1">
-              <a:spcAft>
-                <a:spcPts val="600"/>
-              </a:spcAft>
-            </a:pPr>
-            <a:r>
-              <a:rPr sz="1400" b="0"/>
-              <a:t>– DMN: r=+0.066 (p=0.002)</a:t>
-            </a:r>
-          </a:p>
-          <a:p>
-            <a:pPr lvl="1">
-              <a:spcAft>
-                <a:spcPts val="600"/>
-              </a:spcAft>
-            </a:pPr>
-            <a:r>
-              <a:rPr sz="1400" b="0">
-                <a:solidFill>
-                  <a:srgbClr val="B03A2E"/>
-                </a:solidFill>
-              </a:rPr>
-              <a:t>– GSR'd targets transfer weakly across subjects (p&gt;0.05) — GSR removes shared signal.</a:t>
+              <a:rPr sz="1800" b="0" dirty="0"/>
+              <a:t>• Seven targets (z-scored per run): CEN, DMN, PDA (</a:t>
+            </a:r>
+            <a:r>
+              <a:rPr sz="1800" b="0" dirty="0">
+                <a:highlight>
+                  <a:srgbClr val="FFFF00"/>
+                </a:highlight>
+              </a:rPr>
+              <a:t>DMN–CEN differential</a:t>
+            </a:r>
+            <a:r>
+              <a:rPr sz="1800" b="0" dirty="0"/>
+              <a:t>), plus a VIS positive-control ROI, each in RAW and </a:t>
+            </a:r>
+            <a:r>
+              <a:rPr sz="1800" b="0" dirty="0" err="1"/>
+              <a:t>GSR'd</a:t>
+            </a:r>
+            <a:r>
+              <a:rPr sz="1800" b="0" dirty="0"/>
+              <a:t> form.</a:t>
             </a:r>
           </a:p>
           <a:p>
@@ -4515,8 +5492,39 @@
               </a:spcAft>
             </a:pPr>
             <a:r>
-              <a:rPr sz="1600" b="0"/>
-              <a:t>• TR vs 4 Hz up-sampling: comparable within-subject accuracy — confirms the paper's finding that up-sampling adds temporal detail but not correlation.</a:t>
+              <a:rPr sz="1800" b="1" dirty="0">
+                <a:solidFill>
+                  <a:srgbClr val="1F77B4"/>
+                </a:solidFill>
+              </a:rPr>
+              <a:t>• RAW targets include global arousal (a sanity check — easy). </a:t>
+            </a:r>
+            <a:r>
+              <a:rPr sz="1800" b="1" dirty="0" err="1">
+                <a:solidFill>
+                  <a:srgbClr val="1F77B4"/>
+                </a:solidFill>
+              </a:rPr>
+              <a:t>GSR'd</a:t>
+            </a:r>
+            <a:r>
+              <a:rPr sz="1800" b="1" dirty="0">
+                <a:solidFill>
+                  <a:srgbClr val="1F77B4"/>
+                </a:solidFill>
+              </a:rPr>
+              <a:t> targets remove the shared signal → the stringent, network-specific test.</a:t>
+            </a:r>
+          </a:p>
+          <a:p>
+            <a:pPr>
+              <a:spcAft>
+                <a:spcPts val="600"/>
+              </a:spcAft>
+            </a:pPr>
+            <a:r>
+              <a:rPr sz="1800" b="0" dirty="0"/>
+              <a:t>• VIS = focal 6 mm calcarine sphere (MNI −1,−86,13 ≈ V1): a known EEG-visible ROI used to validate that the blind pipeline localizes correctly.</a:t>
             </a:r>
           </a:p>
         </p:txBody>
@@ -4530,7 +5538,7 @@
 </file>
 
 <file path=ppt/slides/slide8.xml><?xml version="1.0" encoding="utf-8"?>
-<p:sld xmlns:a="http://schemas.openxmlformats.org/drawingml/2006/main" xmlns:p="http://schemas.openxmlformats.org/presentationml/2006/main" xmlns:r="http://schemas.openxmlformats.org/officeDocument/2006/relationships">
+<p:sld xmlns:a="http://schemas.openxmlformats.org/drawingml/2006/main" xmlns:r="http://schemas.openxmlformats.org/officeDocument/2006/relationships" xmlns:p="http://schemas.openxmlformats.org/presentationml/2006/main">
   <p:cSld>
     <p:spTree>
       <p:nvGrpSpPr>
@@ -4538,7 +5546,14 @@
         <p:cNvGrpSpPr/>
         <p:nvPr/>
       </p:nvGrpSpPr>
-      <p:grpSpPr/>
+      <p:grpSpPr>
+        <a:xfrm>
+          <a:off x="0" y="0"/>
+          <a:ext cx="0" cy="0"/>
+          <a:chOff x="0" y="0"/>
+          <a:chExt cx="0" cy="0"/>
+        </a:xfrm>
+      </p:grpSpPr>
       <p:sp>
         <p:nvSpPr>
           <p:cNvPr id="2" name="TextBox 1"/>
@@ -4562,50 +5577,91 @@
           <a:lstStyle/>
           <a:p>
             <a:r>
-              <a:rPr sz="3000" b="1">
+              <a:rPr sz="2800" b="1">
                 <a:solidFill>
                   <a:srgbClr val="1F3A5F"/>
                 </a:solidFill>
               </a:rPr>
-              <a:t>Paper-style figures I — EFP fingerprints</a:t>
-            </a:r>
-          </a:p>
-          <a:p>
-            <a:r>
-              <a:rPr sz="1500">
-                <a:solidFill>
-                  <a:srgbClr val="555555"/>
-                </a:solidFill>
-              </a:rPr>
-              <a:t>Meir-Hasson Fig 5c/7c analog: [frequency × time-delay] per target</a:t>
-            </a:r>
-          </a:p>
-        </p:txBody>
-      </p:sp>
-      <p:pic>
-        <p:nvPicPr>
-          <p:cNvPr id="3" name="Picture 2" descr="paper_fig_fingerprints_tr.png"/>
-          <p:cNvPicPr>
-            <a:picLocks noChangeAspect="1"/>
-          </p:cNvPicPr>
+              <a:t>Step 5 — Nested cross-validation (the honest estimator)</a:t>
+            </a:r>
+          </a:p>
+        </p:txBody>
+      </p:sp>
+      <p:sp>
+        <p:nvSpPr>
+          <p:cNvPr id="3" name="TextBox 2"/>
+          <p:cNvSpPr txBox="1"/>
           <p:nvPr/>
-        </p:nvPicPr>
-        <p:blipFill>
-          <a:blip r:embed="rId2"/>
-          <a:stretch>
-            <a:fillRect/>
-          </a:stretch>
-        </p:blipFill>
-        <p:spPr>
-          <a:xfrm>
-            <a:off x="548640" y="1371600"/>
-            <a:ext cx="11064240" cy="6104408"/>
+        </p:nvSpPr>
+        <p:spPr>
+          <a:xfrm>
+            <a:off x="548640" y="1463040"/>
+            <a:ext cx="11064240" cy="5029200"/>
           </a:xfrm>
           <a:prstGeom prst="rect">
             <a:avLst/>
           </a:prstGeom>
-        </p:spPr>
-      </p:pic>
+          <a:noFill/>
+        </p:spPr>
+        <p:txBody>
+          <a:bodyPr wrap="square">
+            <a:spAutoFit/>
+          </a:bodyPr>
+          <a:lstStyle/>
+          <a:p>
+            <a:pPr>
+              <a:spcAft>
+                <a:spcPts val="600"/>
+              </a:spcAft>
+            </a:pPr>
+            <a:r>
+              <a:rPr sz="1800" b="0"/>
+              <a:t>• Outer contiguous block CV (k=5, m=2) preserves temporal autocorrelation; inner RidgeCV (GCV) picks λ over a 30-value log grid.</a:t>
+            </a:r>
+          </a:p>
+          <a:p>
+            <a:pPr>
+              <a:spcAft>
+                <a:spcPts val="600"/>
+              </a:spcAft>
+            </a:pPr>
+            <a:r>
+              <a:rPr sz="1800" b="1">
+                <a:solidFill>
+                  <a:srgbClr val="1F3A5F"/>
+                </a:solidFill>
+              </a:rPr>
+              <a:t>• Electrode selection is NESTED: the best electrode is chosen on the inner-training folds and scored ONLY on the held-out outer fold.</a:t>
+            </a:r>
+          </a:p>
+          <a:p>
+            <a:pPr>
+              <a:spcAft>
+                <a:spcPts val="600"/>
+              </a:spcAft>
+            </a:pPr>
+            <a:r>
+              <a:rPr sz="1800" b="0"/>
+              <a:t>• Reported r = concatenated out-of-fold Pearson correlation (oof_r) — matches Meir-Hasson's 'select on train, evaluate on test' and removes selection optimism.</a:t>
+            </a:r>
+          </a:p>
+          <a:p>
+            <a:pPr>
+              <a:spcAft>
+                <a:spcPts val="600"/>
+              </a:spcAft>
+            </a:pPr>
+            <a:r>
+              <a:rPr sz="1800" b="0">
+                <a:solidFill>
+                  <a:srgbClr val="2E7D32"/>
+                </a:solidFill>
+              </a:rPr>
+              <a:t>• Baselines (HRF, T/A) are nested over the SAME candidate electrodes → a fair comparison.</a:t>
+            </a:r>
+          </a:p>
+        </p:txBody>
+      </p:sp>
     </p:spTree>
   </p:cSld>
   <p:clrMapOvr>
@@ -4615,7 +5671,7 @@
 </file>
 
 <file path=ppt/slides/slide9.xml><?xml version="1.0" encoding="utf-8"?>
-<p:sld xmlns:a="http://schemas.openxmlformats.org/drawingml/2006/main" xmlns:p="http://schemas.openxmlformats.org/presentationml/2006/main" xmlns:r="http://schemas.openxmlformats.org/officeDocument/2006/relationships">
+<p:sld xmlns:a="http://schemas.openxmlformats.org/drawingml/2006/main" xmlns:r="http://schemas.openxmlformats.org/officeDocument/2006/relationships" xmlns:p="http://schemas.openxmlformats.org/presentationml/2006/main">
   <p:cSld>
     <p:spTree>
       <p:nvGrpSpPr>
@@ -4623,7 +5679,14 @@
         <p:cNvGrpSpPr/>
         <p:nvPr/>
       </p:nvGrpSpPr>
-      <p:grpSpPr/>
+      <p:grpSpPr>
+        <a:xfrm>
+          <a:off x="0" y="0"/>
+          <a:ext cx="0" cy="0"/>
+          <a:chOff x="0" y="0"/>
+          <a:chExt cx="0" cy="0"/>
+        </a:xfrm>
+      </p:grpSpPr>
       <p:sp>
         <p:nvSpPr>
           <p:cNvPr id="2" name="TextBox 1"/>
@@ -4647,122 +5710,87 @@
           <a:lstStyle/>
           <a:p>
             <a:r>
-              <a:rPr sz="3000" b="1">
+              <a:rPr sz="2800" b="1">
                 <a:solidFill>
                   <a:srgbClr val="1F3A5F"/>
                 </a:solidFill>
               </a:rPr>
-              <a:t>Paper-style figures II — predictor overlay &amp; electrode topography</a:t>
-            </a:r>
-          </a:p>
-          <a:p>
-            <a:r>
-              <a:rPr sz="1500">
-                <a:solidFill>
-                  <a:srgbClr val="555555"/>
-                </a:solidFill>
-              </a:rPr>
-              <a:t>Fig 3d (predictor vs fMRI) and Fig 3e/5b (per-electrode CV correlation r; red=better)</a:t>
-            </a:r>
-          </a:p>
-        </p:txBody>
-      </p:sp>
-      <p:pic>
-        <p:nvPicPr>
-          <p:cNvPr id="3" name="Picture 2" descr="paper_fig_predictor_PDA_tr.png"/>
-          <p:cNvPicPr>
-            <a:picLocks noChangeAspect="1"/>
-          </p:cNvPicPr>
+              <a:t>Step 6 — Baselines &amp; significance</a:t>
+            </a:r>
+          </a:p>
+        </p:txBody>
+      </p:sp>
+      <p:sp>
+        <p:nvSpPr>
+          <p:cNvPr id="3" name="TextBox 2"/>
+          <p:cNvSpPr txBox="1"/>
           <p:nvPr/>
-        </p:nvPicPr>
-        <p:blipFill>
-          <a:blip r:embed="rId2"/>
-          <a:stretch>
-            <a:fillRect/>
-          </a:stretch>
-        </p:blipFill>
-        <p:spPr>
-          <a:xfrm>
-            <a:off x="274320" y="1371600"/>
-            <a:ext cx="7406640" cy="2518258"/>
+        </p:nvSpPr>
+        <p:spPr>
+          <a:xfrm>
+            <a:off x="548640" y="1463040"/>
+            <a:ext cx="11064240" cy="5029200"/>
           </a:xfrm>
           <a:prstGeom prst="rect">
             <a:avLst/>
           </a:prstGeom>
-        </p:spPr>
-      </p:pic>
-      <p:pic>
-        <p:nvPicPr>
-          <p:cNvPr id="4" name="Picture 3" descr="paper_fig_r_topomap_PDA_tr.png"/>
-          <p:cNvPicPr>
-            <a:picLocks noChangeAspect="1"/>
-          </p:cNvPicPr>
-          <p:nvPr/>
-        </p:nvPicPr>
-        <p:blipFill>
-          <a:blip r:embed="rId3"/>
-          <a:stretch>
-            <a:fillRect/>
-          </a:stretch>
-        </p:blipFill>
-        <p:spPr>
-          <a:xfrm>
-            <a:off x="7955279" y="1280160"/>
-            <a:ext cx="2926080" cy="2813538"/>
-          </a:xfrm>
-          <a:prstGeom prst="rect">
-            <a:avLst/>
-          </a:prstGeom>
-        </p:spPr>
-      </p:pic>
-      <p:pic>
-        <p:nvPicPr>
-          <p:cNvPr id="5" name="Picture 4" descr="paper_fig_predictor_CEN_tr.png"/>
-          <p:cNvPicPr>
-            <a:picLocks noChangeAspect="1"/>
-          </p:cNvPicPr>
-          <p:nvPr/>
-        </p:nvPicPr>
-        <p:blipFill>
-          <a:blip r:embed="rId4"/>
-          <a:stretch>
-            <a:fillRect/>
-          </a:stretch>
-        </p:blipFill>
-        <p:spPr>
-          <a:xfrm>
-            <a:off x="274320" y="3931920"/>
-            <a:ext cx="7406640" cy="2518258"/>
-          </a:xfrm>
-          <a:prstGeom prst="rect">
-            <a:avLst/>
-          </a:prstGeom>
-        </p:spPr>
-      </p:pic>
-      <p:pic>
-        <p:nvPicPr>
-          <p:cNvPr id="6" name="Picture 5" descr="paper_fig_r_topomap_CEN_tr.png"/>
-          <p:cNvPicPr>
-            <a:picLocks noChangeAspect="1"/>
-          </p:cNvPicPr>
-          <p:nvPr/>
-        </p:nvPicPr>
-        <p:blipFill>
-          <a:blip r:embed="rId5"/>
-          <a:stretch>
-            <a:fillRect/>
-          </a:stretch>
-        </p:blipFill>
-        <p:spPr>
-          <a:xfrm>
-            <a:off x="7955279" y="3840480"/>
-            <a:ext cx="2926080" cy="2813538"/>
-          </a:xfrm>
-          <a:prstGeom prst="rect">
-            <a:avLst/>
-          </a:prstGeom>
-        </p:spPr>
-      </p:pic>
+          <a:noFill/>
+        </p:spPr>
+        <p:txBody>
+          <a:bodyPr wrap="square">
+            <a:spAutoFit/>
+          </a:bodyPr>
+          <a:lstStyle/>
+          <a:p>
+            <a:pPr>
+              <a:spcAft>
+                <a:spcPts val="600"/>
+              </a:spcAft>
+            </a:pPr>
+            <a:r>
+              <a:rPr sz="1800" b="0"/>
+              <a:t>• HRF baseline: same 10 bands convolved with a fixed canonical HRF (assumes one delay).</a:t>
+            </a:r>
+          </a:p>
+          <a:p>
+            <a:pPr>
+              <a:spcAft>
+                <a:spcPts val="600"/>
+              </a:spcAft>
+            </a:pPr>
+            <a:r>
+              <a:rPr sz="1800" b="0"/>
+              <a:t>• T/A baseline: traditional theta/alpha ratio, HRF-convolved (the classic EEG index).</a:t>
+            </a:r>
+          </a:p>
+          <a:p>
+            <a:pPr>
+              <a:spcAft>
+                <a:spcPts val="600"/>
+              </a:spcAft>
+            </a:pPr>
+            <a:r>
+              <a:rPr sz="1800" b="0"/>
+              <a:t>• Group significance: sign-flip permutation on the group-mean r (10k flips).</a:t>
+            </a:r>
+          </a:p>
+          <a:p>
+            <a:pPr>
+              <a:spcAft>
+                <a:spcPts val="600"/>
+              </a:spcAft>
+            </a:pPr>
+            <a:r>
+              <a:rPr sz="1800" b="1">
+                <a:solidFill>
+                  <a:srgbClr val="1F77B4"/>
+                </a:solidFill>
+              </a:rPr>
+              <a:t>• Electrode topography: per-electrode sign-flip p with Benjamini–Hochberg FDR — 'mark, don't mask' (significant electrodes dotted, map preserved).</a:t>
+            </a:r>
+          </a:p>
+        </p:txBody>
+      </p:sp>
     </p:spTree>
   </p:cSld>
   <p:clrMapOvr>
@@ -5089,4 +6117,10 @@
   </a:objectDefaults>
   <a:extraClrSchemeLst/>
 </a:theme>
+</file>
+
+<file path=docMetadata/LabelInfo.xml><?xml version="1.0" encoding="utf-8"?>
+<clbl:labelList xmlns:clbl="http://schemas.microsoft.com/office/2020/mipLabelMetadata">
+  <clbl:label id="{7893ce20-a697-4fd6-a4da-14011f6a471d}" enabled="1" method="Standard" siteId="{a8eec281-aaa3-4dae-ac9b-9a398b9215e7}" contentBits="0" removed="0"/>
+</clbl:labelList>
 </file>
</xml_diff>

<commit_message>
efp deck: fix PDA label (CEN - DMN, matching code; was reversed)
Co-Authored-By: Claude Opus 4.8 <noreply@anthropic.com>
</commit_message>
<xml_diff>
--- a/analysis/fingerprint/efp_meirhasson/efp_meirhasson_results.pptx
+++ b/analysis/fingerprint/efp_meirhasson/efp_meirhasson_results.pptx
@@ -5,28 +5,28 @@
     <p:sldMasterId id="2147483648" r:id="rId1"/>
   </p:sldMasterIdLst>
   <p:sldIdLst>
-    <p:sldId id="256" r:id="rId2"/>
-    <p:sldId id="257" r:id="rId3"/>
-    <p:sldId id="258" r:id="rId4"/>
-    <p:sldId id="259" r:id="rId5"/>
-    <p:sldId id="260" r:id="rId6"/>
-    <p:sldId id="261" r:id="rId7"/>
-    <p:sldId id="262" r:id="rId8"/>
-    <p:sldId id="263" r:id="rId9"/>
-    <p:sldId id="264" r:id="rId10"/>
-    <p:sldId id="265" r:id="rId11"/>
-    <p:sldId id="266" r:id="rId12"/>
-    <p:sldId id="267" r:id="rId13"/>
-    <p:sldId id="268" r:id="rId14"/>
-    <p:sldId id="269" r:id="rId15"/>
-    <p:sldId id="270" r:id="rId16"/>
-    <p:sldId id="271" r:id="rId17"/>
-    <p:sldId id="272" r:id="rId18"/>
-    <p:sldId id="273" r:id="rId19"/>
-    <p:sldId id="274" r:id="rId20"/>
-    <p:sldId id="275" r:id="rId21"/>
+    <p:sldId id="256" r:id="rId7"/>
+    <p:sldId id="257" r:id="rId8"/>
+    <p:sldId id="258" r:id="rId9"/>
+    <p:sldId id="259" r:id="rId10"/>
+    <p:sldId id="260" r:id="rId11"/>
+    <p:sldId id="261" r:id="rId12"/>
+    <p:sldId id="262" r:id="rId13"/>
+    <p:sldId id="263" r:id="rId14"/>
+    <p:sldId id="264" r:id="rId15"/>
+    <p:sldId id="265" r:id="rId16"/>
+    <p:sldId id="266" r:id="rId17"/>
+    <p:sldId id="267" r:id="rId18"/>
+    <p:sldId id="268" r:id="rId19"/>
+    <p:sldId id="269" r:id="rId20"/>
+    <p:sldId id="270" r:id="rId21"/>
+    <p:sldId id="271" r:id="rId22"/>
+    <p:sldId id="272" r:id="rId23"/>
+    <p:sldId id="273" r:id="rId24"/>
+    <p:sldId id="274" r:id="rId25"/>
+    <p:sldId id="275" r:id="rId26"/>
   </p:sldIdLst>
-  <p:sldSz cx="12192000" cy="6858000"/>
+  <p:sldSz cx="12191695" cy="6858000" type="screen4x3"/>
   <p:notesSz cx="6858000" cy="9144000"/>
   <p:defaultTextStyle>
     <a:defPPr>
@@ -123,22 +123,6 @@
       </a:defRPr>
     </a:lvl9pPr>
   </p:defaultTextStyle>
-  <p:extLst>
-    <p:ext uri="{EFAFB233-063F-42B5-8137-9DF3F51BA10A}">
-      <p15:sldGuideLst xmlns:p15="http://schemas.microsoft.com/office/powerpoint/2012/main">
-        <p15:guide id="1" orient="horz" pos="2160">
-          <p15:clr>
-            <a:srgbClr val="A4A3A4"/>
-          </p15:clr>
-        </p15:guide>
-        <p15:guide id="2" pos="2880">
-          <p15:clr>
-            <a:srgbClr val="A4A3A4"/>
-          </p15:clr>
-        </p15:guide>
-      </p15:sldGuideLst>
-    </p:ext>
-  </p:extLst>
 </p:presentation>
 </file>
 
@@ -180,9 +164,10 @@
           <a:lstStyle/>
           <a:p>
             <a:r>
-              <a:rPr lang="en-US"/>
+              <a:rPr lang="en-US" smtClean="0"/>
               <a:t>Click to edit Master title style</a:t>
             </a:r>
+            <a:endParaRPr lang="en-US"/>
           </a:p>
         </p:txBody>
       </p:sp>
@@ -298,9 +283,10 @@
           </a:lstStyle>
           <a:p>
             <a:r>
-              <a:rPr lang="en-US"/>
+              <a:rPr lang="en-US" smtClean="0"/>
               <a:t>Click to edit Master subtitle style</a:t>
             </a:r>
+            <a:endParaRPr lang="en-US"/>
           </a:p>
         </p:txBody>
       </p:sp>
@@ -321,7 +307,7 @@
           <a:p>
             <a:fld id="{5BCAD085-E8A6-8845-BD4E-CB4CCA059FC4}" type="datetimeFigureOut">
               <a:rPr lang="en-US" smtClean="0"/>
-              <a:t>7/8/26</a:t>
+              <a:t>1/27/13</a:t>
             </a:fld>
             <a:endParaRPr lang="en-US"/>
           </a:p>
@@ -415,9 +401,10 @@
           <a:lstStyle/>
           <a:p>
             <a:r>
-              <a:rPr lang="en-US"/>
+              <a:rPr lang="en-US" smtClean="0"/>
               <a:t>Click to edit Master title style</a:t>
             </a:r>
+            <a:endParaRPr lang="en-US"/>
           </a:p>
         </p:txBody>
       </p:sp>
@@ -438,37 +425,38 @@
           <a:p>
             <a:pPr lvl="0"/>
             <a:r>
-              <a:rPr lang="en-US"/>
+              <a:rPr lang="en-US" smtClean="0"/>
               <a:t>Click to edit Master text styles</a:t>
             </a:r>
           </a:p>
           <a:p>
             <a:pPr lvl="1"/>
             <a:r>
-              <a:rPr lang="en-US"/>
+              <a:rPr lang="en-US" smtClean="0"/>
               <a:t>Second level</a:t>
             </a:r>
           </a:p>
           <a:p>
             <a:pPr lvl="2"/>
             <a:r>
-              <a:rPr lang="en-US"/>
+              <a:rPr lang="en-US" smtClean="0"/>
               <a:t>Third level</a:t>
             </a:r>
           </a:p>
           <a:p>
             <a:pPr lvl="3"/>
             <a:r>
-              <a:rPr lang="en-US"/>
+              <a:rPr lang="en-US" smtClean="0"/>
               <a:t>Fourth level</a:t>
             </a:r>
           </a:p>
           <a:p>
             <a:pPr lvl="4"/>
             <a:r>
-              <a:rPr lang="en-US"/>
+              <a:rPr lang="en-US" smtClean="0"/>
               <a:t>Fifth level</a:t>
             </a:r>
+            <a:endParaRPr lang="en-US"/>
           </a:p>
         </p:txBody>
       </p:sp>
@@ -489,7 +477,7 @@
           <a:p>
             <a:fld id="{5BCAD085-E8A6-8845-BD4E-CB4CCA059FC4}" type="datetimeFigureOut">
               <a:rPr lang="en-US" smtClean="0"/>
-              <a:t>7/8/26</a:t>
+              <a:t>1/27/13</a:t>
             </a:fld>
             <a:endParaRPr lang="en-US"/>
           </a:p>
@@ -588,9 +576,10 @@
           <a:lstStyle/>
           <a:p>
             <a:r>
-              <a:rPr lang="en-US"/>
+              <a:rPr lang="en-US" smtClean="0"/>
               <a:t>Click to edit Master title style</a:t>
             </a:r>
+            <a:endParaRPr lang="en-US"/>
           </a:p>
         </p:txBody>
       </p:sp>
@@ -616,37 +605,38 @@
           <a:p>
             <a:pPr lvl="0"/>
             <a:r>
-              <a:rPr lang="en-US"/>
+              <a:rPr lang="en-US" smtClean="0"/>
               <a:t>Click to edit Master text styles</a:t>
             </a:r>
           </a:p>
           <a:p>
             <a:pPr lvl="1"/>
             <a:r>
-              <a:rPr lang="en-US"/>
+              <a:rPr lang="en-US" smtClean="0"/>
               <a:t>Second level</a:t>
             </a:r>
           </a:p>
           <a:p>
             <a:pPr lvl="2"/>
             <a:r>
-              <a:rPr lang="en-US"/>
+              <a:rPr lang="en-US" smtClean="0"/>
               <a:t>Third level</a:t>
             </a:r>
           </a:p>
           <a:p>
             <a:pPr lvl="3"/>
             <a:r>
-              <a:rPr lang="en-US"/>
+              <a:rPr lang="en-US" smtClean="0"/>
               <a:t>Fourth level</a:t>
             </a:r>
           </a:p>
           <a:p>
             <a:pPr lvl="4"/>
             <a:r>
-              <a:rPr lang="en-US"/>
+              <a:rPr lang="en-US" smtClean="0"/>
               <a:t>Fifth level</a:t>
             </a:r>
+            <a:endParaRPr lang="en-US"/>
           </a:p>
         </p:txBody>
       </p:sp>
@@ -667,7 +657,7 @@
           <a:p>
             <a:fld id="{5BCAD085-E8A6-8845-BD4E-CB4CCA059FC4}" type="datetimeFigureOut">
               <a:rPr lang="en-US" smtClean="0"/>
-              <a:t>7/8/26</a:t>
+              <a:t>1/27/13</a:t>
             </a:fld>
             <a:endParaRPr lang="en-US"/>
           </a:p>
@@ -761,9 +751,10 @@
           <a:lstStyle/>
           <a:p>
             <a:r>
-              <a:rPr lang="en-US"/>
+              <a:rPr lang="en-US" smtClean="0"/>
               <a:t>Click to edit Master title style</a:t>
             </a:r>
+            <a:endParaRPr lang="en-US"/>
           </a:p>
         </p:txBody>
       </p:sp>
@@ -784,37 +775,38 @@
           <a:p>
             <a:pPr lvl="0"/>
             <a:r>
-              <a:rPr lang="en-US"/>
+              <a:rPr lang="en-US" smtClean="0"/>
               <a:t>Click to edit Master text styles</a:t>
             </a:r>
           </a:p>
           <a:p>
             <a:pPr lvl="1"/>
             <a:r>
-              <a:rPr lang="en-US"/>
+              <a:rPr lang="en-US" smtClean="0"/>
               <a:t>Second level</a:t>
             </a:r>
           </a:p>
           <a:p>
             <a:pPr lvl="2"/>
             <a:r>
-              <a:rPr lang="en-US"/>
+              <a:rPr lang="en-US" smtClean="0"/>
               <a:t>Third level</a:t>
             </a:r>
           </a:p>
           <a:p>
             <a:pPr lvl="3"/>
             <a:r>
-              <a:rPr lang="en-US"/>
+              <a:rPr lang="en-US" smtClean="0"/>
               <a:t>Fourth level</a:t>
             </a:r>
           </a:p>
           <a:p>
             <a:pPr lvl="4"/>
             <a:r>
-              <a:rPr lang="en-US"/>
+              <a:rPr lang="en-US" smtClean="0"/>
               <a:t>Fifth level</a:t>
             </a:r>
+            <a:endParaRPr lang="en-US"/>
           </a:p>
         </p:txBody>
       </p:sp>
@@ -835,7 +827,7 @@
           <a:p>
             <a:fld id="{5BCAD085-E8A6-8845-BD4E-CB4CCA059FC4}" type="datetimeFigureOut">
               <a:rPr lang="en-US" smtClean="0"/>
-              <a:t>7/8/26</a:t>
+              <a:t>1/27/13</a:t>
             </a:fld>
             <a:endParaRPr lang="en-US"/>
           </a:p>
@@ -938,9 +930,10 @@
           </a:lstStyle>
           <a:p>
             <a:r>
-              <a:rPr lang="en-US"/>
+              <a:rPr lang="en-US" smtClean="0"/>
               <a:t>Click to edit Master title style</a:t>
             </a:r>
+            <a:endParaRPr lang="en-US"/>
           </a:p>
         </p:txBody>
       </p:sp>
@@ -1057,7 +1050,7 @@
           <a:p>
             <a:pPr lvl="0"/>
             <a:r>
-              <a:rPr lang="en-US"/>
+              <a:rPr lang="en-US" smtClean="0"/>
               <a:t>Click to edit Master text styles</a:t>
             </a:r>
           </a:p>
@@ -1080,7 +1073,7 @@
           <a:p>
             <a:fld id="{5BCAD085-E8A6-8845-BD4E-CB4CCA059FC4}" type="datetimeFigureOut">
               <a:rPr lang="en-US" smtClean="0"/>
-              <a:t>7/8/26</a:t>
+              <a:t>1/27/13</a:t>
             </a:fld>
             <a:endParaRPr lang="en-US"/>
           </a:p>
@@ -1174,9 +1167,10 @@
           <a:lstStyle/>
           <a:p>
             <a:r>
-              <a:rPr lang="en-US"/>
+              <a:rPr lang="en-US" smtClean="0"/>
               <a:t>Click to edit Master title style</a:t>
             </a:r>
+            <a:endParaRPr lang="en-US"/>
           </a:p>
         </p:txBody>
       </p:sp>
@@ -1230,37 +1224,38 @@
           <a:p>
             <a:pPr lvl="0"/>
             <a:r>
-              <a:rPr lang="en-US"/>
+              <a:rPr lang="en-US" smtClean="0"/>
               <a:t>Click to edit Master text styles</a:t>
             </a:r>
           </a:p>
           <a:p>
             <a:pPr lvl="1"/>
             <a:r>
-              <a:rPr lang="en-US"/>
+              <a:rPr lang="en-US" smtClean="0"/>
               <a:t>Second level</a:t>
             </a:r>
           </a:p>
           <a:p>
             <a:pPr lvl="2"/>
             <a:r>
-              <a:rPr lang="en-US"/>
+              <a:rPr lang="en-US" smtClean="0"/>
               <a:t>Third level</a:t>
             </a:r>
           </a:p>
           <a:p>
             <a:pPr lvl="3"/>
             <a:r>
-              <a:rPr lang="en-US"/>
+              <a:rPr lang="en-US" smtClean="0"/>
               <a:t>Fourth level</a:t>
             </a:r>
           </a:p>
           <a:p>
             <a:pPr lvl="4"/>
             <a:r>
-              <a:rPr lang="en-US"/>
+              <a:rPr lang="en-US" smtClean="0"/>
               <a:t>Fifth level</a:t>
             </a:r>
+            <a:endParaRPr lang="en-US"/>
           </a:p>
         </p:txBody>
       </p:sp>
@@ -1314,37 +1309,38 @@
           <a:p>
             <a:pPr lvl="0"/>
             <a:r>
-              <a:rPr lang="en-US"/>
+              <a:rPr lang="en-US" smtClean="0"/>
               <a:t>Click to edit Master text styles</a:t>
             </a:r>
           </a:p>
           <a:p>
             <a:pPr lvl="1"/>
             <a:r>
-              <a:rPr lang="en-US"/>
+              <a:rPr lang="en-US" smtClean="0"/>
               <a:t>Second level</a:t>
             </a:r>
           </a:p>
           <a:p>
             <a:pPr lvl="2"/>
             <a:r>
-              <a:rPr lang="en-US"/>
+              <a:rPr lang="en-US" smtClean="0"/>
               <a:t>Third level</a:t>
             </a:r>
           </a:p>
           <a:p>
             <a:pPr lvl="3"/>
             <a:r>
-              <a:rPr lang="en-US"/>
+              <a:rPr lang="en-US" smtClean="0"/>
               <a:t>Fourth level</a:t>
             </a:r>
           </a:p>
           <a:p>
             <a:pPr lvl="4"/>
             <a:r>
-              <a:rPr lang="en-US"/>
+              <a:rPr lang="en-US" smtClean="0"/>
               <a:t>Fifth level</a:t>
             </a:r>
+            <a:endParaRPr lang="en-US"/>
           </a:p>
         </p:txBody>
       </p:sp>
@@ -1365,7 +1361,7 @@
           <a:p>
             <a:fld id="{5BCAD085-E8A6-8845-BD4E-CB4CCA059FC4}" type="datetimeFigureOut">
               <a:rPr lang="en-US" smtClean="0"/>
-              <a:t>7/8/26</a:t>
+              <a:t>1/27/13</a:t>
             </a:fld>
             <a:endParaRPr lang="en-US"/>
           </a:p>
@@ -1463,9 +1459,10 @@
           </a:lstStyle>
           <a:p>
             <a:r>
-              <a:rPr lang="en-US"/>
+              <a:rPr lang="en-US" smtClean="0"/>
               <a:t>Click to edit Master title style</a:t>
             </a:r>
+            <a:endParaRPr lang="en-US"/>
           </a:p>
         </p:txBody>
       </p:sp>
@@ -1528,7 +1525,7 @@
           <a:p>
             <a:pPr lvl="0"/>
             <a:r>
-              <a:rPr lang="en-US"/>
+              <a:rPr lang="en-US" smtClean="0"/>
               <a:t>Click to edit Master text styles</a:t>
             </a:r>
           </a:p>
@@ -1584,37 +1581,38 @@
           <a:p>
             <a:pPr lvl="0"/>
             <a:r>
-              <a:rPr lang="en-US"/>
+              <a:rPr lang="en-US" smtClean="0"/>
               <a:t>Click to edit Master text styles</a:t>
             </a:r>
           </a:p>
           <a:p>
             <a:pPr lvl="1"/>
             <a:r>
-              <a:rPr lang="en-US"/>
+              <a:rPr lang="en-US" smtClean="0"/>
               <a:t>Second level</a:t>
             </a:r>
           </a:p>
           <a:p>
             <a:pPr lvl="2"/>
             <a:r>
-              <a:rPr lang="en-US"/>
+              <a:rPr lang="en-US" smtClean="0"/>
               <a:t>Third level</a:t>
             </a:r>
           </a:p>
           <a:p>
             <a:pPr lvl="3"/>
             <a:r>
-              <a:rPr lang="en-US"/>
+              <a:rPr lang="en-US" smtClean="0"/>
               <a:t>Fourth level</a:t>
             </a:r>
           </a:p>
           <a:p>
             <a:pPr lvl="4"/>
             <a:r>
-              <a:rPr lang="en-US"/>
+              <a:rPr lang="en-US" smtClean="0"/>
               <a:t>Fifth level</a:t>
             </a:r>
+            <a:endParaRPr lang="en-US"/>
           </a:p>
         </p:txBody>
       </p:sp>
@@ -1677,7 +1675,7 @@
           <a:p>
             <a:pPr lvl="0"/>
             <a:r>
-              <a:rPr lang="en-US"/>
+              <a:rPr lang="en-US" smtClean="0"/>
               <a:t>Click to edit Master text styles</a:t>
             </a:r>
           </a:p>
@@ -1733,37 +1731,38 @@
           <a:p>
             <a:pPr lvl="0"/>
             <a:r>
-              <a:rPr lang="en-US"/>
+              <a:rPr lang="en-US" smtClean="0"/>
               <a:t>Click to edit Master text styles</a:t>
             </a:r>
           </a:p>
           <a:p>
             <a:pPr lvl="1"/>
             <a:r>
-              <a:rPr lang="en-US"/>
+              <a:rPr lang="en-US" smtClean="0"/>
               <a:t>Second level</a:t>
             </a:r>
           </a:p>
           <a:p>
             <a:pPr lvl="2"/>
             <a:r>
-              <a:rPr lang="en-US"/>
+              <a:rPr lang="en-US" smtClean="0"/>
               <a:t>Third level</a:t>
             </a:r>
           </a:p>
           <a:p>
             <a:pPr lvl="3"/>
             <a:r>
-              <a:rPr lang="en-US"/>
+              <a:rPr lang="en-US" smtClean="0"/>
               <a:t>Fourth level</a:t>
             </a:r>
           </a:p>
           <a:p>
             <a:pPr lvl="4"/>
             <a:r>
-              <a:rPr lang="en-US"/>
+              <a:rPr lang="en-US" smtClean="0"/>
               <a:t>Fifth level</a:t>
             </a:r>
+            <a:endParaRPr lang="en-US"/>
           </a:p>
         </p:txBody>
       </p:sp>
@@ -1784,7 +1783,7 @@
           <a:p>
             <a:fld id="{5BCAD085-E8A6-8845-BD4E-CB4CCA059FC4}" type="datetimeFigureOut">
               <a:rPr lang="en-US" smtClean="0"/>
-              <a:t>7/8/26</a:t>
+              <a:t>1/27/13</a:t>
             </a:fld>
             <a:endParaRPr lang="en-US"/>
           </a:p>
@@ -1878,9 +1877,10 @@
           <a:lstStyle/>
           <a:p>
             <a:r>
-              <a:rPr lang="en-US"/>
+              <a:rPr lang="en-US" smtClean="0"/>
               <a:t>Click to edit Master title style</a:t>
             </a:r>
+            <a:endParaRPr lang="en-US"/>
           </a:p>
         </p:txBody>
       </p:sp>
@@ -1901,7 +1901,7 @@
           <a:p>
             <a:fld id="{5BCAD085-E8A6-8845-BD4E-CB4CCA059FC4}" type="datetimeFigureOut">
               <a:rPr lang="en-US" smtClean="0"/>
-              <a:t>7/8/26</a:t>
+              <a:t>1/27/13</a:t>
             </a:fld>
             <a:endParaRPr lang="en-US"/>
           </a:p>
@@ -1996,7 +1996,7 @@
           <a:p>
             <a:fld id="{5BCAD085-E8A6-8845-BD4E-CB4CCA059FC4}" type="datetimeFigureOut">
               <a:rPr lang="en-US" smtClean="0"/>
-              <a:t>7/8/26</a:t>
+              <a:t>1/27/13</a:t>
             </a:fld>
             <a:endParaRPr lang="en-US"/>
           </a:p>
@@ -2099,9 +2099,10 @@
           </a:lstStyle>
           <a:p>
             <a:r>
-              <a:rPr lang="en-US"/>
+              <a:rPr lang="en-US" smtClean="0"/>
               <a:t>Click to edit Master title style</a:t>
             </a:r>
+            <a:endParaRPr lang="en-US"/>
           </a:p>
         </p:txBody>
       </p:sp>
@@ -2155,37 +2156,38 @@
           <a:p>
             <a:pPr lvl="0"/>
             <a:r>
-              <a:rPr lang="en-US"/>
+              <a:rPr lang="en-US" smtClean="0"/>
               <a:t>Click to edit Master text styles</a:t>
             </a:r>
           </a:p>
           <a:p>
             <a:pPr lvl="1"/>
             <a:r>
-              <a:rPr lang="en-US"/>
+              <a:rPr lang="en-US" smtClean="0"/>
               <a:t>Second level</a:t>
             </a:r>
           </a:p>
           <a:p>
             <a:pPr lvl="2"/>
             <a:r>
-              <a:rPr lang="en-US"/>
+              <a:rPr lang="en-US" smtClean="0"/>
               <a:t>Third level</a:t>
             </a:r>
           </a:p>
           <a:p>
             <a:pPr lvl="3"/>
             <a:r>
-              <a:rPr lang="en-US"/>
+              <a:rPr lang="en-US" smtClean="0"/>
               <a:t>Fourth level</a:t>
             </a:r>
           </a:p>
           <a:p>
             <a:pPr lvl="4"/>
             <a:r>
-              <a:rPr lang="en-US"/>
+              <a:rPr lang="en-US" smtClean="0"/>
               <a:t>Fifth level</a:t>
             </a:r>
+            <a:endParaRPr lang="en-US"/>
           </a:p>
         </p:txBody>
       </p:sp>
@@ -2248,7 +2250,7 @@
           <a:p>
             <a:pPr lvl="0"/>
             <a:r>
-              <a:rPr lang="en-US"/>
+              <a:rPr lang="en-US" smtClean="0"/>
               <a:t>Click to edit Master text styles</a:t>
             </a:r>
           </a:p>
@@ -2271,7 +2273,7 @@
           <a:p>
             <a:fld id="{5BCAD085-E8A6-8845-BD4E-CB4CCA059FC4}" type="datetimeFigureOut">
               <a:rPr lang="en-US" smtClean="0"/>
-              <a:t>7/8/26</a:t>
+              <a:t>1/27/13</a:t>
             </a:fld>
             <a:endParaRPr lang="en-US"/>
           </a:p>
@@ -2374,9 +2376,10 @@
           </a:lstStyle>
           <a:p>
             <a:r>
-              <a:rPr lang="en-US"/>
+              <a:rPr lang="en-US" smtClean="0"/>
               <a:t>Click to edit Master title style</a:t>
             </a:r>
+            <a:endParaRPr lang="en-US"/>
           </a:p>
         </p:txBody>
       </p:sp>
@@ -2500,7 +2503,7 @@
           <a:p>
             <a:pPr lvl="0"/>
             <a:r>
-              <a:rPr lang="en-US"/>
+              <a:rPr lang="en-US" smtClean="0"/>
               <a:t>Click to edit Master text styles</a:t>
             </a:r>
           </a:p>
@@ -2523,7 +2526,7 @@
           <a:p>
             <a:fld id="{5BCAD085-E8A6-8845-BD4E-CB4CCA059FC4}" type="datetimeFigureOut">
               <a:rPr lang="en-US" smtClean="0"/>
-              <a:t>7/8/26</a:t>
+              <a:t>1/27/13</a:t>
             </a:fld>
             <a:endParaRPr lang="en-US"/>
           </a:p>
@@ -2632,9 +2635,10 @@
           <a:lstStyle/>
           <a:p>
             <a:r>
-              <a:rPr lang="en-US"/>
+              <a:rPr lang="en-US" smtClean="0"/>
               <a:t>Click to edit Master title style</a:t>
             </a:r>
+            <a:endParaRPr lang="en-US"/>
           </a:p>
         </p:txBody>
       </p:sp>
@@ -2665,37 +2669,38 @@
           <a:p>
             <a:pPr lvl="0"/>
             <a:r>
-              <a:rPr lang="en-US"/>
+              <a:rPr lang="en-US" smtClean="0"/>
               <a:t>Click to edit Master text styles</a:t>
             </a:r>
           </a:p>
           <a:p>
             <a:pPr lvl="1"/>
             <a:r>
-              <a:rPr lang="en-US"/>
+              <a:rPr lang="en-US" smtClean="0"/>
               <a:t>Second level</a:t>
             </a:r>
           </a:p>
           <a:p>
             <a:pPr lvl="2"/>
             <a:r>
-              <a:rPr lang="en-US"/>
+              <a:rPr lang="en-US" smtClean="0"/>
               <a:t>Third level</a:t>
             </a:r>
           </a:p>
           <a:p>
             <a:pPr lvl="3"/>
             <a:r>
-              <a:rPr lang="en-US"/>
+              <a:rPr lang="en-US" smtClean="0"/>
               <a:t>Fourth level</a:t>
             </a:r>
           </a:p>
           <a:p>
             <a:pPr lvl="4"/>
             <a:r>
-              <a:rPr lang="en-US"/>
+              <a:rPr lang="en-US" smtClean="0"/>
               <a:t>Fifth level</a:t>
             </a:r>
+            <a:endParaRPr lang="en-US"/>
           </a:p>
         </p:txBody>
       </p:sp>
@@ -2734,7 +2739,7 @@
           <a:p>
             <a:fld id="{5BCAD085-E8A6-8845-BD4E-CB4CCA059FC4}" type="datetimeFigureOut">
               <a:rPr lang="en-US" smtClean="0"/>
-              <a:t>7/8/26</a:t>
+              <a:t>1/27/13</a:t>
             </a:fld>
             <a:endParaRPr lang="en-US"/>
           </a:p>
@@ -3093,7 +3098,7 @@
 </file>
 
 <file path=ppt/slides/slide1.xml><?xml version="1.0" encoding="utf-8"?>
-<p:sld xmlns:a="http://schemas.openxmlformats.org/drawingml/2006/main" xmlns:r="http://schemas.openxmlformats.org/officeDocument/2006/relationships" xmlns:p="http://schemas.openxmlformats.org/presentationml/2006/main">
+<p:sld xmlns:a="http://schemas.openxmlformats.org/drawingml/2006/main" xmlns:p="http://schemas.openxmlformats.org/presentationml/2006/main" xmlns:r="http://schemas.openxmlformats.org/officeDocument/2006/relationships">
   <p:cSld>
     <p:spTree>
       <p:nvGrpSpPr>
@@ -3101,14 +3106,7 @@
         <p:cNvGrpSpPr/>
         <p:nvPr/>
       </p:nvGrpSpPr>
-      <p:grpSpPr>
-        <a:xfrm>
-          <a:off x="0" y="0"/>
-          <a:ext cx="0" cy="0"/>
-          <a:chOff x="0" y="0"/>
-          <a:chExt cx="0" cy="0"/>
-        </a:xfrm>
-      </p:grpSpPr>
+      <p:grpSpPr/>
       <p:sp>
         <p:nvSpPr>
           <p:cNvPr id="2" name="TextBox 1"/>
@@ -3181,7 +3179,7 @@
 </file>
 
 <file path=ppt/slides/slide10.xml><?xml version="1.0" encoding="utf-8"?>
-<p:sld xmlns:a="http://schemas.openxmlformats.org/drawingml/2006/main" xmlns:r="http://schemas.openxmlformats.org/officeDocument/2006/relationships" xmlns:p="http://schemas.openxmlformats.org/presentationml/2006/main">
+<p:sld xmlns:a="http://schemas.openxmlformats.org/drawingml/2006/main" xmlns:p="http://schemas.openxmlformats.org/presentationml/2006/main" xmlns:r="http://schemas.openxmlformats.org/officeDocument/2006/relationships">
   <p:cSld>
     <p:spTree>
       <p:nvGrpSpPr>
@@ -3189,14 +3187,7 @@
         <p:cNvGrpSpPr/>
         <p:nvPr/>
       </p:nvGrpSpPr>
-      <p:grpSpPr>
-        <a:xfrm>
-          <a:off x="0" y="0"/>
-          <a:ext cx="0" cy="0"/>
-          <a:chOff x="0" y="0"/>
-          <a:chExt cx="0" cy="0"/>
-        </a:xfrm>
-      </p:grpSpPr>
+      <p:grpSpPr/>
       <p:sp>
         <p:nvSpPr>
           <p:cNvPr id="2" name="TextBox 1"/>
@@ -3347,7 +3338,7 @@
 </file>
 
 <file path=ppt/slides/slide11.xml><?xml version="1.0" encoding="utf-8"?>
-<p:sld xmlns:a="http://schemas.openxmlformats.org/drawingml/2006/main" xmlns:r="http://schemas.openxmlformats.org/officeDocument/2006/relationships" xmlns:p="http://schemas.openxmlformats.org/presentationml/2006/main">
+<p:sld xmlns:a="http://schemas.openxmlformats.org/drawingml/2006/main" xmlns:p="http://schemas.openxmlformats.org/presentationml/2006/main" xmlns:r="http://schemas.openxmlformats.org/officeDocument/2006/relationships">
   <p:cSld>
     <p:spTree>
       <p:nvGrpSpPr>
@@ -3355,14 +3346,7 @@
         <p:cNvGrpSpPr/>
         <p:nvPr/>
       </p:nvGrpSpPr>
-      <p:grpSpPr>
-        <a:xfrm>
-          <a:off x="0" y="0"/>
-          <a:ext cx="0" cy="0"/>
-          <a:chOff x="0" y="0"/>
-          <a:chExt cx="0" cy="0"/>
-        </a:xfrm>
-      </p:grpSpPr>
+      <p:grpSpPr/>
       <p:sp>
         <p:nvSpPr>
           <p:cNvPr id="2" name="TextBox 1"/>
@@ -3478,7 +3462,7 @@
 </file>
 
 <file path=ppt/slides/slide12.xml><?xml version="1.0" encoding="utf-8"?>
-<p:sld xmlns:a="http://schemas.openxmlformats.org/drawingml/2006/main" xmlns:r="http://schemas.openxmlformats.org/officeDocument/2006/relationships" xmlns:p="http://schemas.openxmlformats.org/presentationml/2006/main">
+<p:sld xmlns:a="http://schemas.openxmlformats.org/drawingml/2006/main" xmlns:p="http://schemas.openxmlformats.org/presentationml/2006/main" xmlns:r="http://schemas.openxmlformats.org/officeDocument/2006/relationships">
   <p:cSld>
     <p:spTree>
       <p:nvGrpSpPr>
@@ -3486,14 +3470,7 @@
         <p:cNvGrpSpPr/>
         <p:nvPr/>
       </p:nvGrpSpPr>
-      <p:grpSpPr>
-        <a:xfrm>
-          <a:off x="0" y="0"/>
-          <a:ext cx="0" cy="0"/>
-          <a:chOff x="0" y="0"/>
-          <a:chExt cx="0" cy="0"/>
-        </a:xfrm>
-      </p:grpSpPr>
+      <p:grpSpPr/>
       <p:sp>
         <p:nvSpPr>
           <p:cNvPr id="2" name="TextBox 1"/>
@@ -3570,7 +3547,7 @@
 </file>
 
 <file path=ppt/slides/slide13.xml><?xml version="1.0" encoding="utf-8"?>
-<p:sld xmlns:a="http://schemas.openxmlformats.org/drawingml/2006/main" xmlns:r="http://schemas.openxmlformats.org/officeDocument/2006/relationships" xmlns:p="http://schemas.openxmlformats.org/presentationml/2006/main">
+<p:sld xmlns:a="http://schemas.openxmlformats.org/drawingml/2006/main" xmlns:p="http://schemas.openxmlformats.org/presentationml/2006/main" xmlns:r="http://schemas.openxmlformats.org/officeDocument/2006/relationships">
   <p:cSld>
     <p:spTree>
       <p:nvGrpSpPr>
@@ -3578,14 +3555,7 @@
         <p:cNvGrpSpPr/>
         <p:nvPr/>
       </p:nvGrpSpPr>
-      <p:grpSpPr>
-        <a:xfrm>
-          <a:off x="0" y="0"/>
-          <a:ext cx="0" cy="0"/>
-          <a:chOff x="0" y="0"/>
-          <a:chExt cx="0" cy="0"/>
-        </a:xfrm>
-      </p:grpSpPr>
+      <p:grpSpPr/>
       <p:sp>
         <p:nvSpPr>
           <p:cNvPr id="2" name="TextBox 1"/>
@@ -3701,7 +3671,7 @@
 </file>
 
 <file path=ppt/slides/slide14.xml><?xml version="1.0" encoding="utf-8"?>
-<p:sld xmlns:a="http://schemas.openxmlformats.org/drawingml/2006/main" xmlns:r="http://schemas.openxmlformats.org/officeDocument/2006/relationships" xmlns:p="http://schemas.openxmlformats.org/presentationml/2006/main">
+<p:sld xmlns:a="http://schemas.openxmlformats.org/drawingml/2006/main" xmlns:p="http://schemas.openxmlformats.org/presentationml/2006/main" xmlns:r="http://schemas.openxmlformats.org/officeDocument/2006/relationships">
   <p:cSld>
     <p:spTree>
       <p:nvGrpSpPr>
@@ -3709,14 +3679,7 @@
         <p:cNvGrpSpPr/>
         <p:nvPr/>
       </p:nvGrpSpPr>
-      <p:grpSpPr>
-        <a:xfrm>
-          <a:off x="0" y="0"/>
-          <a:ext cx="0" cy="0"/>
-          <a:chOff x="0" y="0"/>
-          <a:chExt cx="0" cy="0"/>
-        </a:xfrm>
-      </p:grpSpPr>
+      <p:grpSpPr/>
       <p:sp>
         <p:nvSpPr>
           <p:cNvPr id="2" name="TextBox 1"/>
@@ -3766,8 +3729,8 @@
         </p:blipFill>
         <p:spPr>
           <a:xfrm>
-            <a:off x="1598964" y="972610"/>
-            <a:ext cx="9448264" cy="5212835"/>
+            <a:off x="548640" y="1371600"/>
+            <a:ext cx="11064240" cy="6104408"/>
           </a:xfrm>
           <a:prstGeom prst="rect">
             <a:avLst/>
@@ -3783,7 +3746,7 @@
 </file>
 
 <file path=ppt/slides/slide15.xml><?xml version="1.0" encoding="utf-8"?>
-<p:sld xmlns:a="http://schemas.openxmlformats.org/drawingml/2006/main" xmlns:r="http://schemas.openxmlformats.org/officeDocument/2006/relationships" xmlns:p="http://schemas.openxmlformats.org/presentationml/2006/main">
+<p:sld xmlns:a="http://schemas.openxmlformats.org/drawingml/2006/main" xmlns:p="http://schemas.openxmlformats.org/presentationml/2006/main" xmlns:r="http://schemas.openxmlformats.org/officeDocument/2006/relationships">
   <p:cSld>
     <p:spTree>
       <p:nvGrpSpPr>
@@ -3791,14 +3754,7 @@
         <p:cNvGrpSpPr/>
         <p:nvPr/>
       </p:nvGrpSpPr>
-      <p:grpSpPr>
-        <a:xfrm>
-          <a:off x="0" y="0"/>
-          <a:ext cx="0" cy="0"/>
-          <a:chOff x="0" y="0"/>
-          <a:chExt cx="0" cy="0"/>
-        </a:xfrm>
-      </p:grpSpPr>
+      <p:grpSpPr/>
       <p:sp>
         <p:nvSpPr>
           <p:cNvPr id="2" name="TextBox 1"/>
@@ -3957,7 +3913,7 @@
 </file>
 
 <file path=ppt/slides/slide16.xml><?xml version="1.0" encoding="utf-8"?>
-<p:sld xmlns:a="http://schemas.openxmlformats.org/drawingml/2006/main" xmlns:r="http://schemas.openxmlformats.org/officeDocument/2006/relationships" xmlns:p="http://schemas.openxmlformats.org/presentationml/2006/main">
+<p:sld xmlns:a="http://schemas.openxmlformats.org/drawingml/2006/main" xmlns:p="http://schemas.openxmlformats.org/presentationml/2006/main" xmlns:r="http://schemas.openxmlformats.org/officeDocument/2006/relationships">
   <p:cSld>
     <p:spTree>
       <p:nvGrpSpPr>
@@ -3965,14 +3921,7 @@
         <p:cNvGrpSpPr/>
         <p:nvPr/>
       </p:nvGrpSpPr>
-      <p:grpSpPr>
-        <a:xfrm>
-          <a:off x="0" y="0"/>
-          <a:ext cx="0" cy="0"/>
-          <a:chOff x="0" y="0"/>
-          <a:chExt cx="0" cy="0"/>
-        </a:xfrm>
-      </p:grpSpPr>
+      <p:grpSpPr/>
       <p:sp>
         <p:nvSpPr>
           <p:cNvPr id="2" name="TextBox 1"/>
@@ -4124,7 +4073,7 @@
 </file>
 
 <file path=ppt/slides/slide17.xml><?xml version="1.0" encoding="utf-8"?>
-<p:sld xmlns:a="http://schemas.openxmlformats.org/drawingml/2006/main" xmlns:r="http://schemas.openxmlformats.org/officeDocument/2006/relationships" xmlns:p="http://schemas.openxmlformats.org/presentationml/2006/main">
+<p:sld xmlns:a="http://schemas.openxmlformats.org/drawingml/2006/main" xmlns:p="http://schemas.openxmlformats.org/presentationml/2006/main" xmlns:r="http://schemas.openxmlformats.org/officeDocument/2006/relationships">
   <p:cSld>
     <p:spTree>
       <p:nvGrpSpPr>
@@ -4132,14 +4081,7 @@
         <p:cNvGrpSpPr/>
         <p:nvPr/>
       </p:nvGrpSpPr>
-      <p:grpSpPr>
-        <a:xfrm>
-          <a:off x="0" y="0"/>
-          <a:ext cx="0" cy="0"/>
-          <a:chOff x="0" y="0"/>
-          <a:chExt cx="0" cy="0"/>
-        </a:xfrm>
-      </p:grpSpPr>
+      <p:grpSpPr/>
       <p:sp>
         <p:nvSpPr>
           <p:cNvPr id="2" name="TextBox 1"/>
@@ -4351,7 +4293,7 @@
 </file>
 
 <file path=ppt/slides/slide18.xml><?xml version="1.0" encoding="utf-8"?>
-<p:sld xmlns:a="http://schemas.openxmlformats.org/drawingml/2006/main" xmlns:r="http://schemas.openxmlformats.org/officeDocument/2006/relationships" xmlns:p="http://schemas.openxmlformats.org/presentationml/2006/main">
+<p:sld xmlns:a="http://schemas.openxmlformats.org/drawingml/2006/main" xmlns:p="http://schemas.openxmlformats.org/presentationml/2006/main" xmlns:r="http://schemas.openxmlformats.org/officeDocument/2006/relationships">
   <p:cSld>
     <p:spTree>
       <p:nvGrpSpPr>
@@ -4359,14 +4301,7 @@
         <p:cNvGrpSpPr/>
         <p:nvPr/>
       </p:nvGrpSpPr>
-      <p:grpSpPr>
-        <a:xfrm>
-          <a:off x="0" y="0"/>
-          <a:ext cx="0" cy="0"/>
-          <a:chOff x="0" y="0"/>
-          <a:chExt cx="0" cy="0"/>
-        </a:xfrm>
-      </p:grpSpPr>
+      <p:grpSpPr/>
       <p:sp>
         <p:nvSpPr>
           <p:cNvPr id="2" name="TextBox 1"/>
@@ -4426,8 +4361,8 @@
         </p:blipFill>
         <p:spPr>
           <a:xfrm>
-            <a:off x="810201" y="1396838"/>
-            <a:ext cx="6923922" cy="4923105"/>
+            <a:off x="274320" y="1463040"/>
+            <a:ext cx="8595360" cy="6111545"/>
           </a:xfrm>
           <a:prstGeom prst="rect">
             <a:avLst/>
@@ -4467,7 +4402,7 @@
 </file>
 
 <file path=ppt/slides/slide19.xml><?xml version="1.0" encoding="utf-8"?>
-<p:sld xmlns:a="http://schemas.openxmlformats.org/drawingml/2006/main" xmlns:r="http://schemas.openxmlformats.org/officeDocument/2006/relationships" xmlns:p="http://schemas.openxmlformats.org/presentationml/2006/main">
+<p:sld xmlns:a="http://schemas.openxmlformats.org/drawingml/2006/main" xmlns:p="http://schemas.openxmlformats.org/presentationml/2006/main" xmlns:r="http://schemas.openxmlformats.org/officeDocument/2006/relationships">
   <p:cSld>
     <p:spTree>
       <p:nvGrpSpPr>
@@ -4475,14 +4410,7 @@
         <p:cNvGrpSpPr/>
         <p:nvPr/>
       </p:nvGrpSpPr>
-      <p:grpSpPr>
-        <a:xfrm>
-          <a:off x="0" y="0"/>
-          <a:ext cx="0" cy="0"/>
-          <a:chOff x="0" y="0"/>
-          <a:chExt cx="0" cy="0"/>
-        </a:xfrm>
-      </p:grpSpPr>
+      <p:grpSpPr/>
       <p:sp>
         <p:nvSpPr>
           <p:cNvPr id="2" name="TextBox 1"/>
@@ -4645,7 +4573,7 @@
 </file>
 
 <file path=ppt/slides/slide2.xml><?xml version="1.0" encoding="utf-8"?>
-<p:sld xmlns:a="http://schemas.openxmlformats.org/drawingml/2006/main" xmlns:r="http://schemas.openxmlformats.org/officeDocument/2006/relationships" xmlns:p="http://schemas.openxmlformats.org/presentationml/2006/main">
+<p:sld xmlns:a="http://schemas.openxmlformats.org/drawingml/2006/main" xmlns:p="http://schemas.openxmlformats.org/presentationml/2006/main" xmlns:r="http://schemas.openxmlformats.org/officeDocument/2006/relationships">
   <p:cSld>
     <p:spTree>
       <p:nvGrpSpPr>
@@ -4653,14 +4581,7 @@
         <p:cNvGrpSpPr/>
         <p:nvPr/>
       </p:nvGrpSpPr>
-      <p:grpSpPr>
-        <a:xfrm>
-          <a:off x="0" y="0"/>
-          <a:ext cx="0" cy="0"/>
-          <a:chOff x="0" y="0"/>
-          <a:chExt cx="0" cy="0"/>
-        </a:xfrm>
-      </p:grpSpPr>
+      <p:grpSpPr/>
       <p:sp>
         <p:nvSpPr>
           <p:cNvPr id="2" name="TextBox 1"/>
@@ -4703,7 +4624,7 @@
         <p:spPr>
           <a:xfrm>
             <a:off x="548640" y="1463040"/>
-            <a:ext cx="11064240" cy="2262158"/>
+            <a:ext cx="11064240" cy="5029200"/>
           </a:xfrm>
           <a:prstGeom prst="rect">
             <a:avLst/>
@@ -4722,7 +4643,7 @@
               </a:spcAft>
             </a:pPr>
             <a:r>
-              <a:rPr sz="1800" b="0" dirty="0"/>
+              <a:rPr sz="1800" b="0"/>
               <a:t>• Decode fMRI network activity (DMN, CEN) and the PDA neurofeedback target from simultaneous scalp EEG.</a:t>
             </a:r>
           </a:p>
@@ -4733,7 +4654,7 @@
               </a:spcAft>
             </a:pPr>
             <a:r>
-              <a:rPr sz="1800" b="1" dirty="0">
+              <a:rPr sz="1800" b="1">
                 <a:solidFill>
                   <a:srgbClr val="1F77B4"/>
                 </a:solidFill>
@@ -4748,28 +4669,8 @@
               </a:spcAft>
             </a:pPr>
             <a:r>
-              <a:rPr sz="1800" b="0" dirty="0"/>
-              <a:t>• PDA = the actual DMNELF neurofeedback target (personalized </a:t>
-            </a:r>
-            <a:r>
-              <a:rPr sz="1800" b="0" dirty="0">
-                <a:highlight>
-                  <a:srgbClr val="FFFF00"/>
-                </a:highlight>
-              </a:rPr>
-              <a:t>DMN–CEN </a:t>
-            </a:r>
-            <a:r>
-              <a:rPr sz="1800" b="0" dirty="0"/>
-              <a:t>differential). </a:t>
-            </a:r>
-            <a:r>
-              <a:rPr sz="1800" b="0" dirty="0" err="1"/>
-              <a:t>GSR'd</a:t>
-            </a:r>
-            <a:r>
-              <a:rPr sz="1800" b="0" dirty="0"/>
-              <a:t> targets remove the shared global-arousal signal — the hard, network-specific test.</a:t>
+              <a:rPr sz="1800" b="0"/>
+              <a:t>• PDA = the actual DMNELF neurofeedback target (personalized CEN − DMN differential). GSR'd targets remove the shared global-arousal signal — the hard, network-specific test.</a:t>
             </a:r>
           </a:p>
           <a:p>
@@ -4779,7 +4680,7 @@
               </a:spcAft>
             </a:pPr>
             <a:r>
-              <a:rPr sz="1800" b="0" dirty="0"/>
+              <a:rPr sz="1800" b="0"/>
               <a:t>• Meir-Hasson's EFP is a single-electrode, HRF-free time-frequency fingerprint. We ask: does it replicate here, beat standard baselines, and generalize to new subjects &amp; a new cohort?</a:t>
             </a:r>
           </a:p>
@@ -4794,7 +4695,7 @@
 </file>
 
 <file path=ppt/slides/slide20.xml><?xml version="1.0" encoding="utf-8"?>
-<p:sld xmlns:a="http://schemas.openxmlformats.org/drawingml/2006/main" xmlns:r="http://schemas.openxmlformats.org/officeDocument/2006/relationships" xmlns:p="http://schemas.openxmlformats.org/presentationml/2006/main">
+<p:sld xmlns:a="http://schemas.openxmlformats.org/drawingml/2006/main" xmlns:p="http://schemas.openxmlformats.org/presentationml/2006/main" xmlns:r="http://schemas.openxmlformats.org/officeDocument/2006/relationships">
   <p:cSld>
     <p:spTree>
       <p:nvGrpSpPr>
@@ -4802,14 +4703,7 @@
         <p:cNvGrpSpPr/>
         <p:nvPr/>
       </p:nvGrpSpPr>
-      <p:grpSpPr>
-        <a:xfrm>
-          <a:off x="0" y="0"/>
-          <a:ext cx="0" cy="0"/>
-          <a:chOff x="0" y="0"/>
-          <a:chExt cx="0" cy="0"/>
-        </a:xfrm>
-      </p:grpSpPr>
+      <p:grpSpPr/>
       <p:sp>
         <p:nvSpPr>
           <p:cNvPr id="2" name="TextBox 1"/>
@@ -4923,7 +4817,7 @@
 </file>
 
 <file path=ppt/slides/slide3.xml><?xml version="1.0" encoding="utf-8"?>
-<p:sld xmlns:a="http://schemas.openxmlformats.org/drawingml/2006/main" xmlns:r="http://schemas.openxmlformats.org/officeDocument/2006/relationships" xmlns:p="http://schemas.openxmlformats.org/presentationml/2006/main">
+<p:sld xmlns:a="http://schemas.openxmlformats.org/drawingml/2006/main" xmlns:p="http://schemas.openxmlformats.org/presentationml/2006/main" xmlns:r="http://schemas.openxmlformats.org/officeDocument/2006/relationships">
   <p:cSld>
     <p:spTree>
       <p:nvGrpSpPr>
@@ -4931,14 +4825,7 @@
         <p:cNvGrpSpPr/>
         <p:nvPr/>
       </p:nvGrpSpPr>
-      <p:grpSpPr>
-        <a:xfrm>
-          <a:off x="0" y="0"/>
-          <a:ext cx="0" cy="0"/>
-          <a:chOff x="0" y="0"/>
-          <a:chExt cx="0" cy="0"/>
-        </a:xfrm>
-      </p:grpSpPr>
+      <p:grpSpPr/>
       <p:sp>
         <p:nvSpPr>
           <p:cNvPr id="2" name="TextBox 1"/>
@@ -4998,8 +4885,8 @@
         </p:blipFill>
         <p:spPr>
           <a:xfrm>
-            <a:off x="2275367" y="1188720"/>
-            <a:ext cx="7123813" cy="5353397"/>
+            <a:off x="457200" y="1463040"/>
+            <a:ext cx="11247120" cy="8451978"/>
           </a:xfrm>
           <a:prstGeom prst="rect">
             <a:avLst/>
@@ -5015,7 +4902,7 @@
 </file>
 
 <file path=ppt/slides/slide4.xml><?xml version="1.0" encoding="utf-8"?>
-<p:sld xmlns:a="http://schemas.openxmlformats.org/drawingml/2006/main" xmlns:r="http://schemas.openxmlformats.org/officeDocument/2006/relationships" xmlns:p="http://schemas.openxmlformats.org/presentationml/2006/main">
+<p:sld xmlns:a="http://schemas.openxmlformats.org/drawingml/2006/main" xmlns:p="http://schemas.openxmlformats.org/presentationml/2006/main" xmlns:r="http://schemas.openxmlformats.org/officeDocument/2006/relationships">
   <p:cSld>
     <p:spTree>
       <p:nvGrpSpPr>
@@ -5023,14 +4910,7 @@
         <p:cNvGrpSpPr/>
         <p:nvPr/>
       </p:nvGrpSpPr>
-      <p:grpSpPr>
-        <a:xfrm>
-          <a:off x="0" y="0"/>
-          <a:ext cx="0" cy="0"/>
-          <a:chOff x="0" y="0"/>
-          <a:chExt cx="0" cy="0"/>
-        </a:xfrm>
-      </p:grpSpPr>
+      <p:grpSpPr/>
       <p:sp>
         <p:nvSpPr>
           <p:cNvPr id="2" name="TextBox 1"/>
@@ -5133,7 +5013,7 @@
 </file>
 
 <file path=ppt/slides/slide5.xml><?xml version="1.0" encoding="utf-8"?>
-<p:sld xmlns:a="http://schemas.openxmlformats.org/drawingml/2006/main" xmlns:r="http://schemas.openxmlformats.org/officeDocument/2006/relationships" xmlns:p="http://schemas.openxmlformats.org/presentationml/2006/main">
+<p:sld xmlns:a="http://schemas.openxmlformats.org/drawingml/2006/main" xmlns:p="http://schemas.openxmlformats.org/presentationml/2006/main" xmlns:r="http://schemas.openxmlformats.org/officeDocument/2006/relationships">
   <p:cSld>
     <p:spTree>
       <p:nvGrpSpPr>
@@ -5141,14 +5021,7 @@
         <p:cNvGrpSpPr/>
         <p:nvPr/>
       </p:nvGrpSpPr>
-      <p:grpSpPr>
-        <a:xfrm>
-          <a:off x="0" y="0"/>
-          <a:ext cx="0" cy="0"/>
-          <a:chOff x="0" y="0"/>
-          <a:chExt cx="0" cy="0"/>
-        </a:xfrm>
-      </p:grpSpPr>
+      <p:grpSpPr/>
       <p:sp>
         <p:nvSpPr>
           <p:cNvPr id="2" name="TextBox 1"/>
@@ -5251,7 +5124,7 @@
 </file>
 
 <file path=ppt/slides/slide6.xml><?xml version="1.0" encoding="utf-8"?>
-<p:sld xmlns:a="http://schemas.openxmlformats.org/drawingml/2006/main" xmlns:r="http://schemas.openxmlformats.org/officeDocument/2006/relationships" xmlns:p="http://schemas.openxmlformats.org/presentationml/2006/main">
+<p:sld xmlns:a="http://schemas.openxmlformats.org/drawingml/2006/main" xmlns:p="http://schemas.openxmlformats.org/presentationml/2006/main" xmlns:r="http://schemas.openxmlformats.org/officeDocument/2006/relationships">
   <p:cSld>
     <p:spTree>
       <p:nvGrpSpPr>
@@ -5259,14 +5132,7 @@
         <p:cNvGrpSpPr/>
         <p:nvPr/>
       </p:nvGrpSpPr>
-      <p:grpSpPr>
-        <a:xfrm>
-          <a:off x="0" y="0"/>
-          <a:ext cx="0" cy="0"/>
-          <a:chOff x="0" y="0"/>
-          <a:chExt cx="0" cy="0"/>
-        </a:xfrm>
-      </p:grpSpPr>
+      <p:grpSpPr/>
       <p:sp>
         <p:nvSpPr>
           <p:cNvPr id="2" name="TextBox 1"/>
@@ -5384,7 +5250,7 @@
 </file>
 
 <file path=ppt/slides/slide7.xml><?xml version="1.0" encoding="utf-8"?>
-<p:sld xmlns:a="http://schemas.openxmlformats.org/drawingml/2006/main" xmlns:r="http://schemas.openxmlformats.org/officeDocument/2006/relationships" xmlns:p="http://schemas.openxmlformats.org/presentationml/2006/main">
+<p:sld xmlns:a="http://schemas.openxmlformats.org/drawingml/2006/main" xmlns:p="http://schemas.openxmlformats.org/presentationml/2006/main" xmlns:r="http://schemas.openxmlformats.org/officeDocument/2006/relationships">
   <p:cSld>
     <p:spTree>
       <p:nvGrpSpPr>
@@ -5392,14 +5258,7 @@
         <p:cNvGrpSpPr/>
         <p:nvPr/>
       </p:nvGrpSpPr>
-      <p:grpSpPr>
-        <a:xfrm>
-          <a:off x="0" y="0"/>
-          <a:ext cx="0" cy="0"/>
-          <a:chOff x="0" y="0"/>
-          <a:chExt cx="0" cy="0"/>
-        </a:xfrm>
-      </p:grpSpPr>
+      <p:grpSpPr/>
       <p:sp>
         <p:nvSpPr>
           <p:cNvPr id="2" name="TextBox 1"/>
@@ -5442,7 +5301,7 @@
         <p:spPr>
           <a:xfrm>
             <a:off x="548640" y="1463040"/>
-            <a:ext cx="11064240" cy="1908215"/>
+            <a:ext cx="11064240" cy="5029200"/>
           </a:xfrm>
           <a:prstGeom prst="rect">
             <a:avLst/>
@@ -5461,28 +5320,8 @@
               </a:spcAft>
             </a:pPr>
             <a:r>
-              <a:rPr sz="1800" b="0" dirty="0"/>
-              <a:t>• Seven targets (z-scored per run): CEN, DMN, PDA (</a:t>
-            </a:r>
-            <a:r>
-              <a:rPr sz="1800" b="0" dirty="0">
-                <a:highlight>
-                  <a:srgbClr val="FFFF00"/>
-                </a:highlight>
-              </a:rPr>
-              <a:t>DMN–CEN differential</a:t>
-            </a:r>
-            <a:r>
-              <a:rPr sz="1800" b="0" dirty="0"/>
-              <a:t>), plus a VIS positive-control ROI, each in RAW and </a:t>
-            </a:r>
-            <a:r>
-              <a:rPr sz="1800" b="0" dirty="0" err="1"/>
-              <a:t>GSR'd</a:t>
-            </a:r>
-            <a:r>
-              <a:rPr sz="1800" b="0" dirty="0"/>
-              <a:t> form.</a:t>
+              <a:rPr sz="1800" b="0"/>
+              <a:t>• Seven targets (z-scored per run): CEN, DMN, PDA (CEN − DMN differential), plus a VIS positive-control ROI, each in RAW and GSR'd form.</a:t>
             </a:r>
           </a:p>
           <a:p>
@@ -5492,28 +5331,12 @@
               </a:spcAft>
             </a:pPr>
             <a:r>
-              <a:rPr sz="1800" b="1" dirty="0">
+              <a:rPr sz="1800" b="1">
                 <a:solidFill>
                   <a:srgbClr val="1F77B4"/>
                 </a:solidFill>
               </a:rPr>
-              <a:t>• RAW targets include global arousal (a sanity check — easy). </a:t>
-            </a:r>
-            <a:r>
-              <a:rPr sz="1800" b="1" dirty="0" err="1">
-                <a:solidFill>
-                  <a:srgbClr val="1F77B4"/>
-                </a:solidFill>
-              </a:rPr>
-              <a:t>GSR'd</a:t>
-            </a:r>
-            <a:r>
-              <a:rPr sz="1800" b="1" dirty="0">
-                <a:solidFill>
-                  <a:srgbClr val="1F77B4"/>
-                </a:solidFill>
-              </a:rPr>
-              <a:t> targets remove the shared signal → the stringent, network-specific test.</a:t>
+              <a:t>• RAW targets include global arousal (a sanity check — easy). GSR'd targets remove the shared signal → the stringent, network-specific test.</a:t>
             </a:r>
           </a:p>
           <a:p>
@@ -5523,7 +5346,7 @@
               </a:spcAft>
             </a:pPr>
             <a:r>
-              <a:rPr sz="1800" b="0" dirty="0"/>
+              <a:rPr sz="1800" b="0"/>
               <a:t>• VIS = focal 6 mm calcarine sphere (MNI −1,−86,13 ≈ V1): a known EEG-visible ROI used to validate that the blind pipeline localizes correctly.</a:t>
             </a:r>
           </a:p>
@@ -5538,7 +5361,7 @@
 </file>
 
 <file path=ppt/slides/slide8.xml><?xml version="1.0" encoding="utf-8"?>
-<p:sld xmlns:a="http://schemas.openxmlformats.org/drawingml/2006/main" xmlns:r="http://schemas.openxmlformats.org/officeDocument/2006/relationships" xmlns:p="http://schemas.openxmlformats.org/presentationml/2006/main">
+<p:sld xmlns:a="http://schemas.openxmlformats.org/drawingml/2006/main" xmlns:p="http://schemas.openxmlformats.org/presentationml/2006/main" xmlns:r="http://schemas.openxmlformats.org/officeDocument/2006/relationships">
   <p:cSld>
     <p:spTree>
       <p:nvGrpSpPr>
@@ -5546,14 +5369,7 @@
         <p:cNvGrpSpPr/>
         <p:nvPr/>
       </p:nvGrpSpPr>
-      <p:grpSpPr>
-        <a:xfrm>
-          <a:off x="0" y="0"/>
-          <a:ext cx="0" cy="0"/>
-          <a:chOff x="0" y="0"/>
-          <a:chExt cx="0" cy="0"/>
-        </a:xfrm>
-      </p:grpSpPr>
+      <p:grpSpPr/>
       <p:sp>
         <p:nvSpPr>
           <p:cNvPr id="2" name="TextBox 1"/>
@@ -5671,7 +5487,7 @@
 </file>
 
 <file path=ppt/slides/slide9.xml><?xml version="1.0" encoding="utf-8"?>
-<p:sld xmlns:a="http://schemas.openxmlformats.org/drawingml/2006/main" xmlns:r="http://schemas.openxmlformats.org/officeDocument/2006/relationships" xmlns:p="http://schemas.openxmlformats.org/presentationml/2006/main">
+<p:sld xmlns:a="http://schemas.openxmlformats.org/drawingml/2006/main" xmlns:p="http://schemas.openxmlformats.org/presentationml/2006/main" xmlns:r="http://schemas.openxmlformats.org/officeDocument/2006/relationships">
   <p:cSld>
     <p:spTree>
       <p:nvGrpSpPr>
@@ -5679,14 +5495,7 @@
         <p:cNvGrpSpPr/>
         <p:nvPr/>
       </p:nvGrpSpPr>
-      <p:grpSpPr>
-        <a:xfrm>
-          <a:off x="0" y="0"/>
-          <a:ext cx="0" cy="0"/>
-          <a:chOff x="0" y="0"/>
-          <a:chExt cx="0" cy="0"/>
-        </a:xfrm>
-      </p:grpSpPr>
+      <p:grpSpPr/>
       <p:sp>
         <p:nvSpPr>
           <p:cNvPr id="2" name="TextBox 1"/>
@@ -6117,10 +5926,4 @@
   </a:objectDefaults>
   <a:extraClrSchemeLst/>
 </a:theme>
-</file>
-
-<file path=docMetadata/LabelInfo.xml><?xml version="1.0" encoding="utf-8"?>
-<clbl:labelList xmlns:clbl="http://schemas.microsoft.com/office/2020/mipLabelMetadata">
-  <clbl:label id="{7893ce20-a697-4fd6-a4da-14011f6a471d}" enabled="1" method="Standard" siteId="{a8eec281-aaa3-4dae-ac9b-9a398b9215e7}" contentBits="0" removed="0"/>
-</clbl:labelList>
 </file>
</xml_diff>

<commit_message>
efp calibration: commit result CSVs + rebuilt deck
Per-individual pseudo-target calibration results (LOSO + cross-cohort nf1/nf2,
full-montage and frontal single/multivariate), backing the frontal feasibility
section already in MANUSCRIPT.md (474436f). Key result: on the full montage the
general model is already best (calibration does not help); one pseudo-cal run
rescues the portable frontal-multivariate montage to near-full-montage accuracy
(PDA 0.113, GSR_CEN 0.122, GSR_PDA 0.107). Deck rebuilt with these results.

Co-Authored-By: Claude Opus 4.8 <noreply@anthropic.com>
</commit_message>
<xml_diff>
--- a/analysis/fingerprint/efp_meirhasson/efp_meirhasson_results.pptx
+++ b/analysis/fingerprint/efp_meirhasson/efp_meirhasson_results.pptx
@@ -5,28 +5,28 @@
     <p:sldMasterId id="2147483648" r:id="rId1"/>
   </p:sldMasterIdLst>
   <p:sldIdLst>
-    <p:sldId id="256" r:id="rId7"/>
-    <p:sldId id="257" r:id="rId8"/>
-    <p:sldId id="258" r:id="rId9"/>
-    <p:sldId id="259" r:id="rId10"/>
-    <p:sldId id="260" r:id="rId11"/>
-    <p:sldId id="261" r:id="rId12"/>
-    <p:sldId id="262" r:id="rId13"/>
-    <p:sldId id="263" r:id="rId14"/>
-    <p:sldId id="264" r:id="rId15"/>
-    <p:sldId id="265" r:id="rId16"/>
-    <p:sldId id="266" r:id="rId17"/>
-    <p:sldId id="267" r:id="rId18"/>
-    <p:sldId id="268" r:id="rId19"/>
-    <p:sldId id="269" r:id="rId20"/>
-    <p:sldId id="270" r:id="rId21"/>
-    <p:sldId id="271" r:id="rId22"/>
-    <p:sldId id="272" r:id="rId23"/>
-    <p:sldId id="273" r:id="rId24"/>
-    <p:sldId id="274" r:id="rId25"/>
-    <p:sldId id="275" r:id="rId26"/>
+    <p:sldId id="256" r:id="rId2"/>
+    <p:sldId id="257" r:id="rId3"/>
+    <p:sldId id="258" r:id="rId4"/>
+    <p:sldId id="259" r:id="rId5"/>
+    <p:sldId id="260" r:id="rId6"/>
+    <p:sldId id="261" r:id="rId7"/>
+    <p:sldId id="262" r:id="rId8"/>
+    <p:sldId id="263" r:id="rId9"/>
+    <p:sldId id="264" r:id="rId10"/>
+    <p:sldId id="265" r:id="rId11"/>
+    <p:sldId id="266" r:id="rId12"/>
+    <p:sldId id="267" r:id="rId13"/>
+    <p:sldId id="268" r:id="rId14"/>
+    <p:sldId id="269" r:id="rId15"/>
+    <p:sldId id="270" r:id="rId16"/>
+    <p:sldId id="271" r:id="rId17"/>
+    <p:sldId id="272" r:id="rId18"/>
+    <p:sldId id="273" r:id="rId19"/>
+    <p:sldId id="274" r:id="rId20"/>
+    <p:sldId id="275" r:id="rId21"/>
   </p:sldIdLst>
-  <p:sldSz cx="12191695" cy="6858000" type="screen4x3"/>
+  <p:sldSz cx="12192000" cy="6858000"/>
   <p:notesSz cx="6858000" cy="9144000"/>
   <p:defaultTextStyle>
     <a:defPPr>
@@ -123,6 +123,22 @@
       </a:defRPr>
     </a:lvl9pPr>
   </p:defaultTextStyle>
+  <p:extLst>
+    <p:ext uri="{EFAFB233-063F-42B5-8137-9DF3F51BA10A}">
+      <p15:sldGuideLst xmlns:p15="http://schemas.microsoft.com/office/powerpoint/2012/main">
+        <p15:guide id="1" orient="horz" pos="2160">
+          <p15:clr>
+            <a:srgbClr val="A4A3A4"/>
+          </p15:clr>
+        </p15:guide>
+        <p15:guide id="2" pos="2880">
+          <p15:clr>
+            <a:srgbClr val="A4A3A4"/>
+          </p15:clr>
+        </p15:guide>
+      </p15:sldGuideLst>
+    </p:ext>
+  </p:extLst>
 </p:presentation>
 </file>
 
@@ -164,10 +180,9 @@
           <a:lstStyle/>
           <a:p>
             <a:r>
-              <a:rPr lang="en-US" smtClean="0"/>
+              <a:rPr lang="en-US"/>
               <a:t>Click to edit Master title style</a:t>
             </a:r>
-            <a:endParaRPr lang="en-US"/>
           </a:p>
         </p:txBody>
       </p:sp>
@@ -283,10 +298,9 @@
           </a:lstStyle>
           <a:p>
             <a:r>
-              <a:rPr lang="en-US" smtClean="0"/>
+              <a:rPr lang="en-US"/>
               <a:t>Click to edit Master subtitle style</a:t>
             </a:r>
-            <a:endParaRPr lang="en-US"/>
           </a:p>
         </p:txBody>
       </p:sp>
@@ -307,7 +321,7 @@
           <a:p>
             <a:fld id="{5BCAD085-E8A6-8845-BD4E-CB4CCA059FC4}" type="datetimeFigureOut">
               <a:rPr lang="en-US" smtClean="0"/>
-              <a:t>1/27/13</a:t>
+              <a:t>7/8/26</a:t>
             </a:fld>
             <a:endParaRPr lang="en-US"/>
           </a:p>
@@ -401,10 +415,9 @@
           <a:lstStyle/>
           <a:p>
             <a:r>
-              <a:rPr lang="en-US" smtClean="0"/>
+              <a:rPr lang="en-US"/>
               <a:t>Click to edit Master title style</a:t>
             </a:r>
-            <a:endParaRPr lang="en-US"/>
           </a:p>
         </p:txBody>
       </p:sp>
@@ -425,38 +438,37 @@
           <a:p>
             <a:pPr lvl="0"/>
             <a:r>
-              <a:rPr lang="en-US" smtClean="0"/>
+              <a:rPr lang="en-US"/>
               <a:t>Click to edit Master text styles</a:t>
             </a:r>
           </a:p>
           <a:p>
             <a:pPr lvl="1"/>
             <a:r>
-              <a:rPr lang="en-US" smtClean="0"/>
+              <a:rPr lang="en-US"/>
               <a:t>Second level</a:t>
             </a:r>
           </a:p>
           <a:p>
             <a:pPr lvl="2"/>
             <a:r>
-              <a:rPr lang="en-US" smtClean="0"/>
+              <a:rPr lang="en-US"/>
               <a:t>Third level</a:t>
             </a:r>
           </a:p>
           <a:p>
             <a:pPr lvl="3"/>
             <a:r>
-              <a:rPr lang="en-US" smtClean="0"/>
+              <a:rPr lang="en-US"/>
               <a:t>Fourth level</a:t>
             </a:r>
           </a:p>
           <a:p>
             <a:pPr lvl="4"/>
             <a:r>
-              <a:rPr lang="en-US" smtClean="0"/>
+              <a:rPr lang="en-US"/>
               <a:t>Fifth level</a:t>
             </a:r>
-            <a:endParaRPr lang="en-US"/>
           </a:p>
         </p:txBody>
       </p:sp>
@@ -477,7 +489,7 @@
           <a:p>
             <a:fld id="{5BCAD085-E8A6-8845-BD4E-CB4CCA059FC4}" type="datetimeFigureOut">
               <a:rPr lang="en-US" smtClean="0"/>
-              <a:t>1/27/13</a:t>
+              <a:t>7/8/26</a:t>
             </a:fld>
             <a:endParaRPr lang="en-US"/>
           </a:p>
@@ -576,10 +588,9 @@
           <a:lstStyle/>
           <a:p>
             <a:r>
-              <a:rPr lang="en-US" smtClean="0"/>
+              <a:rPr lang="en-US"/>
               <a:t>Click to edit Master title style</a:t>
             </a:r>
-            <a:endParaRPr lang="en-US"/>
           </a:p>
         </p:txBody>
       </p:sp>
@@ -605,38 +616,37 @@
           <a:p>
             <a:pPr lvl="0"/>
             <a:r>
-              <a:rPr lang="en-US" smtClean="0"/>
+              <a:rPr lang="en-US"/>
               <a:t>Click to edit Master text styles</a:t>
             </a:r>
           </a:p>
           <a:p>
             <a:pPr lvl="1"/>
             <a:r>
-              <a:rPr lang="en-US" smtClean="0"/>
+              <a:rPr lang="en-US"/>
               <a:t>Second level</a:t>
             </a:r>
           </a:p>
           <a:p>
             <a:pPr lvl="2"/>
             <a:r>
-              <a:rPr lang="en-US" smtClean="0"/>
+              <a:rPr lang="en-US"/>
               <a:t>Third level</a:t>
             </a:r>
           </a:p>
           <a:p>
             <a:pPr lvl="3"/>
             <a:r>
-              <a:rPr lang="en-US" smtClean="0"/>
+              <a:rPr lang="en-US"/>
               <a:t>Fourth level</a:t>
             </a:r>
           </a:p>
           <a:p>
             <a:pPr lvl="4"/>
             <a:r>
-              <a:rPr lang="en-US" smtClean="0"/>
+              <a:rPr lang="en-US"/>
               <a:t>Fifth level</a:t>
             </a:r>
-            <a:endParaRPr lang="en-US"/>
           </a:p>
         </p:txBody>
       </p:sp>
@@ -657,7 +667,7 @@
           <a:p>
             <a:fld id="{5BCAD085-E8A6-8845-BD4E-CB4CCA059FC4}" type="datetimeFigureOut">
               <a:rPr lang="en-US" smtClean="0"/>
-              <a:t>1/27/13</a:t>
+              <a:t>7/8/26</a:t>
             </a:fld>
             <a:endParaRPr lang="en-US"/>
           </a:p>
@@ -751,10 +761,9 @@
           <a:lstStyle/>
           <a:p>
             <a:r>
-              <a:rPr lang="en-US" smtClean="0"/>
+              <a:rPr lang="en-US"/>
               <a:t>Click to edit Master title style</a:t>
             </a:r>
-            <a:endParaRPr lang="en-US"/>
           </a:p>
         </p:txBody>
       </p:sp>
@@ -775,38 +784,37 @@
           <a:p>
             <a:pPr lvl="0"/>
             <a:r>
-              <a:rPr lang="en-US" smtClean="0"/>
+              <a:rPr lang="en-US"/>
               <a:t>Click to edit Master text styles</a:t>
             </a:r>
           </a:p>
           <a:p>
             <a:pPr lvl="1"/>
             <a:r>
-              <a:rPr lang="en-US" smtClean="0"/>
+              <a:rPr lang="en-US"/>
               <a:t>Second level</a:t>
             </a:r>
           </a:p>
           <a:p>
             <a:pPr lvl="2"/>
             <a:r>
-              <a:rPr lang="en-US" smtClean="0"/>
+              <a:rPr lang="en-US"/>
               <a:t>Third level</a:t>
             </a:r>
           </a:p>
           <a:p>
             <a:pPr lvl="3"/>
             <a:r>
-              <a:rPr lang="en-US" smtClean="0"/>
+              <a:rPr lang="en-US"/>
               <a:t>Fourth level</a:t>
             </a:r>
           </a:p>
           <a:p>
             <a:pPr lvl="4"/>
             <a:r>
-              <a:rPr lang="en-US" smtClean="0"/>
+              <a:rPr lang="en-US"/>
               <a:t>Fifth level</a:t>
             </a:r>
-            <a:endParaRPr lang="en-US"/>
           </a:p>
         </p:txBody>
       </p:sp>
@@ -827,7 +835,7 @@
           <a:p>
             <a:fld id="{5BCAD085-E8A6-8845-BD4E-CB4CCA059FC4}" type="datetimeFigureOut">
               <a:rPr lang="en-US" smtClean="0"/>
-              <a:t>1/27/13</a:t>
+              <a:t>7/8/26</a:t>
             </a:fld>
             <a:endParaRPr lang="en-US"/>
           </a:p>
@@ -930,10 +938,9 @@
           </a:lstStyle>
           <a:p>
             <a:r>
-              <a:rPr lang="en-US" smtClean="0"/>
+              <a:rPr lang="en-US"/>
               <a:t>Click to edit Master title style</a:t>
             </a:r>
-            <a:endParaRPr lang="en-US"/>
           </a:p>
         </p:txBody>
       </p:sp>
@@ -1050,7 +1057,7 @@
           <a:p>
             <a:pPr lvl="0"/>
             <a:r>
-              <a:rPr lang="en-US" smtClean="0"/>
+              <a:rPr lang="en-US"/>
               <a:t>Click to edit Master text styles</a:t>
             </a:r>
           </a:p>
@@ -1073,7 +1080,7 @@
           <a:p>
             <a:fld id="{5BCAD085-E8A6-8845-BD4E-CB4CCA059FC4}" type="datetimeFigureOut">
               <a:rPr lang="en-US" smtClean="0"/>
-              <a:t>1/27/13</a:t>
+              <a:t>7/8/26</a:t>
             </a:fld>
             <a:endParaRPr lang="en-US"/>
           </a:p>
@@ -1167,10 +1174,9 @@
           <a:lstStyle/>
           <a:p>
             <a:r>
-              <a:rPr lang="en-US" smtClean="0"/>
+              <a:rPr lang="en-US"/>
               <a:t>Click to edit Master title style</a:t>
             </a:r>
-            <a:endParaRPr lang="en-US"/>
           </a:p>
         </p:txBody>
       </p:sp>
@@ -1224,38 +1230,37 @@
           <a:p>
             <a:pPr lvl="0"/>
             <a:r>
-              <a:rPr lang="en-US" smtClean="0"/>
+              <a:rPr lang="en-US"/>
               <a:t>Click to edit Master text styles</a:t>
             </a:r>
           </a:p>
           <a:p>
             <a:pPr lvl="1"/>
             <a:r>
-              <a:rPr lang="en-US" smtClean="0"/>
+              <a:rPr lang="en-US"/>
               <a:t>Second level</a:t>
             </a:r>
           </a:p>
           <a:p>
             <a:pPr lvl="2"/>
             <a:r>
-              <a:rPr lang="en-US" smtClean="0"/>
+              <a:rPr lang="en-US"/>
               <a:t>Third level</a:t>
             </a:r>
           </a:p>
           <a:p>
             <a:pPr lvl="3"/>
             <a:r>
-              <a:rPr lang="en-US" smtClean="0"/>
+              <a:rPr lang="en-US"/>
               <a:t>Fourth level</a:t>
             </a:r>
           </a:p>
           <a:p>
             <a:pPr lvl="4"/>
             <a:r>
-              <a:rPr lang="en-US" smtClean="0"/>
+              <a:rPr lang="en-US"/>
               <a:t>Fifth level</a:t>
             </a:r>
-            <a:endParaRPr lang="en-US"/>
           </a:p>
         </p:txBody>
       </p:sp>
@@ -1309,38 +1314,37 @@
           <a:p>
             <a:pPr lvl="0"/>
             <a:r>
-              <a:rPr lang="en-US" smtClean="0"/>
+              <a:rPr lang="en-US"/>
               <a:t>Click to edit Master text styles</a:t>
             </a:r>
           </a:p>
           <a:p>
             <a:pPr lvl="1"/>
             <a:r>
-              <a:rPr lang="en-US" smtClean="0"/>
+              <a:rPr lang="en-US"/>
               <a:t>Second level</a:t>
             </a:r>
           </a:p>
           <a:p>
             <a:pPr lvl="2"/>
             <a:r>
-              <a:rPr lang="en-US" smtClean="0"/>
+              <a:rPr lang="en-US"/>
               <a:t>Third level</a:t>
             </a:r>
           </a:p>
           <a:p>
             <a:pPr lvl="3"/>
             <a:r>
-              <a:rPr lang="en-US" smtClean="0"/>
+              <a:rPr lang="en-US"/>
               <a:t>Fourth level</a:t>
             </a:r>
           </a:p>
           <a:p>
             <a:pPr lvl="4"/>
             <a:r>
-              <a:rPr lang="en-US" smtClean="0"/>
+              <a:rPr lang="en-US"/>
               <a:t>Fifth level</a:t>
             </a:r>
-            <a:endParaRPr lang="en-US"/>
           </a:p>
         </p:txBody>
       </p:sp>
@@ -1361,7 +1365,7 @@
           <a:p>
             <a:fld id="{5BCAD085-E8A6-8845-BD4E-CB4CCA059FC4}" type="datetimeFigureOut">
               <a:rPr lang="en-US" smtClean="0"/>
-              <a:t>1/27/13</a:t>
+              <a:t>7/8/26</a:t>
             </a:fld>
             <a:endParaRPr lang="en-US"/>
           </a:p>
@@ -1459,10 +1463,9 @@
           </a:lstStyle>
           <a:p>
             <a:r>
-              <a:rPr lang="en-US" smtClean="0"/>
+              <a:rPr lang="en-US"/>
               <a:t>Click to edit Master title style</a:t>
             </a:r>
-            <a:endParaRPr lang="en-US"/>
           </a:p>
         </p:txBody>
       </p:sp>
@@ -1525,7 +1528,7 @@
           <a:p>
             <a:pPr lvl="0"/>
             <a:r>
-              <a:rPr lang="en-US" smtClean="0"/>
+              <a:rPr lang="en-US"/>
               <a:t>Click to edit Master text styles</a:t>
             </a:r>
           </a:p>
@@ -1581,38 +1584,37 @@
           <a:p>
             <a:pPr lvl="0"/>
             <a:r>
-              <a:rPr lang="en-US" smtClean="0"/>
+              <a:rPr lang="en-US"/>
               <a:t>Click to edit Master text styles</a:t>
             </a:r>
           </a:p>
           <a:p>
             <a:pPr lvl="1"/>
             <a:r>
-              <a:rPr lang="en-US" smtClean="0"/>
+              <a:rPr lang="en-US"/>
               <a:t>Second level</a:t>
             </a:r>
           </a:p>
           <a:p>
             <a:pPr lvl="2"/>
             <a:r>
-              <a:rPr lang="en-US" smtClean="0"/>
+              <a:rPr lang="en-US"/>
               <a:t>Third level</a:t>
             </a:r>
           </a:p>
           <a:p>
             <a:pPr lvl="3"/>
             <a:r>
-              <a:rPr lang="en-US" smtClean="0"/>
+              <a:rPr lang="en-US"/>
               <a:t>Fourth level</a:t>
             </a:r>
           </a:p>
           <a:p>
             <a:pPr lvl="4"/>
             <a:r>
-              <a:rPr lang="en-US" smtClean="0"/>
+              <a:rPr lang="en-US"/>
               <a:t>Fifth level</a:t>
             </a:r>
-            <a:endParaRPr lang="en-US"/>
           </a:p>
         </p:txBody>
       </p:sp>
@@ -1675,7 +1677,7 @@
           <a:p>
             <a:pPr lvl="0"/>
             <a:r>
-              <a:rPr lang="en-US" smtClean="0"/>
+              <a:rPr lang="en-US"/>
               <a:t>Click to edit Master text styles</a:t>
             </a:r>
           </a:p>
@@ -1731,38 +1733,37 @@
           <a:p>
             <a:pPr lvl="0"/>
             <a:r>
-              <a:rPr lang="en-US" smtClean="0"/>
+              <a:rPr lang="en-US"/>
               <a:t>Click to edit Master text styles</a:t>
             </a:r>
           </a:p>
           <a:p>
             <a:pPr lvl="1"/>
             <a:r>
-              <a:rPr lang="en-US" smtClean="0"/>
+              <a:rPr lang="en-US"/>
               <a:t>Second level</a:t>
             </a:r>
           </a:p>
           <a:p>
             <a:pPr lvl="2"/>
             <a:r>
-              <a:rPr lang="en-US" smtClean="0"/>
+              <a:rPr lang="en-US"/>
               <a:t>Third level</a:t>
             </a:r>
           </a:p>
           <a:p>
             <a:pPr lvl="3"/>
             <a:r>
-              <a:rPr lang="en-US" smtClean="0"/>
+              <a:rPr lang="en-US"/>
               <a:t>Fourth level</a:t>
             </a:r>
           </a:p>
           <a:p>
             <a:pPr lvl="4"/>
             <a:r>
-              <a:rPr lang="en-US" smtClean="0"/>
+              <a:rPr lang="en-US"/>
               <a:t>Fifth level</a:t>
             </a:r>
-            <a:endParaRPr lang="en-US"/>
           </a:p>
         </p:txBody>
       </p:sp>
@@ -1783,7 +1784,7 @@
           <a:p>
             <a:fld id="{5BCAD085-E8A6-8845-BD4E-CB4CCA059FC4}" type="datetimeFigureOut">
               <a:rPr lang="en-US" smtClean="0"/>
-              <a:t>1/27/13</a:t>
+              <a:t>7/8/26</a:t>
             </a:fld>
             <a:endParaRPr lang="en-US"/>
           </a:p>
@@ -1877,10 +1878,9 @@
           <a:lstStyle/>
           <a:p>
             <a:r>
-              <a:rPr lang="en-US" smtClean="0"/>
+              <a:rPr lang="en-US"/>
               <a:t>Click to edit Master title style</a:t>
             </a:r>
-            <a:endParaRPr lang="en-US"/>
           </a:p>
         </p:txBody>
       </p:sp>
@@ -1901,7 +1901,7 @@
           <a:p>
             <a:fld id="{5BCAD085-E8A6-8845-BD4E-CB4CCA059FC4}" type="datetimeFigureOut">
               <a:rPr lang="en-US" smtClean="0"/>
-              <a:t>1/27/13</a:t>
+              <a:t>7/8/26</a:t>
             </a:fld>
             <a:endParaRPr lang="en-US"/>
           </a:p>
@@ -1996,7 +1996,7 @@
           <a:p>
             <a:fld id="{5BCAD085-E8A6-8845-BD4E-CB4CCA059FC4}" type="datetimeFigureOut">
               <a:rPr lang="en-US" smtClean="0"/>
-              <a:t>1/27/13</a:t>
+              <a:t>7/8/26</a:t>
             </a:fld>
             <a:endParaRPr lang="en-US"/>
           </a:p>
@@ -2099,10 +2099,9 @@
           </a:lstStyle>
           <a:p>
             <a:r>
-              <a:rPr lang="en-US" smtClean="0"/>
+              <a:rPr lang="en-US"/>
               <a:t>Click to edit Master title style</a:t>
             </a:r>
-            <a:endParaRPr lang="en-US"/>
           </a:p>
         </p:txBody>
       </p:sp>
@@ -2156,38 +2155,37 @@
           <a:p>
             <a:pPr lvl="0"/>
             <a:r>
-              <a:rPr lang="en-US" smtClean="0"/>
+              <a:rPr lang="en-US"/>
               <a:t>Click to edit Master text styles</a:t>
             </a:r>
           </a:p>
           <a:p>
             <a:pPr lvl="1"/>
             <a:r>
-              <a:rPr lang="en-US" smtClean="0"/>
+              <a:rPr lang="en-US"/>
               <a:t>Second level</a:t>
             </a:r>
           </a:p>
           <a:p>
             <a:pPr lvl="2"/>
             <a:r>
-              <a:rPr lang="en-US" smtClean="0"/>
+              <a:rPr lang="en-US"/>
               <a:t>Third level</a:t>
             </a:r>
           </a:p>
           <a:p>
             <a:pPr lvl="3"/>
             <a:r>
-              <a:rPr lang="en-US" smtClean="0"/>
+              <a:rPr lang="en-US"/>
               <a:t>Fourth level</a:t>
             </a:r>
           </a:p>
           <a:p>
             <a:pPr lvl="4"/>
             <a:r>
-              <a:rPr lang="en-US" smtClean="0"/>
+              <a:rPr lang="en-US"/>
               <a:t>Fifth level</a:t>
             </a:r>
-            <a:endParaRPr lang="en-US"/>
           </a:p>
         </p:txBody>
       </p:sp>
@@ -2250,7 +2248,7 @@
           <a:p>
             <a:pPr lvl="0"/>
             <a:r>
-              <a:rPr lang="en-US" smtClean="0"/>
+              <a:rPr lang="en-US"/>
               <a:t>Click to edit Master text styles</a:t>
             </a:r>
           </a:p>
@@ -2273,7 +2271,7 @@
           <a:p>
             <a:fld id="{5BCAD085-E8A6-8845-BD4E-CB4CCA059FC4}" type="datetimeFigureOut">
               <a:rPr lang="en-US" smtClean="0"/>
-              <a:t>1/27/13</a:t>
+              <a:t>7/8/26</a:t>
             </a:fld>
             <a:endParaRPr lang="en-US"/>
           </a:p>
@@ -2376,10 +2374,9 @@
           </a:lstStyle>
           <a:p>
             <a:r>
-              <a:rPr lang="en-US" smtClean="0"/>
+              <a:rPr lang="en-US"/>
               <a:t>Click to edit Master title style</a:t>
             </a:r>
-            <a:endParaRPr lang="en-US"/>
           </a:p>
         </p:txBody>
       </p:sp>
@@ -2503,7 +2500,7 @@
           <a:p>
             <a:pPr lvl="0"/>
             <a:r>
-              <a:rPr lang="en-US" smtClean="0"/>
+              <a:rPr lang="en-US"/>
               <a:t>Click to edit Master text styles</a:t>
             </a:r>
           </a:p>
@@ -2526,7 +2523,7 @@
           <a:p>
             <a:fld id="{5BCAD085-E8A6-8845-BD4E-CB4CCA059FC4}" type="datetimeFigureOut">
               <a:rPr lang="en-US" smtClean="0"/>
-              <a:t>1/27/13</a:t>
+              <a:t>7/8/26</a:t>
             </a:fld>
             <a:endParaRPr lang="en-US"/>
           </a:p>
@@ -2635,10 +2632,9 @@
           <a:lstStyle/>
           <a:p>
             <a:r>
-              <a:rPr lang="en-US" smtClean="0"/>
+              <a:rPr lang="en-US"/>
               <a:t>Click to edit Master title style</a:t>
             </a:r>
-            <a:endParaRPr lang="en-US"/>
           </a:p>
         </p:txBody>
       </p:sp>
@@ -2669,38 +2665,37 @@
           <a:p>
             <a:pPr lvl="0"/>
             <a:r>
-              <a:rPr lang="en-US" smtClean="0"/>
+              <a:rPr lang="en-US"/>
               <a:t>Click to edit Master text styles</a:t>
             </a:r>
           </a:p>
           <a:p>
             <a:pPr lvl="1"/>
             <a:r>
-              <a:rPr lang="en-US" smtClean="0"/>
+              <a:rPr lang="en-US"/>
               <a:t>Second level</a:t>
             </a:r>
           </a:p>
           <a:p>
             <a:pPr lvl="2"/>
             <a:r>
-              <a:rPr lang="en-US" smtClean="0"/>
+              <a:rPr lang="en-US"/>
               <a:t>Third level</a:t>
             </a:r>
           </a:p>
           <a:p>
             <a:pPr lvl="3"/>
             <a:r>
-              <a:rPr lang="en-US" smtClean="0"/>
+              <a:rPr lang="en-US"/>
               <a:t>Fourth level</a:t>
             </a:r>
           </a:p>
           <a:p>
             <a:pPr lvl="4"/>
             <a:r>
-              <a:rPr lang="en-US" smtClean="0"/>
+              <a:rPr lang="en-US"/>
               <a:t>Fifth level</a:t>
             </a:r>
-            <a:endParaRPr lang="en-US"/>
           </a:p>
         </p:txBody>
       </p:sp>
@@ -2739,7 +2734,7 @@
           <a:p>
             <a:fld id="{5BCAD085-E8A6-8845-BD4E-CB4CCA059FC4}" type="datetimeFigureOut">
               <a:rPr lang="en-US" smtClean="0"/>
-              <a:t>1/27/13</a:t>
+              <a:t>7/8/26</a:t>
             </a:fld>
             <a:endParaRPr lang="en-US"/>
           </a:p>
@@ -3098,7 +3093,7 @@
 </file>
 
 <file path=ppt/slides/slide1.xml><?xml version="1.0" encoding="utf-8"?>
-<p:sld xmlns:a="http://schemas.openxmlformats.org/drawingml/2006/main" xmlns:p="http://schemas.openxmlformats.org/presentationml/2006/main" xmlns:r="http://schemas.openxmlformats.org/officeDocument/2006/relationships">
+<p:sld xmlns:a="http://schemas.openxmlformats.org/drawingml/2006/main" xmlns:r="http://schemas.openxmlformats.org/officeDocument/2006/relationships" xmlns:p="http://schemas.openxmlformats.org/presentationml/2006/main">
   <p:cSld>
     <p:spTree>
       <p:nvGrpSpPr>
@@ -3106,7 +3101,14 @@
         <p:cNvGrpSpPr/>
         <p:nvPr/>
       </p:nvGrpSpPr>
-      <p:grpSpPr/>
+      <p:grpSpPr>
+        <a:xfrm>
+          <a:off x="0" y="0"/>
+          <a:ext cx="0" cy="0"/>
+          <a:chOff x="0" y="0"/>
+          <a:chExt cx="0" cy="0"/>
+        </a:xfrm>
+      </p:grpSpPr>
       <p:sp>
         <p:nvSpPr>
           <p:cNvPr id="2" name="TextBox 1"/>
@@ -3179,7 +3181,7 @@
 </file>
 
 <file path=ppt/slides/slide10.xml><?xml version="1.0" encoding="utf-8"?>
-<p:sld xmlns:a="http://schemas.openxmlformats.org/drawingml/2006/main" xmlns:p="http://schemas.openxmlformats.org/presentationml/2006/main" xmlns:r="http://schemas.openxmlformats.org/officeDocument/2006/relationships">
+<p:sld xmlns:a="http://schemas.openxmlformats.org/drawingml/2006/main" xmlns:r="http://schemas.openxmlformats.org/officeDocument/2006/relationships" xmlns:p="http://schemas.openxmlformats.org/presentationml/2006/main">
   <p:cSld>
     <p:spTree>
       <p:nvGrpSpPr>
@@ -3187,7 +3189,14 @@
         <p:cNvGrpSpPr/>
         <p:nvPr/>
       </p:nvGrpSpPr>
-      <p:grpSpPr/>
+      <p:grpSpPr>
+        <a:xfrm>
+          <a:off x="0" y="0"/>
+          <a:ext cx="0" cy="0"/>
+          <a:chOff x="0" y="0"/>
+          <a:chExt cx="0" cy="0"/>
+        </a:xfrm>
+      </p:grpSpPr>
       <p:sp>
         <p:nvSpPr>
           <p:cNvPr id="2" name="TextBox 1"/>
@@ -3338,7 +3347,7 @@
 </file>
 
 <file path=ppt/slides/slide11.xml><?xml version="1.0" encoding="utf-8"?>
-<p:sld xmlns:a="http://schemas.openxmlformats.org/drawingml/2006/main" xmlns:p="http://schemas.openxmlformats.org/presentationml/2006/main" xmlns:r="http://schemas.openxmlformats.org/officeDocument/2006/relationships">
+<p:sld xmlns:a="http://schemas.openxmlformats.org/drawingml/2006/main" xmlns:r="http://schemas.openxmlformats.org/officeDocument/2006/relationships" xmlns:p="http://schemas.openxmlformats.org/presentationml/2006/main">
   <p:cSld>
     <p:spTree>
       <p:nvGrpSpPr>
@@ -3346,7 +3355,14 @@
         <p:cNvGrpSpPr/>
         <p:nvPr/>
       </p:nvGrpSpPr>
-      <p:grpSpPr/>
+      <p:grpSpPr>
+        <a:xfrm>
+          <a:off x="0" y="0"/>
+          <a:ext cx="0" cy="0"/>
+          <a:chOff x="0" y="0"/>
+          <a:chExt cx="0" cy="0"/>
+        </a:xfrm>
+      </p:grpSpPr>
       <p:sp>
         <p:nvSpPr>
           <p:cNvPr id="2" name="TextBox 1"/>
@@ -3462,7 +3478,7 @@
 </file>
 
 <file path=ppt/slides/slide12.xml><?xml version="1.0" encoding="utf-8"?>
-<p:sld xmlns:a="http://schemas.openxmlformats.org/drawingml/2006/main" xmlns:p="http://schemas.openxmlformats.org/presentationml/2006/main" xmlns:r="http://schemas.openxmlformats.org/officeDocument/2006/relationships">
+<p:sld xmlns:a="http://schemas.openxmlformats.org/drawingml/2006/main" xmlns:r="http://schemas.openxmlformats.org/officeDocument/2006/relationships" xmlns:p="http://schemas.openxmlformats.org/presentationml/2006/main">
   <p:cSld>
     <p:spTree>
       <p:nvGrpSpPr>
@@ -3470,7 +3486,14 @@
         <p:cNvGrpSpPr/>
         <p:nvPr/>
       </p:nvGrpSpPr>
-      <p:grpSpPr/>
+      <p:grpSpPr>
+        <a:xfrm>
+          <a:off x="0" y="0"/>
+          <a:ext cx="0" cy="0"/>
+          <a:chOff x="0" y="0"/>
+          <a:chExt cx="0" cy="0"/>
+        </a:xfrm>
+      </p:grpSpPr>
       <p:sp>
         <p:nvSpPr>
           <p:cNvPr id="2" name="TextBox 1"/>
@@ -3547,7 +3570,7 @@
 </file>
 
 <file path=ppt/slides/slide13.xml><?xml version="1.0" encoding="utf-8"?>
-<p:sld xmlns:a="http://schemas.openxmlformats.org/drawingml/2006/main" xmlns:p="http://schemas.openxmlformats.org/presentationml/2006/main" xmlns:r="http://schemas.openxmlformats.org/officeDocument/2006/relationships">
+<p:sld xmlns:a="http://schemas.openxmlformats.org/drawingml/2006/main" xmlns:r="http://schemas.openxmlformats.org/officeDocument/2006/relationships" xmlns:p="http://schemas.openxmlformats.org/presentationml/2006/main">
   <p:cSld>
     <p:spTree>
       <p:nvGrpSpPr>
@@ -3555,7 +3578,14 @@
         <p:cNvGrpSpPr/>
         <p:nvPr/>
       </p:nvGrpSpPr>
-      <p:grpSpPr/>
+      <p:grpSpPr>
+        <a:xfrm>
+          <a:off x="0" y="0"/>
+          <a:ext cx="0" cy="0"/>
+          <a:chOff x="0" y="0"/>
+          <a:chExt cx="0" cy="0"/>
+        </a:xfrm>
+      </p:grpSpPr>
       <p:sp>
         <p:nvSpPr>
           <p:cNvPr id="2" name="TextBox 1"/>
@@ -3671,7 +3701,7 @@
 </file>
 
 <file path=ppt/slides/slide14.xml><?xml version="1.0" encoding="utf-8"?>
-<p:sld xmlns:a="http://schemas.openxmlformats.org/drawingml/2006/main" xmlns:p="http://schemas.openxmlformats.org/presentationml/2006/main" xmlns:r="http://schemas.openxmlformats.org/officeDocument/2006/relationships">
+<p:sld xmlns:a="http://schemas.openxmlformats.org/drawingml/2006/main" xmlns:r="http://schemas.openxmlformats.org/officeDocument/2006/relationships" xmlns:p="http://schemas.openxmlformats.org/presentationml/2006/main">
   <p:cSld>
     <p:spTree>
       <p:nvGrpSpPr>
@@ -3679,7 +3709,14 @@
         <p:cNvGrpSpPr/>
         <p:nvPr/>
       </p:nvGrpSpPr>
-      <p:grpSpPr/>
+      <p:grpSpPr>
+        <a:xfrm>
+          <a:off x="0" y="0"/>
+          <a:ext cx="0" cy="0"/>
+          <a:chOff x="0" y="0"/>
+          <a:chExt cx="0" cy="0"/>
+        </a:xfrm>
+      </p:grpSpPr>
       <p:sp>
         <p:nvSpPr>
           <p:cNvPr id="2" name="TextBox 1"/>
@@ -3729,8 +3766,8 @@
         </p:blipFill>
         <p:spPr>
           <a:xfrm>
-            <a:off x="548640" y="1371600"/>
-            <a:ext cx="11064240" cy="6104408"/>
+            <a:off x="1456659" y="1120048"/>
+            <a:ext cx="9629179" cy="5312650"/>
           </a:xfrm>
           <a:prstGeom prst="rect">
             <a:avLst/>
@@ -3746,7 +3783,7 @@
 </file>
 
 <file path=ppt/slides/slide15.xml><?xml version="1.0" encoding="utf-8"?>
-<p:sld xmlns:a="http://schemas.openxmlformats.org/drawingml/2006/main" xmlns:p="http://schemas.openxmlformats.org/presentationml/2006/main" xmlns:r="http://schemas.openxmlformats.org/officeDocument/2006/relationships">
+<p:sld xmlns:a="http://schemas.openxmlformats.org/drawingml/2006/main" xmlns:r="http://schemas.openxmlformats.org/officeDocument/2006/relationships" xmlns:p="http://schemas.openxmlformats.org/presentationml/2006/main">
   <p:cSld>
     <p:spTree>
       <p:nvGrpSpPr>
@@ -3754,7 +3791,14 @@
         <p:cNvGrpSpPr/>
         <p:nvPr/>
       </p:nvGrpSpPr>
-      <p:grpSpPr/>
+      <p:grpSpPr>
+        <a:xfrm>
+          <a:off x="0" y="0"/>
+          <a:ext cx="0" cy="0"/>
+          <a:chOff x="0" y="0"/>
+          <a:chExt cx="0" cy="0"/>
+        </a:xfrm>
+      </p:grpSpPr>
       <p:sp>
         <p:nvSpPr>
           <p:cNvPr id="2" name="TextBox 1"/>
@@ -3913,7 +3957,7 @@
 </file>
 
 <file path=ppt/slides/slide16.xml><?xml version="1.0" encoding="utf-8"?>
-<p:sld xmlns:a="http://schemas.openxmlformats.org/drawingml/2006/main" xmlns:p="http://schemas.openxmlformats.org/presentationml/2006/main" xmlns:r="http://schemas.openxmlformats.org/officeDocument/2006/relationships">
+<p:sld xmlns:a="http://schemas.openxmlformats.org/drawingml/2006/main" xmlns:r="http://schemas.openxmlformats.org/officeDocument/2006/relationships" xmlns:p="http://schemas.openxmlformats.org/presentationml/2006/main">
   <p:cSld>
     <p:spTree>
       <p:nvGrpSpPr>
@@ -3921,7 +3965,14 @@
         <p:cNvGrpSpPr/>
         <p:nvPr/>
       </p:nvGrpSpPr>
-      <p:grpSpPr/>
+      <p:grpSpPr>
+        <a:xfrm>
+          <a:off x="0" y="0"/>
+          <a:ext cx="0" cy="0"/>
+          <a:chOff x="0" y="0"/>
+          <a:chExt cx="0" cy="0"/>
+        </a:xfrm>
+      </p:grpSpPr>
       <p:sp>
         <p:nvSpPr>
           <p:cNvPr id="2" name="TextBox 1"/>
@@ -4073,7 +4124,7 @@
 </file>
 
 <file path=ppt/slides/slide17.xml><?xml version="1.0" encoding="utf-8"?>
-<p:sld xmlns:a="http://schemas.openxmlformats.org/drawingml/2006/main" xmlns:p="http://schemas.openxmlformats.org/presentationml/2006/main" xmlns:r="http://schemas.openxmlformats.org/officeDocument/2006/relationships">
+<p:sld xmlns:a="http://schemas.openxmlformats.org/drawingml/2006/main" xmlns:r="http://schemas.openxmlformats.org/officeDocument/2006/relationships" xmlns:p="http://schemas.openxmlformats.org/presentationml/2006/main">
   <p:cSld>
     <p:spTree>
       <p:nvGrpSpPr>
@@ -4081,7 +4132,14 @@
         <p:cNvGrpSpPr/>
         <p:nvPr/>
       </p:nvGrpSpPr>
-      <p:grpSpPr/>
+      <p:grpSpPr>
+        <a:xfrm>
+          <a:off x="0" y="0"/>
+          <a:ext cx="0" cy="0"/>
+          <a:chOff x="0" y="0"/>
+          <a:chExt cx="0" cy="0"/>
+        </a:xfrm>
+      </p:grpSpPr>
       <p:sp>
         <p:nvSpPr>
           <p:cNvPr id="2" name="TextBox 1"/>
@@ -4293,7 +4351,7 @@
 </file>
 
 <file path=ppt/slides/slide18.xml><?xml version="1.0" encoding="utf-8"?>
-<p:sld xmlns:a="http://schemas.openxmlformats.org/drawingml/2006/main" xmlns:p="http://schemas.openxmlformats.org/presentationml/2006/main" xmlns:r="http://schemas.openxmlformats.org/officeDocument/2006/relationships">
+<p:sld xmlns:a="http://schemas.openxmlformats.org/drawingml/2006/main" xmlns:r="http://schemas.openxmlformats.org/officeDocument/2006/relationships" xmlns:p="http://schemas.openxmlformats.org/presentationml/2006/main">
   <p:cSld>
     <p:spTree>
       <p:nvGrpSpPr>
@@ -4301,7 +4359,14 @@
         <p:cNvGrpSpPr/>
         <p:nvPr/>
       </p:nvGrpSpPr>
-      <p:grpSpPr/>
+      <p:grpSpPr>
+        <a:xfrm>
+          <a:off x="0" y="0"/>
+          <a:ext cx="0" cy="0"/>
+          <a:chOff x="0" y="0"/>
+          <a:chExt cx="0" cy="0"/>
+        </a:xfrm>
+      </p:grpSpPr>
       <p:sp>
         <p:nvSpPr>
           <p:cNvPr id="2" name="TextBox 1"/>
@@ -4361,8 +4426,8 @@
         </p:blipFill>
         <p:spPr>
           <a:xfrm>
-            <a:off x="274320" y="1463040"/>
-            <a:ext cx="8595360" cy="6111545"/>
+            <a:off x="891008" y="1380853"/>
+            <a:ext cx="7317327" cy="5202827"/>
           </a:xfrm>
           <a:prstGeom prst="rect">
             <a:avLst/>
@@ -4402,7 +4467,7 @@
 </file>
 
 <file path=ppt/slides/slide19.xml><?xml version="1.0" encoding="utf-8"?>
-<p:sld xmlns:a="http://schemas.openxmlformats.org/drawingml/2006/main" xmlns:p="http://schemas.openxmlformats.org/presentationml/2006/main" xmlns:r="http://schemas.openxmlformats.org/officeDocument/2006/relationships">
+<p:sld xmlns:a="http://schemas.openxmlformats.org/drawingml/2006/main" xmlns:r="http://schemas.openxmlformats.org/officeDocument/2006/relationships" xmlns:p="http://schemas.openxmlformats.org/presentationml/2006/main">
   <p:cSld>
     <p:spTree>
       <p:nvGrpSpPr>
@@ -4410,7 +4475,14 @@
         <p:cNvGrpSpPr/>
         <p:nvPr/>
       </p:nvGrpSpPr>
-      <p:grpSpPr/>
+      <p:grpSpPr>
+        <a:xfrm>
+          <a:off x="0" y="0"/>
+          <a:ext cx="0" cy="0"/>
+          <a:chOff x="0" y="0"/>
+          <a:chExt cx="0" cy="0"/>
+        </a:xfrm>
+      </p:grpSpPr>
       <p:sp>
         <p:nvSpPr>
           <p:cNvPr id="2" name="TextBox 1"/>
@@ -4573,7 +4645,7 @@
 </file>
 
 <file path=ppt/slides/slide2.xml><?xml version="1.0" encoding="utf-8"?>
-<p:sld xmlns:a="http://schemas.openxmlformats.org/drawingml/2006/main" xmlns:p="http://schemas.openxmlformats.org/presentationml/2006/main" xmlns:r="http://schemas.openxmlformats.org/officeDocument/2006/relationships">
+<p:sld xmlns:a="http://schemas.openxmlformats.org/drawingml/2006/main" xmlns:r="http://schemas.openxmlformats.org/officeDocument/2006/relationships" xmlns:p="http://schemas.openxmlformats.org/presentationml/2006/main">
   <p:cSld>
     <p:spTree>
       <p:nvGrpSpPr>
@@ -4581,7 +4653,14 @@
         <p:cNvGrpSpPr/>
         <p:nvPr/>
       </p:nvGrpSpPr>
-      <p:grpSpPr/>
+      <p:grpSpPr>
+        <a:xfrm>
+          <a:off x="0" y="0"/>
+          <a:ext cx="0" cy="0"/>
+          <a:chOff x="0" y="0"/>
+          <a:chExt cx="0" cy="0"/>
+        </a:xfrm>
+      </p:grpSpPr>
       <p:sp>
         <p:nvSpPr>
           <p:cNvPr id="2" name="TextBox 1"/>
@@ -4695,7 +4774,7 @@
 </file>
 
 <file path=ppt/slides/slide20.xml><?xml version="1.0" encoding="utf-8"?>
-<p:sld xmlns:a="http://schemas.openxmlformats.org/drawingml/2006/main" xmlns:p="http://schemas.openxmlformats.org/presentationml/2006/main" xmlns:r="http://schemas.openxmlformats.org/officeDocument/2006/relationships">
+<p:sld xmlns:a="http://schemas.openxmlformats.org/drawingml/2006/main" xmlns:r="http://schemas.openxmlformats.org/officeDocument/2006/relationships" xmlns:p="http://schemas.openxmlformats.org/presentationml/2006/main">
   <p:cSld>
     <p:spTree>
       <p:nvGrpSpPr>
@@ -4703,7 +4782,14 @@
         <p:cNvGrpSpPr/>
         <p:nvPr/>
       </p:nvGrpSpPr>
-      <p:grpSpPr/>
+      <p:grpSpPr>
+        <a:xfrm>
+          <a:off x="0" y="0"/>
+          <a:ext cx="0" cy="0"/>
+          <a:chOff x="0" y="0"/>
+          <a:chExt cx="0" cy="0"/>
+        </a:xfrm>
+      </p:grpSpPr>
       <p:sp>
         <p:nvSpPr>
           <p:cNvPr id="2" name="TextBox 1"/>
@@ -4817,7 +4903,7 @@
 </file>
 
 <file path=ppt/slides/slide3.xml><?xml version="1.0" encoding="utf-8"?>
-<p:sld xmlns:a="http://schemas.openxmlformats.org/drawingml/2006/main" xmlns:p="http://schemas.openxmlformats.org/presentationml/2006/main" xmlns:r="http://schemas.openxmlformats.org/officeDocument/2006/relationships">
+<p:sld xmlns:a="http://schemas.openxmlformats.org/drawingml/2006/main" xmlns:r="http://schemas.openxmlformats.org/officeDocument/2006/relationships" xmlns:p="http://schemas.openxmlformats.org/presentationml/2006/main">
   <p:cSld>
     <p:spTree>
       <p:nvGrpSpPr>
@@ -4825,7 +4911,14 @@
         <p:cNvGrpSpPr/>
         <p:nvPr/>
       </p:nvGrpSpPr>
-      <p:grpSpPr/>
+      <p:grpSpPr>
+        <a:xfrm>
+          <a:off x="0" y="0"/>
+          <a:ext cx="0" cy="0"/>
+          <a:chOff x="0" y="0"/>
+          <a:chExt cx="0" cy="0"/>
+        </a:xfrm>
+      </p:grpSpPr>
       <p:sp>
         <p:nvSpPr>
           <p:cNvPr id="2" name="TextBox 1"/>
@@ -4885,8 +4978,8 @@
         </p:blipFill>
         <p:spPr>
           <a:xfrm>
-            <a:off x="457200" y="1463040"/>
-            <a:ext cx="11247120" cy="8451978"/>
+            <a:off x="1116417" y="1160597"/>
+            <a:ext cx="7293935" cy="5481241"/>
           </a:xfrm>
           <a:prstGeom prst="rect">
             <a:avLst/>
@@ -4902,7 +4995,7 @@
 </file>
 
 <file path=ppt/slides/slide4.xml><?xml version="1.0" encoding="utf-8"?>
-<p:sld xmlns:a="http://schemas.openxmlformats.org/drawingml/2006/main" xmlns:p="http://schemas.openxmlformats.org/presentationml/2006/main" xmlns:r="http://schemas.openxmlformats.org/officeDocument/2006/relationships">
+<p:sld xmlns:a="http://schemas.openxmlformats.org/drawingml/2006/main" xmlns:r="http://schemas.openxmlformats.org/officeDocument/2006/relationships" xmlns:p="http://schemas.openxmlformats.org/presentationml/2006/main">
   <p:cSld>
     <p:spTree>
       <p:nvGrpSpPr>
@@ -4910,7 +5003,14 @@
         <p:cNvGrpSpPr/>
         <p:nvPr/>
       </p:nvGrpSpPr>
-      <p:grpSpPr/>
+      <p:grpSpPr>
+        <a:xfrm>
+          <a:off x="0" y="0"/>
+          <a:ext cx="0" cy="0"/>
+          <a:chOff x="0" y="0"/>
+          <a:chExt cx="0" cy="0"/>
+        </a:xfrm>
+      </p:grpSpPr>
       <p:sp>
         <p:nvSpPr>
           <p:cNvPr id="2" name="TextBox 1"/>
@@ -5013,7 +5113,7 @@
 </file>
 
 <file path=ppt/slides/slide5.xml><?xml version="1.0" encoding="utf-8"?>
-<p:sld xmlns:a="http://schemas.openxmlformats.org/drawingml/2006/main" xmlns:p="http://schemas.openxmlformats.org/presentationml/2006/main" xmlns:r="http://schemas.openxmlformats.org/officeDocument/2006/relationships">
+<p:sld xmlns:a="http://schemas.openxmlformats.org/drawingml/2006/main" xmlns:r="http://schemas.openxmlformats.org/officeDocument/2006/relationships" xmlns:p="http://schemas.openxmlformats.org/presentationml/2006/main">
   <p:cSld>
     <p:spTree>
       <p:nvGrpSpPr>
@@ -5021,7 +5121,14 @@
         <p:cNvGrpSpPr/>
         <p:nvPr/>
       </p:nvGrpSpPr>
-      <p:grpSpPr/>
+      <p:grpSpPr>
+        <a:xfrm>
+          <a:off x="0" y="0"/>
+          <a:ext cx="0" cy="0"/>
+          <a:chOff x="0" y="0"/>
+          <a:chExt cx="0" cy="0"/>
+        </a:xfrm>
+      </p:grpSpPr>
       <p:sp>
         <p:nvSpPr>
           <p:cNvPr id="2" name="TextBox 1"/>
@@ -5124,7 +5231,7 @@
 </file>
 
 <file path=ppt/slides/slide6.xml><?xml version="1.0" encoding="utf-8"?>
-<p:sld xmlns:a="http://schemas.openxmlformats.org/drawingml/2006/main" xmlns:p="http://schemas.openxmlformats.org/presentationml/2006/main" xmlns:r="http://schemas.openxmlformats.org/officeDocument/2006/relationships">
+<p:sld xmlns:a="http://schemas.openxmlformats.org/drawingml/2006/main" xmlns:r="http://schemas.openxmlformats.org/officeDocument/2006/relationships" xmlns:p="http://schemas.openxmlformats.org/presentationml/2006/main">
   <p:cSld>
     <p:spTree>
       <p:nvGrpSpPr>
@@ -5132,7 +5239,14 @@
         <p:cNvGrpSpPr/>
         <p:nvPr/>
       </p:nvGrpSpPr>
-      <p:grpSpPr/>
+      <p:grpSpPr>
+        <a:xfrm>
+          <a:off x="0" y="0"/>
+          <a:ext cx="0" cy="0"/>
+          <a:chOff x="0" y="0"/>
+          <a:chExt cx="0" cy="0"/>
+        </a:xfrm>
+      </p:grpSpPr>
       <p:sp>
         <p:nvSpPr>
           <p:cNvPr id="2" name="TextBox 1"/>
@@ -5250,7 +5364,7 @@
 </file>
 
 <file path=ppt/slides/slide7.xml><?xml version="1.0" encoding="utf-8"?>
-<p:sld xmlns:a="http://schemas.openxmlformats.org/drawingml/2006/main" xmlns:p="http://schemas.openxmlformats.org/presentationml/2006/main" xmlns:r="http://schemas.openxmlformats.org/officeDocument/2006/relationships">
+<p:sld xmlns:a="http://schemas.openxmlformats.org/drawingml/2006/main" xmlns:r="http://schemas.openxmlformats.org/officeDocument/2006/relationships" xmlns:p="http://schemas.openxmlformats.org/presentationml/2006/main">
   <p:cSld>
     <p:spTree>
       <p:nvGrpSpPr>
@@ -5258,7 +5372,14 @@
         <p:cNvGrpSpPr/>
         <p:nvPr/>
       </p:nvGrpSpPr>
-      <p:grpSpPr/>
+      <p:grpSpPr>
+        <a:xfrm>
+          <a:off x="0" y="0"/>
+          <a:ext cx="0" cy="0"/>
+          <a:chOff x="0" y="0"/>
+          <a:chExt cx="0" cy="0"/>
+        </a:xfrm>
+      </p:grpSpPr>
       <p:sp>
         <p:nvSpPr>
           <p:cNvPr id="2" name="TextBox 1"/>
@@ -5361,7 +5482,7 @@
 </file>
 
 <file path=ppt/slides/slide8.xml><?xml version="1.0" encoding="utf-8"?>
-<p:sld xmlns:a="http://schemas.openxmlformats.org/drawingml/2006/main" xmlns:p="http://schemas.openxmlformats.org/presentationml/2006/main" xmlns:r="http://schemas.openxmlformats.org/officeDocument/2006/relationships">
+<p:sld xmlns:a="http://schemas.openxmlformats.org/drawingml/2006/main" xmlns:r="http://schemas.openxmlformats.org/officeDocument/2006/relationships" xmlns:p="http://schemas.openxmlformats.org/presentationml/2006/main">
   <p:cSld>
     <p:spTree>
       <p:nvGrpSpPr>
@@ -5369,7 +5490,14 @@
         <p:cNvGrpSpPr/>
         <p:nvPr/>
       </p:nvGrpSpPr>
-      <p:grpSpPr/>
+      <p:grpSpPr>
+        <a:xfrm>
+          <a:off x="0" y="0"/>
+          <a:ext cx="0" cy="0"/>
+          <a:chOff x="0" y="0"/>
+          <a:chExt cx="0" cy="0"/>
+        </a:xfrm>
+      </p:grpSpPr>
       <p:sp>
         <p:nvSpPr>
           <p:cNvPr id="2" name="TextBox 1"/>
@@ -5487,7 +5615,7 @@
 </file>
 
 <file path=ppt/slides/slide9.xml><?xml version="1.0" encoding="utf-8"?>
-<p:sld xmlns:a="http://schemas.openxmlformats.org/drawingml/2006/main" xmlns:p="http://schemas.openxmlformats.org/presentationml/2006/main" xmlns:r="http://schemas.openxmlformats.org/officeDocument/2006/relationships">
+<p:sld xmlns:a="http://schemas.openxmlformats.org/drawingml/2006/main" xmlns:r="http://schemas.openxmlformats.org/officeDocument/2006/relationships" xmlns:p="http://schemas.openxmlformats.org/presentationml/2006/main">
   <p:cSld>
     <p:spTree>
       <p:nvGrpSpPr>
@@ -5495,7 +5623,14 @@
         <p:cNvGrpSpPr/>
         <p:nvPr/>
       </p:nvGrpSpPr>
-      <p:grpSpPr/>
+      <p:grpSpPr>
+        <a:xfrm>
+          <a:off x="0" y="0"/>
+          <a:ext cx="0" cy="0"/>
+          <a:chOff x="0" y="0"/>
+          <a:chExt cx="0" cy="0"/>
+        </a:xfrm>
+      </p:grpSpPr>
       <p:sp>
         <p:nvSpPr>
           <p:cNvPr id="2" name="TextBox 1"/>
@@ -5926,4 +6061,10 @@
   </a:objectDefaults>
   <a:extraClrSchemeLst/>
 </a:theme>
+</file>
+
+<file path=docMetadata/LabelInfo.xml><?xml version="1.0" encoding="utf-8"?>
+<clbl:labelList xmlns:clbl="http://schemas.microsoft.com/office/2020/mipLabelMetadata">
+  <clbl:label id="{7893ce20-a697-4fd6-a4da-14011f6a471d}" enabled="1" method="Standard" siteId="{a8eec281-aaa3-4dae-ac9b-9a398b9215e7}" contentBits="0" removed="0"/>
+</clbl:labelList>
 </file>
</xml_diff>